<commit_message>
Deck: add 'what Zen does differently', architecture diagram and inference red-team chart
</commit_message>
<xml_diff>
--- a/submission/Zen_PECathon.pptx
+++ b/submission/Zen_PECathon.pptx
@@ -114,26 +114,26 @@
   <p:extLst>
     <p:ext uri="{521415D9-36F7-43E2-AB2F-B90AF26B5E84}">
       <p14:sectionLst xmlns:p14="http://schemas.microsoft.com/office/powerpoint/2010/main">
-        <p14:section name="Intro" id="{2064bd24-67b4-e514-5385-f2a52ad5146a}">
+        <p14:section name="Intro" id="{88ed5224-2e7f-81fc-e74f-04f800bcb694}">
           <p14:sldIdLst>
             <p14:sldId id="256"/>
           </p14:sldIdLst>
         </p14:section>
-        <p14:section name="Problem and design" id="{19efd1f9-7371-d214-7e64-60054fc4d798}">
+        <p14:section name="Problem and design" id="{23b27dbd-dba0-6536-0659-4803ba7d2b49}">
           <p14:sldIdLst>
             <p14:sldId id="257"/>
             <p14:sldId id="258"/>
+            <p14:sldId id="259"/>
           </p14:sldIdLst>
         </p14:section>
-        <p14:section name="How it works" id="{410377b2-d729-9dab-dfb7-a5256f00c943}">
+        <p14:section name="How it works" id="{d6b1e2cb-2673-2638-0f5d-690a856d8652}">
           <p14:sldIdLst>
-            <p14:sldId id="259"/>
             <p14:sldId id="260"/>
             <p14:sldId id="261"/>
             <p14:sldId id="262"/>
           </p14:sldIdLst>
         </p14:section>
-        <p14:section name="Results" id="{ca57041c-fcd6-c924-da3b-23d81270b965}">
+        <p14:section name="Results" id="{86bf25e1-159c-3f30-b2a7-290251b14709}">
           <p14:sldIdLst>
             <p14:sldId id="263"/>
           </p14:sldIdLst>
@@ -145,6 +145,392 @@
     </p:ext>
   </p:extLst>
 </p:presentation>
+</file>
+
+<file path=ppt/charts/chart1.xml><?xml version="1.0" encoding="utf-8"?>
+<c:chartSpace xmlns:c="http://schemas.openxmlformats.org/drawingml/2006/chart" xmlns:a="http://schemas.openxmlformats.org/drawingml/2006/main" xmlns:r="http://schemas.openxmlformats.org/officeDocument/2006/relationships">
+  <c:date1904 val="0"/>
+  <c:roundedCorners val="1"/>
+  <c:chart>
+    <c:title>
+      <c:tx>
+        <c:rich>
+          <a:bodyPr/>
+          <a:lstStyle/>
+          <a:p>
+            <a:pPr>
+              <a:defRPr sz="1200" b="0" i="0" u="none" strike="noStrike">
+                <a:solidFill>
+                  <a:srgbClr val="16140F"/>
+                </a:solidFill>
+                <a:latin typeface="+mn-lt"/>
+              </a:defRPr>
+            </a:pPr>
+            <a:r>
+              <a:rPr sz="1200" b="0" i="0" u="none" strike="noStrike">
+                <a:solidFill>
+                  <a:srgbClr val="16140F"/>
+                </a:solidFill>
+                <a:latin typeface="+mn-lt"/>
+              </a:rPr>
+              <a:t>Leak rate by attack type (%), 48 scenarios</a:t>
+            </a:r>
+          </a:p>
+        </c:rich>
+      </c:tx>
+      <c:layout/>
+      <c:overlay val="0"/>
+    </c:title>
+    <c:autoTitleDeleted val="0"/>
+    <c:plotArea>
+      <c:layout/>
+      <c:barChart>
+        <c:barDir val="col"/>
+        <c:grouping val="clustered"/>
+        <c:varyColors val="0"/>
+        <c:ser>
+          <c:idx val="0"/>
+          <c:order val="0"/>
+          <c:tx>
+            <c:strRef>
+              <c:f>Sheet1!$B$1</c:f>
+              <c:strCache>
+                <c:ptCount val="1"/>
+                <c:pt idx="0">
+                  <c:v>Plain redaction</c:v>
+                </c:pt>
+              </c:strCache>
+            </c:strRef>
+          </c:tx>
+          <c:spPr>
+            <a:solidFill>
+              <a:srgbClr val="D9B8AB"/>
+            </a:solidFill>
+            <a:effectLst/>
+          </c:spPr>
+          <c:invertIfNegative val="0"/>
+          <c:dLbls>
+            <c:numFmt formatCode="#,##0" sourceLinked="0"/>
+            <c:txPr>
+              <a:bodyPr/>
+              <a:lstStyle/>
+              <a:p>
+                <a:pPr>
+                  <a:defRPr b="0" i="0" strike="noStrike" sz="1000" u="none">
+                    <a:solidFill>
+                      <a:srgbClr val="5A4A40"/>
+                    </a:solidFill>
+                    <a:latin typeface="+mn-lt"/>
+                  </a:defRPr>
+                </a:pPr>
+              </a:p>
+            </c:txPr>
+            <c:showLegendKey val="0"/>
+            <c:showVal val="1"/>
+            <c:showCatName val="0"/>
+            <c:showSerName val="0"/>
+            <c:showPercent val="0"/>
+            <c:showBubbleSize val="0"/>
+            <c:showLeaderLines val="0"/>
+          </c:dLbls>
+          <c:cat>
+            <c:multiLvlStrRef>
+              <c:f>Sheet1!$A$2:$A$6</c:f>
+              <c:multiLvlStrCache>
+                <c:ptCount val="5"/>
+                <c:lvl>
+                  <c:pt idx="0">
+                    <c:v>Partial values</c:v>
+                  </c:pt>
+                  <c:pt idx="1">
+                    <c:v>Recomputable</c:v>
+                  </c:pt>
+                  <c:pt idx="2">
+                    <c:v>Quasi-IDs</c:v>
+                  </c:pt>
+                  <c:pt idx="3">
+                    <c:v>Cross-field</c:v>
+                  </c:pt>
+                  <c:pt idx="4">
+                    <c:v>Context</c:v>
+                  </c:pt>
+                </c:lvl>
+              </c:multiLvlStrCache>
+            </c:multiLvlStrRef>
+          </c:cat>
+          <c:val>
+            <c:numRef>
+              <c:f>Sheet1!$B$2:$B$6</c:f>
+              <c:numCache>
+                <c:formatCode>General</c:formatCode>
+                <c:ptCount val="5"/>
+                <c:pt idx="0">
+                  <c:v>100</c:v>
+                </c:pt>
+                <c:pt idx="1">
+                  <c:v>100</c:v>
+                </c:pt>
+                <c:pt idx="2">
+                  <c:v>100</c:v>
+                </c:pt>
+                <c:pt idx="3">
+                  <c:v>100</c:v>
+                </c:pt>
+                <c:pt idx="4">
+                  <c:v>100</c:v>
+                </c:pt>
+              </c:numCache>
+            </c:numRef>
+          </c:val>
+        </c:ser>
+        <c:ser>
+          <c:idx val="1"/>
+          <c:order val="1"/>
+          <c:tx>
+            <c:strRef>
+              <c:f>Sheet1!$C$1</c:f>
+              <c:strCache>
+                <c:ptCount val="1"/>
+                <c:pt idx="0">
+                  <c:v>Zen (minimised)</c:v>
+                </c:pt>
+              </c:strCache>
+            </c:strRef>
+          </c:tx>
+          <c:spPr>
+            <a:solidFill>
+              <a:srgbClr val="B8431E"/>
+            </a:solidFill>
+            <a:effectLst/>
+          </c:spPr>
+          <c:invertIfNegative val="0"/>
+          <c:dLbls>
+            <c:numFmt formatCode="#,##0" sourceLinked="0"/>
+            <c:txPr>
+              <a:bodyPr/>
+              <a:lstStyle/>
+              <a:p>
+                <a:pPr>
+                  <a:defRPr b="0" i="0" strike="noStrike" sz="1000" u="none">
+                    <a:solidFill>
+                      <a:srgbClr val="5A4A40"/>
+                    </a:solidFill>
+                    <a:latin typeface="+mn-lt"/>
+                  </a:defRPr>
+                </a:pPr>
+              </a:p>
+            </c:txPr>
+            <c:showLegendKey val="0"/>
+            <c:showVal val="1"/>
+            <c:showCatName val="0"/>
+            <c:showSerName val="0"/>
+            <c:showPercent val="0"/>
+            <c:showBubbleSize val="0"/>
+            <c:showLeaderLines val="0"/>
+          </c:dLbls>
+          <c:cat>
+            <c:multiLvlStrRef>
+              <c:f>Sheet1!$A$2:$A$6</c:f>
+              <c:multiLvlStrCache>
+                <c:ptCount val="5"/>
+                <c:lvl>
+                  <c:pt idx="0">
+                    <c:v>Partial values</c:v>
+                  </c:pt>
+                  <c:pt idx="1">
+                    <c:v>Recomputable</c:v>
+                  </c:pt>
+                  <c:pt idx="2">
+                    <c:v>Quasi-IDs</c:v>
+                  </c:pt>
+                  <c:pt idx="3">
+                    <c:v>Cross-field</c:v>
+                  </c:pt>
+                  <c:pt idx="4">
+                    <c:v>Context</c:v>
+                  </c:pt>
+                </c:lvl>
+              </c:multiLvlStrCache>
+            </c:multiLvlStrRef>
+          </c:cat>
+          <c:val>
+            <c:numRef>
+              <c:f>Sheet1!$C$2:$C$6</c:f>
+              <c:numCache>
+                <c:formatCode>General</c:formatCode>
+                <c:ptCount val="5"/>
+                <c:pt idx="0">
+                  <c:v>0</c:v>
+                </c:pt>
+                <c:pt idx="1">
+                  <c:v>9</c:v>
+                </c:pt>
+                <c:pt idx="2">
+                  <c:v>0</c:v>
+                </c:pt>
+                <c:pt idx="3">
+                  <c:v>12</c:v>
+                </c:pt>
+                <c:pt idx="4">
+                  <c:v>0</c:v>
+                </c:pt>
+              </c:numCache>
+            </c:numRef>
+          </c:val>
+        </c:ser>
+        <c:dLbls>
+          <c:numFmt formatCode="#,##0" sourceLinked="0"/>
+          <c:txPr>
+            <a:bodyPr/>
+            <a:lstStyle/>
+            <a:p>
+              <a:pPr>
+                <a:defRPr b="0" i="0" strike="noStrike" sz="1000" u="none">
+                  <a:solidFill>
+                    <a:srgbClr val="5A4A40"/>
+                  </a:solidFill>
+                  <a:latin typeface="+mn-lt"/>
+                </a:defRPr>
+              </a:pPr>
+            </a:p>
+          </c:txPr>
+          <c:showLegendKey val="0"/>
+          <c:showVal val="1"/>
+          <c:showCatName val="0"/>
+          <c:showSerName val="0"/>
+          <c:showPercent val="0"/>
+          <c:showBubbleSize val="0"/>
+          <c:showLeaderLines val="0"/>
+        </c:dLbls>
+        <c:gapWidth val="60"/>
+        <c:overlap val="0"/>
+        <c:axId val="2094734554"/>
+        <c:axId val="2094734552"/>
+        <c:axId val="2094734556"/>
+      </c:barChart>
+      <c:catAx>
+        <c:axId val="2094734554"/>
+        <c:scaling>
+          <c:orientation val="minMax"/>
+        </c:scaling>
+        <c:delete val="0"/>
+        <c:axPos val="b"/>
+        <c:numFmt formatCode="General" sourceLinked="1"/>
+        <c:majorTickMark val="out"/>
+        <c:minorTickMark val="none"/>
+        <c:tickLblPos val="low"/>
+        <c:spPr>
+          <a:ln w="12700" cap="flat">
+            <a:solidFill>
+              <a:srgbClr val="888888"/>
+            </a:solidFill>
+            <a:prstDash val="solid"/>
+            <a:round/>
+          </a:ln>
+        </c:spPr>
+        <c:txPr>
+          <a:bodyPr/>
+          <a:lstStyle/>
+          <a:p>
+            <a:pPr>
+              <a:defRPr sz="1000" b="0" i="0" u="none" strike="noStrike">
+                <a:solidFill>
+                  <a:srgbClr val="5A4A40"/>
+                </a:solidFill>
+                <a:latin typeface="+mn-lt"/>
+              </a:defRPr>
+            </a:pPr>
+            <a:endParaRPr lang="en-US"/>
+          </a:p>
+        </c:txPr>
+        <c:crossAx val="2094734552"/>
+        <c:crosses val="autoZero"/>
+        <c:auto val="1"/>
+        <c:lblAlgn val="ctr"/>
+        <c:noMultiLvlLbl val="1"/>
+      </c:catAx>
+      <c:valAx>
+        <c:axId val="2094734552"/>
+        <c:scaling>
+          <c:orientation val="minMax"/>
+          <c:max val="110"/>
+        </c:scaling>
+        <c:delete val="1"/>
+        <c:axPos val="l"/>
+        <c:numFmt formatCode="General" sourceLinked="0"/>
+        <c:majorTickMark val="out"/>
+        <c:minorTickMark val="none"/>
+        <c:tickLblPos val="nextTo"/>
+        <c:spPr>
+          <a:ln w="12700" cap="flat">
+            <a:solidFill>
+              <a:srgbClr val="888888"/>
+            </a:solidFill>
+            <a:prstDash val="solid"/>
+            <a:round/>
+          </a:ln>
+        </c:spPr>
+        <c:txPr>
+          <a:bodyPr/>
+          <a:lstStyle/>
+          <a:p>
+            <a:pPr>
+              <a:defRPr sz="1200" b="0" i="0" u="none" strike="noStrike">
+                <a:solidFill>
+                  <a:srgbClr val="000000"/>
+                </a:solidFill>
+                <a:latin typeface="Arial"/>
+              </a:defRPr>
+            </a:pPr>
+            <a:endParaRPr lang="en-US"/>
+          </a:p>
+        </c:txPr>
+        <c:crossAx val="2094734554"/>
+        <c:crosses val="autoZero"/>
+        <c:crossBetween val="between"/>
+      </c:valAx>
+      <c:spPr>
+        <a:noFill/>
+        <a:ln>
+          <a:noFill/>
+        </a:ln>
+        <a:effectLst/>
+      </c:spPr>
+    </c:plotArea>
+    <c:legend>
+      <c:legendPos val="b"/>
+      <c:overlay val="0"/>
+      <c:txPr>
+        <a:bodyPr/>
+        <a:lstStyle/>
+        <a:p>
+          <a:pPr>
+            <a:defRPr sz="1100">
+              <a:solidFill>
+                <a:srgbClr val="1B1C1A"/>
+              </a:solidFill>
+              <a:latin typeface="+mn-lt"/>
+              <a:cs typeface="+mn-lt"/>
+            </a:defRPr>
+          </a:pPr>
+          <a:endParaRPr lang="en-US"/>
+        </a:p>
+      </c:txPr>
+    </c:legend>
+    <c:plotVisOnly val="1"/>
+    <c:dispBlanksAs val="span"/>
+  </c:chart>
+  <c:spPr>
+    <a:noFill/>
+    <a:ln>
+      <a:noFill/>
+    </a:ln>
+    <a:effectLst/>
+  </c:spPr>
+  <c:externalData r:id="rId1">
+    <c:autoUpdate val="0"/>
+  </c:externalData>
+</c:chartSpace>
 </file>
 
 <file path=ppt/notesMasters/notesMaster1.xml><?xml version="1.0" encoding="utf-8"?>
@@ -718,7 +1104,7 @@
           <a:p>
             <a:r>
               <a:rPr lang="en-US" dirty="0"/>
-              <a:t>Three surfaces share one detector: zenlens/detect.py and its exact JS port extension/lib/detect.js, kept in parity by a test.</a:t>
+              <a:t>Also: India-specific IDs with real checksums (Aadhaar Verhoeff, GSTIN mod-36, UPI, IFSC), a JS port that runs offline in the extension, and an on-device planner option via Ollama.</a:t>
             </a:r>
             <a:endParaRPr lang="en-US" dirty="0"/>
           </a:p>
@@ -806,7 +1192,7 @@
           <a:p>
             <a:r>
               <a:rPr lang="en-US" dirty="0"/>
-              <a:t>Text detector on 150 labelled synthetic cases: recall 0.99, precision 1.00, about 0.014 ms per detect() call.</a:t>
+              <a:t>Three surfaces share this pipeline: the Chrome extension (main), the Python agent, and the web app.</a:t>
             </a:r>
             <a:endParaRPr lang="en-US" dirty="0"/>
           </a:p>
@@ -982,7 +1368,7 @@
           <a:p>
             <a:r>
               <a:rPr lang="en-US" dirty="0"/>
-              <a:t>Gate test: 5 of 5 canaries blocked, 0 over-blocks on the eval set.</a:t>
+              <a:t>eval.inference.run: an offline attacker tries to recover each redacted value from context. Leak = exact recovery, at least 1 bit narrowed, or re-identification. 2 known-gap leaks remain after minimise.</a:t>
             </a:r>
             <a:endParaRPr lang="en-US" dirty="0"/>
           </a:p>
@@ -1070,7 +1456,7 @@
           <a:p>
             <a:r>
               <a:rPr lang="en-US" dirty="0"/>
-              <a:t>Planner options: scripted, on-device Ollama, or Claude on sanitized data only.</a:t>
+              <a:t>End-to-end tests prove vault values reach the page but never model payloads, logs or reports.</a:t>
             </a:r>
             <a:endParaRPr lang="en-US" dirty="0"/>
           </a:p>
@@ -2677,7 +3063,7 @@
                 <a:ea typeface="Cambria" pitchFamily="34" charset="-122"/>
                 <a:cs typeface="Cambria" pitchFamily="34" charset="-120"/>
               </a:rPr>
-              <a:t>Everything sensitive is decided on the device</a:t>
+              <a:t>What Zen does differently</a:t>
             </a:r>
             <a:endParaRPr lang="en-US" sz="3000" dirty="0"/>
           </a:p>
@@ -2685,18 +3071,90 @@
       </p:sp>
       <p:sp>
         <p:nvSpPr>
-          <p:cNvPr id="3" name="card"/>
+          <p:cNvPr id="3" name="Text 1"/>
+          <p:cNvSpPr txBox="1"/>
+          <p:nvPr/>
+        </p:nvSpPr>
+        <p:spPr>
+          <a:xfrm>
+            <a:off x="457200" y="987552"/>
+            <a:ext cx="3108960" cy="274320"/>
+          </a:xfrm>
+          <a:prstGeom prst="rect">
+            <a:avLst/>
+          </a:prstGeom>
+          <a:noFill/>
+          <a:ln/>
+        </p:spPr>
+        <p:txBody>
+          <a:bodyPr wrap="square" lIns="0" tIns="0" rIns="0" bIns="0" rtlCol="0" anchor="t"/>
+          <a:lstStyle/>
+          <a:p>
+            <a:pPr indent="0" marL="0">
+              <a:buNone/>
+            </a:pPr>
+            <a:r>
+              <a:rPr lang="en-US" sz="1200" b="1" spc="100" kern="0" dirty="0">
+                <a:solidFill>
+                  <a:schemeClr val="accent5"/>
+                </a:solidFill>
+              </a:rPr>
+              <a:t>Typical privacy layer</a:t>
+            </a:r>
+            <a:endParaRPr lang="en-US" sz="1200" dirty="0"/>
+          </a:p>
+        </p:txBody>
+      </p:sp>
+      <p:sp>
+        <p:nvSpPr>
+          <p:cNvPr id="4" name="Text 2"/>
+          <p:cNvSpPr txBox="1"/>
+          <p:nvPr/>
+        </p:nvSpPr>
+        <p:spPr>
+          <a:xfrm>
+            <a:off x="3749040" y="987552"/>
+            <a:ext cx="4937760" cy="274320"/>
+          </a:xfrm>
+          <a:prstGeom prst="rect">
+            <a:avLst/>
+          </a:prstGeom>
+          <a:noFill/>
+          <a:ln/>
+        </p:spPr>
+        <p:txBody>
+          <a:bodyPr wrap="square" lIns="0" tIns="0" rIns="0" bIns="0" rtlCol="0" anchor="t"/>
+          <a:lstStyle/>
+          <a:p>
+            <a:pPr indent="0" marL="0">
+              <a:buNone/>
+            </a:pPr>
+            <a:r>
+              <a:rPr lang="en-US" sz="1200" b="1" spc="100" kern="0" dirty="0">
+                <a:solidFill>
+                  <a:schemeClr val="accent1"/>
+                </a:solidFill>
+              </a:rPr>
+              <a:t>Zen</a:t>
+            </a:r>
+            <a:endParaRPr lang="en-US" sz="1200" dirty="0"/>
+          </a:p>
+        </p:txBody>
+      </p:sp>
+      <p:sp>
+        <p:nvSpPr>
+          <p:cNvPr id="5" name="card"/>
           <p:cNvSpPr/>
           <p:nvPr/>
         </p:nvSpPr>
         <p:spPr>
           <a:xfrm>
-            <a:off x="457200" y="1234440"/>
-            <a:ext cx="1783080" cy="1234440"/>
+            <a:off x="457200" y="1298448"/>
+            <a:ext cx="3108960" cy="576072"/>
           </a:xfrm>
           <a:prstGeom prst="roundRect">
             <a:avLst>
-              <a:gd name="adj" fmla="val 5926"/>
+              <a:gd name="adj" fmla="val 12698"/>
             </a:avLst>
           </a:prstGeom>
           <a:solidFill>
@@ -2712,71 +3170,35 @@
       </p:sp>
       <p:sp>
         <p:nvSpPr>
-          <p:cNvPr id="4" name="Text 2"/>
+          <p:cNvPr id="6" name="Text 4"/>
           <p:cNvSpPr txBox="1"/>
           <p:nvPr/>
         </p:nvSpPr>
         <p:spPr>
           <a:xfrm>
-            <a:off x="594360" y="1344168"/>
-            <a:ext cx="1508760" cy="320040"/>
-          </a:xfrm>
-          <a:prstGeom prst="rect">
-            <a:avLst/>
-          </a:prstGeom>
-          <a:noFill/>
-          <a:ln/>
-        </p:spPr>
-        <p:txBody>
-          <a:bodyPr wrap="square" lIns="0" tIns="0" rIns="0" bIns="0" rtlCol="0" anchor="t"/>
+            <a:off x="594360" y="1298448"/>
+            <a:ext cx="2880360" cy="576072"/>
+          </a:xfrm>
+          <a:prstGeom prst="rect">
+            <a:avLst/>
+          </a:prstGeom>
+          <a:noFill/>
+          <a:ln/>
+        </p:spPr>
+        <p:txBody>
+          <a:bodyPr wrap="square" lIns="0" tIns="0" rIns="0" bIns="0" rtlCol="0" anchor="ctr"/>
           <a:lstStyle/>
           <a:p>
             <a:pPr indent="0" marL="0">
               <a:buNone/>
             </a:pPr>
             <a:r>
-              <a:rPr lang="en-US" sz="1500" b="1" dirty="0">
-                <a:solidFill>
-                  <a:schemeClr val="accent3"/>
-                </a:solidFill>
-              </a:rPr>
-              <a:t>Web page</a:t>
-            </a:r>
-            <a:endParaRPr lang="en-US" sz="1500" dirty="0"/>
-          </a:p>
-        </p:txBody>
-      </p:sp>
-      <p:sp>
-        <p:nvSpPr>
-          <p:cNvPr id="5" name="Text 3"/>
-          <p:cNvSpPr txBox="1"/>
-          <p:nvPr/>
-        </p:nvSpPr>
-        <p:spPr>
-          <a:xfrm>
-            <a:off x="594360" y="1691640"/>
-            <a:ext cx="1508760" cy="731520"/>
-          </a:xfrm>
-          <a:prstGeom prst="rect">
-            <a:avLst/>
-          </a:prstGeom>
-          <a:noFill/>
-          <a:ln/>
-        </p:spPr>
-        <p:txBody>
-          <a:bodyPr wrap="square" lIns="0" tIns="0" rIns="0" bIns="0" rtlCol="0" anchor="t"/>
-          <a:lstStyle/>
-          <a:p>
-            <a:pPr indent="0" marL="0">
-              <a:buNone/>
-            </a:pPr>
-            <a:r>
               <a:rPr lang="en-US" sz="1200" dirty="0">
                 <a:solidFill>
-                  <a:schemeClr val="tx1"/>
-                </a:solidFill>
-              </a:rPr>
-              <a:t>any site, any agent</a:t>
+                  <a:schemeClr val="accent5"/>
+                </a:solidFill>
+              </a:rPr>
+              <a:t>Filters the text you send to one model</a:t>
             </a:r>
             <a:endParaRPr lang="en-US" sz="1200" dirty="0"/>
           </a:p>
@@ -2784,14 +3206,14 @@
       </p:sp>
       <p:sp>
         <p:nvSpPr>
-          <p:cNvPr id="6" name="Shape 4"/>
+          <p:cNvPr id="7" name="Shape 5"/>
           <p:cNvSpPr/>
           <p:nvPr/>
         </p:nvSpPr>
         <p:spPr>
           <a:xfrm>
-            <a:off x="2286000" y="1719072"/>
-            <a:ext cx="256032" cy="274320"/>
+            <a:off x="3593592" y="1481328"/>
+            <a:ext cx="128016" cy="210312"/>
           </a:xfrm>
           <a:prstGeom prst="rightArrow">
             <a:avLst/>
@@ -2809,18 +3231,81 @@
       </p:sp>
       <p:sp>
         <p:nvSpPr>
-          <p:cNvPr id="7" name="card"/>
+          <p:cNvPr id="8" name="card"/>
           <p:cNvSpPr/>
           <p:nvPr/>
         </p:nvSpPr>
         <p:spPr>
           <a:xfrm>
-            <a:off x="2587752" y="1234440"/>
-            <a:ext cx="1783080" cy="1234440"/>
+            <a:off x="3749040" y="1298448"/>
+            <a:ext cx="4937760" cy="576072"/>
           </a:xfrm>
           <a:prstGeom prst="roundRect">
             <a:avLst>
-              <a:gd name="adj" fmla="val 5926"/>
+              <a:gd name="adj" fmla="val 12698"/>
+            </a:avLst>
+          </a:prstGeom>
+          <a:solidFill>
+            <a:srgbClr val="FBE3DA"/>
+          </a:solidFill>
+          <a:ln w="12700">
+            <a:solidFill>
+              <a:srgbClr val="FBE3DA"/>
+            </a:solidFill>
+            <a:prstDash val="solid"/>
+          </a:ln>
+        </p:spPr>
+      </p:sp>
+      <p:sp>
+        <p:nvSpPr>
+          <p:cNvPr id="9" name="Text 7"/>
+          <p:cNvSpPr txBox="1"/>
+          <p:nvPr/>
+        </p:nvSpPr>
+        <p:spPr>
+          <a:xfrm>
+            <a:off x="3886200" y="1298448"/>
+            <a:ext cx="4709160" cy="576072"/>
+          </a:xfrm>
+          <a:prstGeom prst="rect">
+            <a:avLst/>
+          </a:prstGeom>
+          <a:noFill/>
+          <a:ln/>
+        </p:spPr>
+        <p:txBody>
+          <a:bodyPr wrap="square" lIns="0" tIns="0" rIns="0" bIns="0" rtlCol="0" anchor="ctr"/>
+          <a:lstStyle/>
+          <a:p>
+            <a:pPr indent="0" marL="0">
+              <a:buNone/>
+            </a:pPr>
+            <a:r>
+              <a:rPr lang="en-US" sz="1200" dirty="0">
+                <a:solidFill>
+                  <a:schemeClr val="tx2"/>
+                </a:solidFill>
+              </a:rPr>
+              <a:t>Shields the page itself: screenshots, DOM text and input values. Works for any agent, no integration</a:t>
+            </a:r>
+            <a:endParaRPr lang="en-US" sz="1200" dirty="0"/>
+          </a:p>
+        </p:txBody>
+      </p:sp>
+      <p:sp>
+        <p:nvSpPr>
+          <p:cNvPr id="10" name="card"/>
+          <p:cNvSpPr/>
+          <p:nvPr/>
+        </p:nvSpPr>
+        <p:spPr>
+          <a:xfrm>
+            <a:off x="457200" y="1965960"/>
+            <a:ext cx="3108960" cy="576072"/>
+          </a:xfrm>
+          <a:prstGeom prst="roundRect">
+            <a:avLst>
+              <a:gd name="adj" fmla="val 12698"/>
             </a:avLst>
           </a:prstGeom>
           <a:solidFill>
@@ -2836,71 +3321,35 @@
       </p:sp>
       <p:sp>
         <p:nvSpPr>
-          <p:cNvPr id="8" name="Text 6"/>
+          <p:cNvPr id="11" name="Text 9"/>
           <p:cNvSpPr txBox="1"/>
           <p:nvPr/>
         </p:nvSpPr>
         <p:spPr>
           <a:xfrm>
-            <a:off x="2724912" y="1344168"/>
-            <a:ext cx="1508760" cy="320040"/>
-          </a:xfrm>
-          <a:prstGeom prst="rect">
-            <a:avLst/>
-          </a:prstGeom>
-          <a:noFill/>
-          <a:ln/>
-        </p:spPr>
-        <p:txBody>
-          <a:bodyPr wrap="square" lIns="0" tIns="0" rIns="0" bIns="0" rtlCol="0" anchor="t"/>
+            <a:off x="594360" y="1965960"/>
+            <a:ext cx="2880360" cy="576072"/>
+          </a:xfrm>
+          <a:prstGeom prst="rect">
+            <a:avLst/>
+          </a:prstGeom>
+          <a:noFill/>
+          <a:ln/>
+        </p:spPr>
+        <p:txBody>
+          <a:bodyPr wrap="square" lIns="0" tIns="0" rIns="0" bIns="0" rtlCol="0" anchor="ctr"/>
           <a:lstStyle/>
           <a:p>
             <a:pPr indent="0" marL="0">
               <a:buNone/>
             </a:pPr>
             <a:r>
-              <a:rPr lang="en-US" sz="1500" b="1" dirty="0">
-                <a:solidFill>
-                  <a:schemeClr val="accent3"/>
-                </a:solidFill>
-              </a:rPr>
-              <a:t>Detect locally</a:t>
-            </a:r>
-            <a:endParaRPr lang="en-US" sz="1500" dirty="0"/>
-          </a:p>
-        </p:txBody>
-      </p:sp>
-      <p:sp>
-        <p:nvSpPr>
-          <p:cNvPr id="9" name="Text 7"/>
-          <p:cNvSpPr txBox="1"/>
-          <p:nvPr/>
-        </p:nvSpPr>
-        <p:spPr>
-          <a:xfrm>
-            <a:off x="2724912" y="1691640"/>
-            <a:ext cx="1508760" cy="731520"/>
-          </a:xfrm>
-          <a:prstGeom prst="rect">
-            <a:avLst/>
-          </a:prstGeom>
-          <a:noFill/>
-          <a:ln/>
-        </p:spPr>
-        <p:txBody>
-          <a:bodyPr wrap="square" lIns="0" tIns="0" rIns="0" bIns="0" rtlCol="0" anchor="t"/>
-          <a:lstStyle/>
-          <a:p>
-            <a:pPr indent="0" marL="0">
-              <a:buNone/>
-            </a:pPr>
-            <a:r>
               <a:rPr lang="en-US" sz="1200" dirty="0">
                 <a:solidFill>
-                  <a:schemeClr val="tx1"/>
-                </a:solidFill>
-              </a:rPr>
-              <a:t>detect.js + structural.js + face detector</a:t>
+                  <a:schemeClr val="accent5"/>
+                </a:solidFill>
+              </a:rPr>
+              <a:t>Blanks values out, so the AI loses the thread</a:t>
             </a:r>
             <a:endParaRPr lang="en-US" sz="1200" dirty="0"/>
           </a:p>
@@ -2908,14 +3357,14 @@
       </p:sp>
       <p:sp>
         <p:nvSpPr>
-          <p:cNvPr id="10" name="Shape 8"/>
+          <p:cNvPr id="12" name="Shape 10"/>
           <p:cNvSpPr/>
           <p:nvPr/>
         </p:nvSpPr>
         <p:spPr>
           <a:xfrm>
-            <a:off x="4416552" y="1719072"/>
-            <a:ext cx="256032" cy="274320"/>
+            <a:off x="3593592" y="2148840"/>
+            <a:ext cx="128016" cy="210312"/>
           </a:xfrm>
           <a:prstGeom prst="rightArrow">
             <a:avLst/>
@@ -2933,18 +3382,81 @@
       </p:sp>
       <p:sp>
         <p:nvSpPr>
-          <p:cNvPr id="11" name="card"/>
+          <p:cNvPr id="13" name="card"/>
           <p:cNvSpPr/>
           <p:nvPr/>
         </p:nvSpPr>
         <p:spPr>
           <a:xfrm>
-            <a:off x="4718304" y="1234440"/>
-            <a:ext cx="1783080" cy="1234440"/>
+            <a:off x="3749040" y="1965960"/>
+            <a:ext cx="4937760" cy="576072"/>
           </a:xfrm>
           <a:prstGeom prst="roundRect">
             <a:avLst>
-              <a:gd name="adj" fmla="val 5926"/>
+              <a:gd name="adj" fmla="val 12698"/>
+            </a:avLst>
+          </a:prstGeom>
+          <a:solidFill>
+            <a:srgbClr val="FBE3DA"/>
+          </a:solidFill>
+          <a:ln w="12700">
+            <a:solidFill>
+              <a:srgbClr val="FBE3DA"/>
+            </a:solidFill>
+            <a:prstDash val="solid"/>
+          </a:ln>
+        </p:spPr>
+      </p:sp>
+      <p:sp>
+        <p:nvSpPr>
+          <p:cNvPr id="14" name="Text 12"/>
+          <p:cNvSpPr txBox="1"/>
+          <p:nvPr/>
+        </p:nvSpPr>
+        <p:spPr>
+          <a:xfrm>
+            <a:off x="3886200" y="1965960"/>
+            <a:ext cx="4709160" cy="576072"/>
+          </a:xfrm>
+          <a:prstGeom prst="rect">
+            <a:avLst/>
+          </a:prstGeom>
+          <a:noFill/>
+          <a:ln/>
+        </p:spPr>
+        <p:txBody>
+          <a:bodyPr wrap="square" lIns="0" tIns="0" rIns="0" bIns="0" rtlCol="0" anchor="ctr"/>
+          <a:lstStyle/>
+          <a:p>
+            <a:pPr indent="0" marL="0">
+              <a:buNone/>
+            </a:pPr>
+            <a:r>
+              <a:rPr lang="en-US" sz="1200" dirty="0">
+                <a:solidFill>
+                  <a:schemeClr val="tx2"/>
+                </a:solidFill>
+              </a:rPr>
+              <a:t>Consistent pseudonyms ([EMAIL_1], [CARD_1]); the AI types the token, the real value is filled locally</a:t>
+            </a:r>
+            <a:endParaRPr lang="en-US" sz="1200" dirty="0"/>
+          </a:p>
+        </p:txBody>
+      </p:sp>
+      <p:sp>
+        <p:nvSpPr>
+          <p:cNvPr id="15" name="card"/>
+          <p:cNvSpPr/>
+          <p:nvPr/>
+        </p:nvSpPr>
+        <p:spPr>
+          <a:xfrm>
+            <a:off x="457200" y="2633472"/>
+            <a:ext cx="3108960" cy="576072"/>
+          </a:xfrm>
+          <a:prstGeom prst="roundRect">
+            <a:avLst>
+              <a:gd name="adj" fmla="val 12698"/>
             </a:avLst>
           </a:prstGeom>
           <a:solidFill>
@@ -2960,71 +3472,35 @@
       </p:sp>
       <p:sp>
         <p:nvSpPr>
-          <p:cNvPr id="12" name="Text 10"/>
+          <p:cNvPr id="16" name="Text 14"/>
           <p:cNvSpPr txBox="1"/>
           <p:nvPr/>
         </p:nvSpPr>
         <p:spPr>
           <a:xfrm>
-            <a:off x="4855464" y="1344168"/>
-            <a:ext cx="1508760" cy="320040"/>
-          </a:xfrm>
-          <a:prstGeom prst="rect">
-            <a:avLst/>
-          </a:prstGeom>
-          <a:noFill/>
-          <a:ln/>
-        </p:spPr>
-        <p:txBody>
-          <a:bodyPr wrap="square" lIns="0" tIns="0" rIns="0" bIns="0" rtlCol="0" anchor="t"/>
+            <a:off x="594360" y="2633472"/>
+            <a:ext cx="2880360" cy="576072"/>
+          </a:xfrm>
+          <a:prstGeom prst="rect">
+            <a:avLst/>
+          </a:prstGeom>
+          <a:noFill/>
+          <a:ln/>
+        </p:spPr>
+        <p:txBody>
+          <a:bodyPr wrap="square" lIns="0" tIns="0" rIns="0" bIns="0" rtlCol="0" anchor="ctr"/>
           <a:lstStyle/>
           <a:p>
             <a:pPr indent="0" marL="0">
               <a:buNone/>
             </a:pPr>
             <a:r>
-              <a:rPr lang="en-US" sz="1500" b="1" dirty="0">
-                <a:solidFill>
-                  <a:schemeClr val="accent3"/>
-                </a:solidFill>
-              </a:rPr>
-              <a:t>Shield</a:t>
-            </a:r>
-            <a:endParaRPr lang="en-US" sz="1500" dirty="0"/>
-          </a:p>
-        </p:txBody>
-      </p:sp>
-      <p:sp>
-        <p:nvSpPr>
-          <p:cNvPr id="13" name="Text 11"/>
-          <p:cNvSpPr txBox="1"/>
-          <p:nvPr/>
-        </p:nvSpPr>
-        <p:spPr>
-          <a:xfrm>
-            <a:off x="4855464" y="1691640"/>
-            <a:ext cx="1508760" cy="731520"/>
-          </a:xfrm>
-          <a:prstGeom prst="rect">
-            <a:avLst/>
-          </a:prstGeom>
-          <a:noFill/>
-          <a:ln/>
-        </p:spPr>
-        <p:txBody>
-          <a:bodyPr wrap="square" lIns="0" tIns="0" rIns="0" bIns="0" rtlCol="0" anchor="t"/>
-          <a:lstStyle/>
-          <a:p>
-            <a:pPr indent="0" marL="0">
-              <a:buNone/>
-            </a:pPr>
-            <a:r>
               <a:rPr lang="en-US" sz="1200" dirty="0">
                 <a:solidFill>
-                  <a:schemeClr val="tx1"/>
-                </a:solidFill>
-              </a:rPr>
-              <a:t>covers pixels, rewrites DOM text and input values</a:t>
+                  <a:schemeClr val="accent5"/>
+                </a:solidFill>
+              </a:rPr>
+              <a:t>Counts regex hits, ignores what can be inferred</a:t>
             </a:r>
             <a:endParaRPr lang="en-US" sz="1200" dirty="0"/>
           </a:p>
@@ -3032,14 +3508,14 @@
       </p:sp>
       <p:sp>
         <p:nvSpPr>
-          <p:cNvPr id="14" name="Shape 12"/>
+          <p:cNvPr id="17" name="Shape 15"/>
           <p:cNvSpPr/>
           <p:nvPr/>
         </p:nvSpPr>
         <p:spPr>
           <a:xfrm>
-            <a:off x="6547104" y="1719072"/>
-            <a:ext cx="256032" cy="274320"/>
+            <a:off x="3593592" y="2816352"/>
+            <a:ext cx="128016" cy="210312"/>
           </a:xfrm>
           <a:prstGeom prst="rightArrow">
             <a:avLst/>
@@ -3057,153 +3533,18 @@
       </p:sp>
       <p:sp>
         <p:nvSpPr>
-          <p:cNvPr id="15" name="card"/>
+          <p:cNvPr id="18" name="card"/>
           <p:cNvSpPr/>
           <p:nvPr/>
         </p:nvSpPr>
         <p:spPr>
           <a:xfrm>
-            <a:off x="6848856" y="1234440"/>
-            <a:ext cx="1783080" cy="1234440"/>
+            <a:off x="3749040" y="2633472"/>
+            <a:ext cx="4937760" cy="576072"/>
           </a:xfrm>
           <a:prstGeom prst="roundRect">
             <a:avLst>
-              <a:gd name="adj" fmla="val 5926"/>
-            </a:avLst>
-          </a:prstGeom>
-          <a:solidFill>
-            <a:schemeClr val="tx2"/>
-          </a:solidFill>
-          <a:ln w="12700">
-            <a:solidFill>
-              <a:schemeClr val="tx2"/>
-            </a:solidFill>
-            <a:prstDash val="solid"/>
-          </a:ln>
-        </p:spPr>
-      </p:sp>
-      <p:sp>
-        <p:nvSpPr>
-          <p:cNvPr id="16" name="Text 14"/>
-          <p:cNvSpPr txBox="1"/>
-          <p:nvPr/>
-        </p:nvSpPr>
-        <p:spPr>
-          <a:xfrm>
-            <a:off x="6986016" y="1344168"/>
-            <a:ext cx="1508760" cy="320040"/>
-          </a:xfrm>
-          <a:prstGeom prst="rect">
-            <a:avLst/>
-          </a:prstGeom>
-          <a:noFill/>
-          <a:ln/>
-        </p:spPr>
-        <p:txBody>
-          <a:bodyPr wrap="square" lIns="0" tIns="0" rIns="0" bIns="0" rtlCol="0" anchor="t"/>
-          <a:lstStyle/>
-          <a:p>
-            <a:pPr indent="0" marL="0">
-              <a:buNone/>
-            </a:pPr>
-            <a:r>
-              <a:rPr lang="en-US" sz="1500" b="1" dirty="0">
-                <a:solidFill>
-                  <a:schemeClr val="accent2"/>
-                </a:solidFill>
-              </a:rPr>
-              <a:t>Agent / LLM</a:t>
-            </a:r>
-            <a:endParaRPr lang="en-US" sz="1500" dirty="0"/>
-          </a:p>
-        </p:txBody>
-      </p:sp>
-      <p:sp>
-        <p:nvSpPr>
-          <p:cNvPr id="17" name="Text 15"/>
-          <p:cNvSpPr txBox="1"/>
-          <p:nvPr/>
-        </p:nvSpPr>
-        <p:spPr>
-          <a:xfrm>
-            <a:off x="6986016" y="1691640"/>
-            <a:ext cx="1508760" cy="731520"/>
-          </a:xfrm>
-          <a:prstGeom prst="rect">
-            <a:avLst/>
-          </a:prstGeom>
-          <a:noFill/>
-          <a:ln/>
-        </p:spPr>
-        <p:txBody>
-          <a:bodyPr wrap="square" lIns="0" tIns="0" rIns="0" bIns="0" rtlCol="0" anchor="t"/>
-          <a:lstStyle/>
-          <a:p>
-            <a:pPr indent="0" marL="0">
-              <a:buNone/>
-            </a:pPr>
-            <a:r>
-              <a:rPr lang="en-US" sz="1200" dirty="0">
-                <a:solidFill>
-                  <a:schemeClr val="bg2"/>
-                </a:solidFill>
-              </a:rPr>
-              <a:t>sees [REDACTED:KIND] only</a:t>
-            </a:r>
-            <a:endParaRPr lang="en-US" sz="1200" dirty="0"/>
-          </a:p>
-        </p:txBody>
-      </p:sp>
-      <p:sp>
-        <p:nvSpPr>
-          <p:cNvPr id="18" name="Text 16"/>
-          <p:cNvSpPr txBox="1"/>
-          <p:nvPr/>
-        </p:nvSpPr>
-        <p:spPr>
-          <a:xfrm>
-            <a:off x="457200" y="2560320"/>
-            <a:ext cx="6217920" cy="274320"/>
-          </a:xfrm>
-          <a:prstGeom prst="rect">
-            <a:avLst/>
-          </a:prstGeom>
-          <a:noFill/>
-          <a:ln/>
-        </p:spPr>
-        <p:txBody>
-          <a:bodyPr wrap="square" lIns="0" tIns="0" rIns="0" bIns="0" rtlCol="0" anchor="t"/>
-          <a:lstStyle/>
-          <a:p>
-            <a:pPr indent="0" marL="0">
-              <a:buNone/>
-            </a:pPr>
-            <a:r>
-              <a:rPr lang="en-US" sz="1100" i="1" dirty="0">
-                <a:solidFill>
-                  <a:schemeClr val="accent5"/>
-                </a:solidFill>
-              </a:rPr>
-              <a:t>Local trust boundary: page → detection → shield</a:t>
-            </a:r>
-            <a:endParaRPr lang="en-US" sz="1100" dirty="0"/>
-          </a:p>
-        </p:txBody>
-      </p:sp>
-      <p:sp>
-        <p:nvSpPr>
-          <p:cNvPr id="19" name="card"/>
-          <p:cNvSpPr/>
-          <p:nvPr/>
-        </p:nvSpPr>
-        <p:spPr>
-          <a:xfrm>
-            <a:off x="457200" y="2971800"/>
-            <a:ext cx="2606040" cy="1600200"/>
-          </a:xfrm>
-          <a:prstGeom prst="roundRect">
-            <a:avLst>
-              <a:gd name="adj" fmla="val 4571"/>
+              <a:gd name="adj" fmla="val 12698"/>
             </a:avLst>
           </a:prstGeom>
           <a:solidFill>
@@ -3219,71 +3560,35 @@
       </p:sp>
       <p:sp>
         <p:nvSpPr>
-          <p:cNvPr id="20" name="Text 18"/>
+          <p:cNvPr id="19" name="Text 17"/>
           <p:cNvSpPr txBox="1"/>
           <p:nvPr/>
         </p:nvSpPr>
         <p:spPr>
           <a:xfrm>
-            <a:off x="621792" y="3090672"/>
-            <a:ext cx="2286000" cy="320040"/>
-          </a:xfrm>
-          <a:prstGeom prst="rect">
-            <a:avLst/>
-          </a:prstGeom>
-          <a:noFill/>
-          <a:ln/>
-        </p:spPr>
-        <p:txBody>
-          <a:bodyPr wrap="square" lIns="0" tIns="0" rIns="0" bIns="0" rtlCol="0" anchor="t"/>
+            <a:off x="3886200" y="2633472"/>
+            <a:ext cx="4709160" cy="576072"/>
+          </a:xfrm>
+          <a:prstGeom prst="rect">
+            <a:avLst/>
+          </a:prstGeom>
+          <a:noFill/>
+          <a:ln/>
+        </p:spPr>
+        <p:txBody>
+          <a:bodyPr wrap="square" lIns="0" tIns="0" rIns="0" bIns="0" rtlCol="0" anchor="ctr"/>
           <a:lstStyle/>
           <a:p>
             <a:pPr indent="0" marL="0">
               <a:buNone/>
             </a:pPr>
             <a:r>
-              <a:rPr lang="en-US" sz="1500" b="1" dirty="0">
+              <a:rPr lang="en-US" sz="1200" dirty="0">
                 <a:solidFill>
                   <a:schemeClr val="tx2"/>
                 </a:solidFill>
               </a:rPr>
-              <a:t>Chrome extension (main)</a:t>
-            </a:r>
-            <a:endParaRPr lang="en-US" sz="1500" dirty="0"/>
-          </a:p>
-        </p:txBody>
-      </p:sp>
-      <p:sp>
-        <p:nvSpPr>
-          <p:cNvPr id="21" name="Text 19"/>
-          <p:cNvSpPr txBox="1"/>
-          <p:nvPr/>
-        </p:nvSpPr>
-        <p:spPr>
-          <a:xfrm>
-            <a:off x="621792" y="3438144"/>
-            <a:ext cx="2286000" cy="1051560"/>
-          </a:xfrm>
-          <a:prstGeom prst="rect">
-            <a:avLst/>
-          </a:prstGeom>
-          <a:noFill/>
-          <a:ln/>
-        </p:spPr>
-        <p:txBody>
-          <a:bodyPr wrap="square" lIns="0" tIns="0" rIns="0" bIns="0" rtlCol="0" anchor="t"/>
-          <a:lstStyle/>
-          <a:p>
-            <a:pPr indent="0" marL="0">
-              <a:buNone/>
-            </a:pPr>
-            <a:r>
-              <a:rPr lang="en-US" sz="1200" dirty="0">
-                <a:solidFill>
-                  <a:schemeClr val="tx1"/>
-                </a:solidFill>
-              </a:rPr>
-              <a:t>Agent Shield for any agent driving the browser, highlight and mask, AI-chat send guard. Works offline.</a:t>
+              <a:t>Red-teams inference (“card ending 4242”, DOB + PIN) and minimises the hints away</a:t>
             </a:r>
             <a:endParaRPr lang="en-US" sz="1200" dirty="0"/>
           </a:p>
@@ -3291,18 +3596,18 @@
       </p:sp>
       <p:sp>
         <p:nvSpPr>
-          <p:cNvPr id="22" name="card"/>
+          <p:cNvPr id="20" name="card"/>
           <p:cNvSpPr/>
           <p:nvPr/>
         </p:nvSpPr>
         <p:spPr>
           <a:xfrm>
-            <a:off x="3264408" y="2971800"/>
-            <a:ext cx="2606040" cy="1600200"/>
+            <a:off x="457200" y="3300984"/>
+            <a:ext cx="3108960" cy="576072"/>
           </a:xfrm>
           <a:prstGeom prst="roundRect">
             <a:avLst>
-              <a:gd name="adj" fmla="val 4571"/>
+              <a:gd name="adj" fmla="val 12698"/>
             </a:avLst>
           </a:prstGeom>
           <a:solidFill>
@@ -3318,39 +3623,91 @@
       </p:sp>
       <p:sp>
         <p:nvSpPr>
-          <p:cNvPr id="23" name="Text 21"/>
+          <p:cNvPr id="21" name="Text 19"/>
           <p:cNvSpPr txBox="1"/>
           <p:nvPr/>
         </p:nvSpPr>
         <p:spPr>
           <a:xfrm>
-            <a:off x="3429000" y="3090672"/>
-            <a:ext cx="2286000" cy="320040"/>
-          </a:xfrm>
-          <a:prstGeom prst="rect">
-            <a:avLst/>
-          </a:prstGeom>
-          <a:noFill/>
-          <a:ln/>
-        </p:spPr>
-        <p:txBody>
-          <a:bodyPr wrap="square" lIns="0" tIns="0" rIns="0" bIns="0" rtlCol="0" anchor="t"/>
+            <a:off x="594360" y="3300984"/>
+            <a:ext cx="2880360" cy="576072"/>
+          </a:xfrm>
+          <a:prstGeom prst="rect">
+            <a:avLst/>
+          </a:prstGeom>
+          <a:noFill/>
+          <a:ln/>
+        </p:spPr>
+        <p:txBody>
+          <a:bodyPr wrap="square" lIns="0" tIns="0" rIns="0" bIns="0" rtlCol="0" anchor="ctr"/>
           <a:lstStyle/>
           <a:p>
             <a:pPr indent="0" marL="0">
               <a:buNone/>
             </a:pPr>
             <a:r>
-              <a:rPr lang="en-US" sz="1500" b="1" dirty="0">
-                <a:solidFill>
-                  <a:schemeClr val="tx2"/>
-                </a:solidFill>
-              </a:rPr>
-              <a:t>Python agent</a:t>
-            </a:r>
-            <a:endParaRPr lang="en-US" sz="1500" dirty="0"/>
-          </a:p>
-        </p:txBody>
+              <a:rPr lang="en-US" sz="1200" dirty="0">
+                <a:solidFill>
+                  <a:schemeClr val="accent5"/>
+                </a:solidFill>
+              </a:rPr>
+              <a:t>Trusts the model's actions</a:t>
+            </a:r>
+            <a:endParaRPr lang="en-US" sz="1200" dirty="0"/>
+          </a:p>
+        </p:txBody>
+      </p:sp>
+      <p:sp>
+        <p:nvSpPr>
+          <p:cNvPr id="22" name="Shape 20"/>
+          <p:cNvSpPr/>
+          <p:nvPr/>
+        </p:nvSpPr>
+        <p:spPr>
+          <a:xfrm>
+            <a:off x="3593592" y="3483864"/>
+            <a:ext cx="128016" cy="210312"/>
+          </a:xfrm>
+          <a:prstGeom prst="rightArrow">
+            <a:avLst/>
+          </a:prstGeom>
+          <a:solidFill>
+            <a:schemeClr val="accent1"/>
+          </a:solidFill>
+          <a:ln w="12700">
+            <a:solidFill>
+              <a:schemeClr val="accent1"/>
+            </a:solidFill>
+            <a:prstDash val="solid"/>
+          </a:ln>
+        </p:spPr>
+      </p:sp>
+      <p:sp>
+        <p:nvSpPr>
+          <p:cNvPr id="23" name="card"/>
+          <p:cNvSpPr/>
+          <p:nvPr/>
+        </p:nvSpPr>
+        <p:spPr>
+          <a:xfrm>
+            <a:off x="3749040" y="3300984"/>
+            <a:ext cx="4937760" cy="576072"/>
+          </a:xfrm>
+          <a:prstGeom prst="roundRect">
+            <a:avLst>
+              <a:gd name="adj" fmla="val 12698"/>
+            </a:avLst>
+          </a:prstGeom>
+          <a:solidFill>
+            <a:srgbClr val="FBE3DA"/>
+          </a:solidFill>
+          <a:ln w="12700">
+            <a:solidFill>
+              <a:srgbClr val="FBE3DA"/>
+            </a:solidFill>
+            <a:prstDash val="solid"/>
+          </a:ln>
+        </p:spPr>
       </p:sp>
       <p:sp>
         <p:nvSpPr>
@@ -3360,17 +3717,17 @@
         </p:nvSpPr>
         <p:spPr>
           <a:xfrm>
-            <a:off x="3429000" y="3438144"/>
-            <a:ext cx="2286000" cy="1051560"/>
-          </a:xfrm>
-          <a:prstGeom prst="rect">
-            <a:avLst/>
-          </a:prstGeom>
-          <a:noFill/>
-          <a:ln/>
-        </p:spPr>
-        <p:txBody>
-          <a:bodyPr wrap="square" lIns="0" tIns="0" rIns="0" bIns="0" rtlCol="0" anchor="t"/>
+            <a:off x="3886200" y="3300984"/>
+            <a:ext cx="4709160" cy="576072"/>
+          </a:xfrm>
+          <a:prstGeom prst="rect">
+            <a:avLst/>
+          </a:prstGeom>
+          <a:noFill/>
+          <a:ln/>
+        </p:spPr>
+        <p:txBody>
+          <a:bodyPr wrap="square" lIns="0" tIns="0" rIns="0" bIns="0" rtlCol="0" anchor="ctr"/>
           <a:lstStyle/>
           <a:p>
             <a:pPr indent="0" marL="0">
@@ -3379,10 +3736,10 @@
             <a:r>
               <a:rPr lang="en-US" sz="1200" dirty="0">
                 <a:solidFill>
-                  <a:schemeClr val="tx1"/>
-                </a:solidFill>
-              </a:rPr>
-              <a:t>Playwright loop: sanitized view → fail-closed egress gate → model → local executor with vault and approvals.</a:t>
+                  <a:schemeClr val="tx2"/>
+                </a:solidFill>
+              </a:rPr>
+              <a:t>Local executor checks every action; secrets stay in a vault as {{SECRET:name}}; risky clicks need approval</a:t>
             </a:r>
             <a:endParaRPr lang="en-US" sz="1200" dirty="0"/>
           </a:p>
@@ -3396,12 +3753,12 @@
         </p:nvSpPr>
         <p:spPr>
           <a:xfrm>
-            <a:off x="6071616" y="2971800"/>
-            <a:ext cx="2606040" cy="1600200"/>
+            <a:off x="457200" y="3968496"/>
+            <a:ext cx="3108960" cy="576072"/>
           </a:xfrm>
           <a:prstGeom prst="roundRect">
             <a:avLst>
-              <a:gd name="adj" fmla="val 4571"/>
+              <a:gd name="adj" fmla="val 12698"/>
             </a:avLst>
           </a:prstGeom>
           <a:solidFill>
@@ -3423,65 +3780,117 @@
         </p:nvSpPr>
         <p:spPr>
           <a:xfrm>
-            <a:off x="6236208" y="3090672"/>
-            <a:ext cx="2286000" cy="320040"/>
-          </a:xfrm>
-          <a:prstGeom prst="rect">
-            <a:avLst/>
-          </a:prstGeom>
-          <a:noFill/>
-          <a:ln/>
-        </p:spPr>
-        <p:txBody>
-          <a:bodyPr wrap="square" lIns="0" tIns="0" rIns="0" bIns="0" rtlCol="0" anchor="t"/>
+            <a:off x="594360" y="3968496"/>
+            <a:ext cx="2880360" cy="576072"/>
+          </a:xfrm>
+          <a:prstGeom prst="rect">
+            <a:avLst/>
+          </a:prstGeom>
+          <a:noFill/>
+          <a:ln/>
+        </p:spPr>
+        <p:txBody>
+          <a:bodyPr wrap="square" lIns="0" tIns="0" rIns="0" bIns="0" rtlCol="0" anchor="ctr"/>
           <a:lstStyle/>
           <a:p>
             <a:pPr indent="0" marL="0">
               <a:buNone/>
             </a:pPr>
             <a:r>
-              <a:rPr lang="en-US" sz="1500" b="1" dirty="0">
+              <a:rPr lang="en-US" sz="1200" dirty="0">
+                <a:solidFill>
+                  <a:schemeClr val="accent5"/>
+                </a:solidFill>
+              </a:rPr>
+              <a:t>Fails open if a check breaks</a:t>
+            </a:r>
+            <a:endParaRPr lang="en-US" sz="1200" dirty="0"/>
+          </a:p>
+        </p:txBody>
+      </p:sp>
+      <p:sp>
+        <p:nvSpPr>
+          <p:cNvPr id="27" name="Shape 25"/>
+          <p:cNvSpPr/>
+          <p:nvPr/>
+        </p:nvSpPr>
+        <p:spPr>
+          <a:xfrm>
+            <a:off x="3593592" y="4151376"/>
+            <a:ext cx="128016" cy="210312"/>
+          </a:xfrm>
+          <a:prstGeom prst="rightArrow">
+            <a:avLst/>
+          </a:prstGeom>
+          <a:solidFill>
+            <a:schemeClr val="accent1"/>
+          </a:solidFill>
+          <a:ln w="12700">
+            <a:solidFill>
+              <a:schemeClr val="accent1"/>
+            </a:solidFill>
+            <a:prstDash val="solid"/>
+          </a:ln>
+        </p:spPr>
+      </p:sp>
+      <p:sp>
+        <p:nvSpPr>
+          <p:cNvPr id="28" name="card"/>
+          <p:cNvSpPr/>
+          <p:nvPr/>
+        </p:nvSpPr>
+        <p:spPr>
+          <a:xfrm>
+            <a:off x="3749040" y="3968496"/>
+            <a:ext cx="4937760" cy="576072"/>
+          </a:xfrm>
+          <a:prstGeom prst="roundRect">
+            <a:avLst>
+              <a:gd name="adj" fmla="val 12698"/>
+            </a:avLst>
+          </a:prstGeom>
+          <a:solidFill>
+            <a:srgbClr val="FBE3DA"/>
+          </a:solidFill>
+          <a:ln w="12700">
+            <a:solidFill>
+              <a:srgbClr val="FBE3DA"/>
+            </a:solidFill>
+            <a:prstDash val="solid"/>
+          </a:ln>
+        </p:spPr>
+      </p:sp>
+      <p:sp>
+        <p:nvSpPr>
+          <p:cNvPr id="29" name="Text 27"/>
+          <p:cNvSpPr txBox="1"/>
+          <p:nvPr/>
+        </p:nvSpPr>
+        <p:spPr>
+          <a:xfrm>
+            <a:off x="3886200" y="3968496"/>
+            <a:ext cx="4709160" cy="576072"/>
+          </a:xfrm>
+          <a:prstGeom prst="rect">
+            <a:avLst/>
+          </a:prstGeom>
+          <a:noFill/>
+          <a:ln/>
+        </p:spPr>
+        <p:txBody>
+          <a:bodyPr wrap="square" lIns="0" tIns="0" rIns="0" bIns="0" rtlCol="0" anchor="ctr"/>
+          <a:lstStyle/>
+          <a:p>
+            <a:pPr indent="0" marL="0">
+              <a:buNone/>
+            </a:pPr>
+            <a:r>
+              <a:rPr lang="en-US" sz="1200" dirty="0">
                 <a:solidFill>
                   <a:schemeClr val="tx2"/>
                 </a:solidFill>
               </a:rPr>
-              <a:t>Web app (PWA)</a:t>
-            </a:r>
-            <a:endParaRPr lang="en-US" sz="1500" dirty="0"/>
-          </a:p>
-        </p:txBody>
-      </p:sp>
-      <p:sp>
-        <p:nvSpPr>
-          <p:cNvPr id="27" name="Text 25"/>
-          <p:cNvSpPr txBox="1"/>
-          <p:nvPr/>
-        </p:nvSpPr>
-        <p:spPr>
-          <a:xfrm>
-            <a:off x="6236208" y="3438144"/>
-            <a:ext cx="2286000" cy="1051560"/>
-          </a:xfrm>
-          <a:prstGeom prst="rect">
-            <a:avLst/>
-          </a:prstGeom>
-          <a:noFill/>
-          <a:ln/>
-        </p:spPr>
-        <p:txBody>
-          <a:bodyPr wrap="square" lIns="0" tIns="0" rIns="0" bIns="0" rtlCol="0" anchor="t"/>
-          <a:lstStyle/>
-          <a:p>
-            <a:pPr indent="0" marL="0">
-              <a:buNone/>
-            </a:pPr>
-            <a:r>
-              <a:rPr lang="en-US" sz="1200" dirty="0">
-                <a:solidFill>
-                  <a:schemeClr val="tx1"/>
-                </a:solidFill>
-              </a:rPr>
-              <a:t>Before/after previews for text, screenshots and pages on PC and phone.</a:t>
+              <a:t>Fail-closed egress gate with canaries; a scanner error blocks the send</a:t>
             </a:r>
             <a:endParaRPr lang="en-US" sz="1200" dirty="0"/>
           </a:p>
@@ -3592,7 +4001,7 @@
                 <a:ea typeface="Cambria" pitchFamily="34" charset="-122"/>
                 <a:cs typeface="Cambria" pitchFamily="34" charset="-120"/>
               </a:rPr>
-              <a:t>Detection in depth, all inside the browser</a:t>
+              <a:t>Everything sensitive is decided on the device</a:t>
             </a:r>
             <a:endParaRPr lang="en-US" sz="3000" dirty="0"/>
           </a:p>
@@ -3600,39 +4009,34 @@
       </p:sp>
       <p:sp>
         <p:nvSpPr>
-          <p:cNvPr id="3" name="Shape 1"/>
+          <p:cNvPr id="3" name="card"/>
           <p:cNvSpPr/>
           <p:nvPr/>
         </p:nvSpPr>
         <p:spPr>
           <a:xfrm>
-            <a:off x="457200" y="1097280"/>
-            <a:ext cx="3566160" cy="3264408"/>
-          </a:xfrm>
-          <a:prstGeom prst="rect">
-            <a:avLst/>
+            <a:off x="457200" y="1051560"/>
+            <a:ext cx="8229600" cy="2377440"/>
+          </a:xfrm>
+          <a:prstGeom prst="roundRect">
+            <a:avLst>
+              <a:gd name="adj" fmla="val 3077"/>
+            </a:avLst>
           </a:prstGeom>
           <a:solidFill>
-            <a:srgbClr val="FFFFFF"/>
+            <a:schemeClr val="tx2"/>
           </a:solidFill>
           <a:ln w="12700">
             <a:solidFill>
-              <a:schemeClr val="accent6"/>
+              <a:schemeClr val="tx2"/>
             </a:solidFill>
             <a:prstDash val="solid"/>
           </a:ln>
-          <a:effectLst>
-            <a:outerShdw sx="100000" sy="100000" kx="0" ky="0" algn="bl" rotWithShape="0" blurRad="76200" dist="25400" dir="5400000">
-              <a:srgbClr val="000000">
-                <a:alpha val="15000"/>
-              </a:srgbClr>
-            </a:outerShdw>
-          </a:effectLst>
         </p:spPr>
       </p:sp>
       <p:pic>
         <p:nvPicPr>
-          <p:cNvPr id="4" name="Image 0" descr="Checkout page with each sensitive value outlined and labelled by kind">    </p:cNvPr>
+          <p:cNvPr id="4" name="Image 0" descr="Data flow: page capture, local detectors, sanitized view, minimize, fail-closed gate, then the external LLM; actions come back through a local executor with vault, pseudonym map and user approval">    </p:cNvPr>
           <p:cNvPicPr>
             <a:picLocks noChangeAspect="1"/>
           </p:cNvPicPr>
@@ -3646,8 +4050,8 @@
         </p:blipFill>
         <p:spPr>
           <a:xfrm>
-            <a:off x="457200" y="1097280"/>
-            <a:ext cx="3566160" cy="3264408"/>
+            <a:off x="502920" y="1097280"/>
+            <a:ext cx="8138160" cy="2240280"/>
           </a:xfrm>
           <a:prstGeom prst="rect">
             <a:avLst/>
@@ -3662,8 +4066,8 @@
         </p:nvSpPr>
         <p:spPr>
           <a:xfrm>
-            <a:off x="457200" y="4434840"/>
-            <a:ext cx="3566160" cy="274320"/>
+            <a:off x="457200" y="3611880"/>
+            <a:ext cx="2606040" cy="274320"/>
           </a:xfrm>
           <a:prstGeom prst="rect">
             <a:avLst/>
@@ -3679,41 +4083,52 @@
               <a:buNone/>
             </a:pPr>
             <a:r>
-              <a:rPr lang="en-US" sz="1100" i="1" dirty="0">
-                <a:solidFill>
-                  <a:schemeClr val="accent5"/>
-                </a:solidFill>
-              </a:rPr>
-              <a:t>Highlight mode: every finding outlined and labelled</a:t>
-            </a:r>
-            <a:endParaRPr lang="en-US" sz="1100" dirty="0"/>
-          </a:p>
-        </p:txBody>
-      </p:sp>
-      <p:sp>
-        <p:nvSpPr>
-          <p:cNvPr id="6" name="Shape 3"/>
-          <p:cNvSpPr/>
-          <p:nvPr/>
-        </p:nvSpPr>
-        <p:spPr>
-          <a:xfrm>
-            <a:off x="4434840" y="1143000"/>
-            <a:ext cx="457200" cy="457200"/>
-          </a:xfrm>
-          <a:prstGeom prst="ellipse">
-            <a:avLst/>
-          </a:prstGeom>
-          <a:solidFill>
-            <a:schemeClr val="accent1"/>
-          </a:solidFill>
-          <a:ln w="12700">
-            <a:solidFill>
-              <a:schemeClr val="accent1"/>
-            </a:solidFill>
-            <a:prstDash val="solid"/>
-          </a:ln>
-        </p:spPr>
+              <a:rPr lang="en-US" sz="1400" b="1" dirty="0">
+                <a:solidFill>
+                  <a:schemeClr val="accent3"/>
+                </a:solidFill>
+              </a:rPr>
+              <a:t>Only sanitized JSON crosses</a:t>
+            </a:r>
+            <a:endParaRPr lang="en-US" sz="1400" dirty="0"/>
+          </a:p>
+        </p:txBody>
+      </p:sp>
+      <p:sp>
+        <p:nvSpPr>
+          <p:cNvPr id="6" name="Text 3"/>
+          <p:cNvSpPr txBox="1"/>
+          <p:nvPr/>
+        </p:nvSpPr>
+        <p:spPr>
+          <a:xfrm>
+            <a:off x="457200" y="3904488"/>
+            <a:ext cx="2606040" cy="685800"/>
+          </a:xfrm>
+          <a:prstGeom prst="rect">
+            <a:avLst/>
+          </a:prstGeom>
+          <a:noFill/>
+          <a:ln/>
+        </p:spPr>
+        <p:txBody>
+          <a:bodyPr wrap="square" lIns="0" tIns="0" rIns="0" bIns="0" rtlCol="0" anchor="t"/>
+          <a:lstStyle/>
+          <a:p>
+            <a:pPr indent="0" marL="0">
+              <a:buNone/>
+            </a:pPr>
+            <a:r>
+              <a:rPr lang="en-US" sz="1200" dirty="0">
+                <a:solidFill>
+                  <a:schemeClr val="tx1"/>
+                </a:solidFill>
+              </a:rPr>
+              <a:t>the trust boundary to the external LLM</a:t>
+            </a:r>
+            <a:endParaRPr lang="en-US" sz="1200" dirty="0"/>
+          </a:p>
+        </p:txBody>
       </p:sp>
       <p:sp>
         <p:nvSpPr>
@@ -3723,31 +4138,31 @@
         </p:nvSpPr>
         <p:spPr>
           <a:xfrm>
-            <a:off x="4434840" y="1143000"/>
-            <a:ext cx="457200" cy="457200"/>
-          </a:xfrm>
-          <a:prstGeom prst="rect">
-            <a:avLst/>
-          </a:prstGeom>
-          <a:noFill/>
-          <a:ln/>
-        </p:spPr>
-        <p:txBody>
-          <a:bodyPr wrap="square" lIns="0" tIns="0" rIns="0" bIns="0" rtlCol="0" anchor="ctr"/>
-          <a:lstStyle/>
-          <a:p>
-            <a:pPr algn="ctr" indent="0" marL="0">
-              <a:buNone/>
-            </a:pPr>
-            <a:r>
-              <a:rPr lang="en-US" sz="1600" b="1" dirty="0">
-                <a:solidFill>
-                  <a:srgbClr val="FFFFFF"/>
-                </a:solidFill>
-              </a:rPr>
-              <a:t>1</a:t>
-            </a:r>
-            <a:endParaRPr lang="en-US" sz="1600" dirty="0"/>
+            <a:off x="3264408" y="3611880"/>
+            <a:ext cx="2606040" cy="274320"/>
+          </a:xfrm>
+          <a:prstGeom prst="rect">
+            <a:avLst/>
+          </a:prstGeom>
+          <a:noFill/>
+          <a:ln/>
+        </p:spPr>
+        <p:txBody>
+          <a:bodyPr wrap="square" lIns="0" tIns="0" rIns="0" bIns="0" rtlCol="0" anchor="t"/>
+          <a:lstStyle/>
+          <a:p>
+            <a:pPr indent="0" marL="0">
+              <a:buNone/>
+            </a:pPr>
+            <a:r>
+              <a:rPr lang="en-US" sz="1400" b="1" dirty="0">
+                <a:solidFill>
+                  <a:schemeClr val="accent3"/>
+                </a:solidFill>
+              </a:rPr>
+              <a:t>Real values come back locally</a:t>
+            </a:r>
+            <a:endParaRPr lang="en-US" sz="1400" dirty="0"/>
           </a:p>
         </p:txBody>
       </p:sp>
@@ -3759,8 +4174,8 @@
         </p:nvSpPr>
         <p:spPr>
           <a:xfrm>
-            <a:off x="5074920" y="1124712"/>
-            <a:ext cx="3566160" cy="292608"/>
+            <a:off x="3264408" y="3904488"/>
+            <a:ext cx="2606040" cy="685800"/>
           </a:xfrm>
           <a:prstGeom prst="rect">
             <a:avLst/>
@@ -3776,14 +4191,14 @@
               <a:buNone/>
             </a:pPr>
             <a:r>
-              <a:rPr lang="en-US" sz="1500" b="1" dirty="0">
-                <a:solidFill>
-                  <a:schemeClr val="tx2"/>
-                </a:solidFill>
-              </a:rPr>
-              <a:t>Patterns + checksums</a:t>
-            </a:r>
-            <a:endParaRPr lang="en-US" sz="1500" dirty="0"/>
+              <a:rPr lang="en-US" sz="1200" dirty="0">
+                <a:solidFill>
+                  <a:schemeClr val="tx1"/>
+                </a:solidFill>
+              </a:rPr>
+              <a:t>pseudonym.py and vault.py resolve tokens inside the executor</a:t>
+            </a:r>
+            <a:endParaRPr lang="en-US" sz="1200" dirty="0"/>
           </a:p>
         </p:txBody>
       </p:sp>
@@ -3795,8 +4210,8 @@
         </p:nvSpPr>
         <p:spPr>
           <a:xfrm>
-            <a:off x="5074920" y="1435608"/>
-            <a:ext cx="3566160" cy="731520"/>
+            <a:off x="6071616" y="3611880"/>
+            <a:ext cx="2606040" cy="274320"/>
           </a:xfrm>
           <a:prstGeom prst="rect">
             <a:avLst/>
@@ -3812,280 +4227,50 @@
               <a:buNone/>
             </a:pPr>
             <a:r>
-              <a:rPr lang="en-US" sz="1300" dirty="0">
+              <a:rPr lang="en-US" sz="1400" b="1" dirty="0">
+                <a:solidFill>
+                  <a:schemeClr val="accent3"/>
+                </a:solidFill>
+              </a:rPr>
+              <a:t>Same detector everywhere</a:t>
+            </a:r>
+            <a:endParaRPr lang="en-US" sz="1400" dirty="0"/>
+          </a:p>
+        </p:txBody>
+      </p:sp>
+      <p:sp>
+        <p:nvSpPr>
+          <p:cNvPr id="10" name="Text 7"/>
+          <p:cNvSpPr txBox="1"/>
+          <p:nvPr/>
+        </p:nvSpPr>
+        <p:spPr>
+          <a:xfrm>
+            <a:off x="6071616" y="3904488"/>
+            <a:ext cx="2606040" cy="685800"/>
+          </a:xfrm>
+          <a:prstGeom prst="rect">
+            <a:avLst/>
+          </a:prstGeom>
+          <a:noFill/>
+          <a:ln/>
+        </p:spPr>
+        <p:txBody>
+          <a:bodyPr wrap="square" lIns="0" tIns="0" rIns="0" bIns="0" rtlCol="0" anchor="t"/>
+          <a:lstStyle/>
+          <a:p>
+            <a:pPr indent="0" marL="0">
+              <a:buNone/>
+            </a:pPr>
+            <a:r>
+              <a:rPr lang="en-US" sz="1200" dirty="0">
                 <a:solidFill>
                   <a:schemeClr val="tx1"/>
                 </a:solidFill>
               </a:rPr>
-              <a:t>Luhn for cards, Verhoeff for Aadhaar, IP octet rules, API key and JWT shapes, India IDs (UPI, IFSC, GSTIN, PAN)</a:t>
-            </a:r>
-            <a:endParaRPr lang="en-US" sz="1300" dirty="0"/>
-          </a:p>
-        </p:txBody>
-      </p:sp>
-      <p:sp>
-        <p:nvSpPr>
-          <p:cNvPr id="10" name="Shape 7"/>
-          <p:cNvSpPr/>
-          <p:nvPr/>
-        </p:nvSpPr>
-        <p:spPr>
-          <a:xfrm>
-            <a:off x="4434840" y="2240280"/>
-            <a:ext cx="457200" cy="457200"/>
-          </a:xfrm>
-          <a:prstGeom prst="ellipse">
-            <a:avLst/>
-          </a:prstGeom>
-          <a:solidFill>
-            <a:schemeClr val="accent1"/>
-          </a:solidFill>
-          <a:ln w="12700">
-            <a:solidFill>
-              <a:schemeClr val="accent1"/>
-            </a:solidFill>
-            <a:prstDash val="solid"/>
-          </a:ln>
-        </p:spPr>
-      </p:sp>
-      <p:sp>
-        <p:nvSpPr>
-          <p:cNvPr id="11" name="Text 8"/>
-          <p:cNvSpPr txBox="1"/>
-          <p:nvPr/>
-        </p:nvSpPr>
-        <p:spPr>
-          <a:xfrm>
-            <a:off x="4434840" y="2240280"/>
-            <a:ext cx="457200" cy="457200"/>
-          </a:xfrm>
-          <a:prstGeom prst="rect">
-            <a:avLst/>
-          </a:prstGeom>
-          <a:noFill/>
-          <a:ln/>
-        </p:spPr>
-        <p:txBody>
-          <a:bodyPr wrap="square" lIns="0" tIns="0" rIns="0" bIns="0" rtlCol="0" anchor="ctr"/>
-          <a:lstStyle/>
-          <a:p>
-            <a:pPr algn="ctr" indent="0" marL="0">
-              <a:buNone/>
-            </a:pPr>
-            <a:r>
-              <a:rPr lang="en-US" sz="1600" b="1" dirty="0">
-                <a:solidFill>
-                  <a:srgbClr val="FFFFFF"/>
-                </a:solidFill>
-              </a:rPr>
-              <a:t>2</a:t>
-            </a:r>
-            <a:endParaRPr lang="en-US" sz="1600" dirty="0"/>
-          </a:p>
-        </p:txBody>
-      </p:sp>
-      <p:sp>
-        <p:nvSpPr>
-          <p:cNvPr id="12" name="Text 9"/>
-          <p:cNvSpPr txBox="1"/>
-          <p:nvPr/>
-        </p:nvSpPr>
-        <p:spPr>
-          <a:xfrm>
-            <a:off x="5074920" y="2221992"/>
-            <a:ext cx="3566160" cy="292608"/>
-          </a:xfrm>
-          <a:prstGeom prst="rect">
-            <a:avLst/>
-          </a:prstGeom>
-          <a:noFill/>
-          <a:ln/>
-        </p:spPr>
-        <p:txBody>
-          <a:bodyPr wrap="square" lIns="0" tIns="0" rIns="0" bIns="0" rtlCol="0" anchor="t"/>
-          <a:lstStyle/>
-          <a:p>
-            <a:pPr indent="0" marL="0">
-              <a:buNone/>
-            </a:pPr>
-            <a:r>
-              <a:rPr lang="en-US" sz="1500" b="1" dirty="0">
-                <a:solidFill>
-                  <a:schemeClr val="tx2"/>
-                </a:solidFill>
-              </a:rPr>
-              <a:t>Structure</a:t>
-            </a:r>
-            <a:endParaRPr lang="en-US" sz="1500" dirty="0"/>
-          </a:p>
-        </p:txBody>
-      </p:sp>
-      <p:sp>
-        <p:nvSpPr>
-          <p:cNvPr id="13" name="Text 10"/>
-          <p:cNvSpPr txBox="1"/>
-          <p:nvPr/>
-        </p:nvSpPr>
-        <p:spPr>
-          <a:xfrm>
-            <a:off x="5074920" y="2532888"/>
-            <a:ext cx="3566160" cy="731520"/>
-          </a:xfrm>
-          <a:prstGeom prst="rect">
-            <a:avLst/>
-          </a:prstGeom>
-          <a:noFill/>
-          <a:ln/>
-        </p:spPr>
-        <p:txBody>
-          <a:bodyPr wrap="square" lIns="0" tIns="0" rIns="0" bIns="0" rtlCol="0" anchor="t"/>
-          <a:lstStyle/>
-          <a:p>
-            <a:pPr indent="0" marL="0">
-              <a:buNone/>
-            </a:pPr>
-            <a:r>
-              <a:rPr lang="en-US" sz="1300" dirty="0">
-                <a:solidFill>
-                  <a:schemeClr val="tx1"/>
-                </a:solidFill>
-              </a:rPr>
-              <a:t>type=password, autocomplete=cc-number / one-time-code, labels like OTP, CVV, PIN, token</a:t>
-            </a:r>
-            <a:endParaRPr lang="en-US" sz="1300" dirty="0"/>
-          </a:p>
-        </p:txBody>
-      </p:sp>
-      <p:sp>
-        <p:nvSpPr>
-          <p:cNvPr id="14" name="Shape 11"/>
-          <p:cNvSpPr/>
-          <p:nvPr/>
-        </p:nvSpPr>
-        <p:spPr>
-          <a:xfrm>
-            <a:off x="4434840" y="3337560"/>
-            <a:ext cx="457200" cy="457200"/>
-          </a:xfrm>
-          <a:prstGeom prst="ellipse">
-            <a:avLst/>
-          </a:prstGeom>
-          <a:solidFill>
-            <a:schemeClr val="accent1"/>
-          </a:solidFill>
-          <a:ln w="12700">
-            <a:solidFill>
-              <a:schemeClr val="accent1"/>
-            </a:solidFill>
-            <a:prstDash val="solid"/>
-          </a:ln>
-        </p:spPr>
-      </p:sp>
-      <p:sp>
-        <p:nvSpPr>
-          <p:cNvPr id="15" name="Text 12"/>
-          <p:cNvSpPr txBox="1"/>
-          <p:nvPr/>
-        </p:nvSpPr>
-        <p:spPr>
-          <a:xfrm>
-            <a:off x="4434840" y="3337560"/>
-            <a:ext cx="457200" cy="457200"/>
-          </a:xfrm>
-          <a:prstGeom prst="rect">
-            <a:avLst/>
-          </a:prstGeom>
-          <a:noFill/>
-          <a:ln/>
-        </p:spPr>
-        <p:txBody>
-          <a:bodyPr wrap="square" lIns="0" tIns="0" rIns="0" bIns="0" rtlCol="0" anchor="ctr"/>
-          <a:lstStyle/>
-          <a:p>
-            <a:pPr algn="ctr" indent="0" marL="0">
-              <a:buNone/>
-            </a:pPr>
-            <a:r>
-              <a:rPr lang="en-US" sz="1600" b="1" dirty="0">
-                <a:solidFill>
-                  <a:srgbClr val="FFFFFF"/>
-                </a:solidFill>
-              </a:rPr>
-              <a:t>3</a:t>
-            </a:r>
-            <a:endParaRPr lang="en-US" sz="1600" dirty="0"/>
-          </a:p>
-        </p:txBody>
-      </p:sp>
-      <p:sp>
-        <p:nvSpPr>
-          <p:cNvPr id="16" name="Text 13"/>
-          <p:cNvSpPr txBox="1"/>
-          <p:nvPr/>
-        </p:nvSpPr>
-        <p:spPr>
-          <a:xfrm>
-            <a:off x="5074920" y="3319272"/>
-            <a:ext cx="3566160" cy="292608"/>
-          </a:xfrm>
-          <a:prstGeom prst="rect">
-            <a:avLst/>
-          </a:prstGeom>
-          <a:noFill/>
-          <a:ln/>
-        </p:spPr>
-        <p:txBody>
-          <a:bodyPr wrap="square" lIns="0" tIns="0" rIns="0" bIns="0" rtlCol="0" anchor="t"/>
-          <a:lstStyle/>
-          <a:p>
-            <a:pPr indent="0" marL="0">
-              <a:buNone/>
-            </a:pPr>
-            <a:r>
-              <a:rPr lang="en-US" sz="1500" b="1" dirty="0">
-                <a:solidFill>
-                  <a:schemeClr val="tx2"/>
-                </a:solidFill>
-              </a:rPr>
-              <a:t>Pictures</a:t>
-            </a:r>
-            <a:endParaRPr lang="en-US" sz="1500" dirty="0"/>
-          </a:p>
-        </p:txBody>
-      </p:sp>
-      <p:sp>
-        <p:nvSpPr>
-          <p:cNvPr id="17" name="Text 14"/>
-          <p:cNvSpPr txBox="1"/>
-          <p:nvPr/>
-        </p:nvSpPr>
-        <p:spPr>
-          <a:xfrm>
-            <a:off x="5074920" y="3630168"/>
-            <a:ext cx="3566160" cy="731520"/>
-          </a:xfrm>
-          <a:prstGeom prst="rect">
-            <a:avLst/>
-          </a:prstGeom>
-          <a:noFill/>
-          <a:ln/>
-        </p:spPr>
-        <p:txBody>
-          <a:bodyPr wrap="square" lIns="0" tIns="0" rIns="0" bIns="0" rtlCol="0" anchor="t"/>
-          <a:lstStyle/>
-          <a:p>
-            <a:pPr indent="0" marL="0">
-              <a:buNone/>
-            </a:pPr>
-            <a:r>
-              <a:rPr lang="en-US" sz="1300" dirty="0">
-                <a:solidFill>
-                  <a:schemeClr val="tx1"/>
-                </a:solidFill>
-              </a:rPr>
-              <a:t>bundled face detector per image; local OCR for text in images; unanalysable images covered whole</a:t>
-            </a:r>
-            <a:endParaRPr lang="en-US" sz="1300" dirty="0"/>
+              <a:t>detect.py and its JS port stay in parity, checked by a test</a:t>
+            </a:r>
+            <a:endParaRPr lang="en-US" sz="1200" dirty="0"/>
           </a:p>
         </p:txBody>
       </p:sp>
@@ -4194,7 +4379,7 @@
                 <a:ea typeface="Cambria" pitchFamily="34" charset="-122"/>
                 <a:cs typeface="Cambria" pitchFamily="34" charset="-120"/>
               </a:rPr>
-              <a:t>Agent Shield: the agent sees placeholders</a:t>
+              <a:t>Agent Shield: protect the page, not the prompt</a:t>
             </a:r>
             <a:endParaRPr lang="en-US" sz="3000" dirty="0"/>
           </a:p>
@@ -4418,7 +4603,7 @@
                   <a:schemeClr val="tx1"/>
                 </a:solidFill>
               </a:rPr>
-              <a:t>Auto-on when navigator.webdriver is true or a debugger client is attached; “Always on” to fail closed</a:t>
+              <a:t>Finds data with patterns + checksums (Luhn, Verhoeff), field structure, and a face detector</a:t>
             </a:r>
             <a:endParaRPr lang="en-US" sz="1300" dirty="0"/>
           </a:p>
@@ -4436,7 +4621,7 @@
                   <a:schemeClr val="tx1"/>
                 </a:solidFill>
               </a:rPr>
-              <a:t>Screenshots: opaque blocks labelled by kind, kept on focus and scroll</a:t>
+              <a:t>Turns on by itself when automation or a debugger is attached</a:t>
             </a:r>
             <a:endParaRPr lang="en-US" sz="1300" dirty="0"/>
           </a:p>
@@ -4454,7 +4639,7 @@
                   <a:schemeClr val="tx1"/>
                 </a:solidFill>
               </a:rPr>
-              <a:t>DOM reads: text and input values become [REDACTED:KIND]; real values restored only for the instant of a submit</a:t>
+              <a:t>Covers screenshots and rewrites DOM text and input values to [REDACTED:KIND]</a:t>
             </a:r>
             <a:endParaRPr lang="en-US" sz="1300" dirty="0"/>
           </a:p>
@@ -4472,7 +4657,7 @@
                   <a:schemeClr val="tx1"/>
                 </a:solidFill>
               </a:rPr>
-              <a:t>No integration: works for Playwright, CDP and browser-agent extensions</a:t>
+              <a:t>Works for Playwright, CDP and agent extensions with no integration</a:t>
             </a:r>
             <a:endParaRPr lang="en-US" sz="1300" dirty="0"/>
           </a:p>
@@ -4619,118 +4804,42 @@
                 <a:ea typeface="Cambria" pitchFamily="34" charset="-122"/>
                 <a:cs typeface="Cambria" pitchFamily="34" charset="-120"/>
               </a:rPr>
-              <a:t>Unsafe outgoing payloads are stopped</a:t>
+              <a:t>We also test what an AI could guess</a:t>
             </a:r>
             <a:endParaRPr lang="en-US" sz="3000" dirty="0"/>
           </a:p>
         </p:txBody>
       </p:sp>
-      <p:sp>
-        <p:nvSpPr>
-          <p:cNvPr id="3" name="Shape 1"/>
+      <p:graphicFrame>
+        <p:nvGraphicFramePr>
+          <p:cNvPr id="3" name="Chart 0" descr=""/>
+          <p:cNvGraphicFramePr/>
+          <p:nvPr/>
+        </p:nvGraphicFramePr>
+        <p:xfrm>
+          <a:off x="365760" y="1005840"/>
+          <a:ext cx="4937760" cy="3566160"/>
+        </p:xfrm>
+        <a:graphic xmlns:a="http://schemas.openxmlformats.org/drawingml/2006/main">
+          <a:graphicData uri="http://schemas.openxmlformats.org/drawingml/2006/chart">
+            <c:chart xmlns:c="http://schemas.openxmlformats.org/drawingml/2006/chart" r:id="rId1"/>
+          </a:graphicData>
+        </a:graphic>
+      </p:graphicFrame>
+      <p:sp>
+        <p:nvSpPr>
+          <p:cNvPr id="4" name="card"/>
           <p:cNvSpPr/>
           <p:nvPr/>
         </p:nvSpPr>
         <p:spPr>
           <a:xfrm>
-            <a:off x="457200" y="1097280"/>
-            <a:ext cx="3840480" cy="3218688"/>
-          </a:xfrm>
-          <a:prstGeom prst="rect">
-            <a:avLst/>
-          </a:prstGeom>
-          <a:solidFill>
-            <a:srgbClr val="FFFFFF"/>
-          </a:solidFill>
-          <a:ln w="12700">
-            <a:solidFill>
-              <a:schemeClr val="accent6"/>
-            </a:solidFill>
-            <a:prstDash val="solid"/>
-          </a:ln>
-          <a:effectLst>
-            <a:outerShdw sx="100000" sy="100000" kx="0" ky="0" algn="bl" rotWithShape="0" blurRad="76200" dist="25400" dir="5400000">
-              <a:srgbClr val="000000">
-                <a:alpha val="15000"/>
-              </a:srgbClr>
-            </a:outerShdw>
-          </a:effectLst>
-        </p:spPr>
-      </p:sp>
-      <p:pic>
-        <p:nvPicPr>
-          <p:cNvPr id="4" name="Image 0" descr="Zen dialog stopping a chat message that contains a card, phone and email">    </p:cNvPr>
-          <p:cNvPicPr>
-            <a:picLocks noChangeAspect="1"/>
-          </p:cNvPicPr>
-          <p:nvPr/>
-        </p:nvPicPr>
-        <p:blipFill>
-          <a:blip r:embed="rId1"/>
-          <a:stretch>
-            <a:fillRect/>
-          </a:stretch>
-        </p:blipFill>
-        <p:spPr>
-          <a:xfrm>
-            <a:off x="457200" y="1097280"/>
-            <a:ext cx="3840480" cy="3218688"/>
-          </a:xfrm>
-          <a:prstGeom prst="rect">
-            <a:avLst/>
-          </a:prstGeom>
-        </p:spPr>
-      </p:pic>
-      <p:sp>
-        <p:nvSpPr>
-          <p:cNvPr id="5" name="Text 2"/>
-          <p:cNvSpPr txBox="1"/>
-          <p:nvPr/>
-        </p:nvSpPr>
-        <p:spPr>
-          <a:xfrm>
-            <a:off x="457200" y="4389120"/>
-            <a:ext cx="3840480" cy="274320"/>
-          </a:xfrm>
-          <a:prstGeom prst="rect">
-            <a:avLst/>
-          </a:prstGeom>
-          <a:noFill/>
-          <a:ln/>
-        </p:spPr>
-        <p:txBody>
-          <a:bodyPr wrap="square" lIns="0" tIns="0" rIns="0" bIns="0" rtlCol="0" anchor="t"/>
-          <a:lstStyle/>
-          <a:p>
-            <a:pPr indent="0" marL="0">
-              <a:buNone/>
-            </a:pPr>
-            <a:r>
-              <a:rPr lang="en-US" sz="1100" i="1" dirty="0">
-                <a:solidFill>
-                  <a:schemeClr val="accent5"/>
-                </a:solidFill>
-              </a:rPr>
-              <a:t>AI-chat send guard on paste and send</a:t>
-            </a:r>
-            <a:endParaRPr lang="en-US" sz="1100" dirty="0"/>
-          </a:p>
-        </p:txBody>
-      </p:sp>
-      <p:sp>
-        <p:nvSpPr>
-          <p:cNvPr id="6" name="card"/>
-          <p:cNvSpPr/>
-          <p:nvPr/>
-        </p:nvSpPr>
-        <p:spPr>
-          <a:xfrm>
-            <a:off x="4617720" y="1097280"/>
-            <a:ext cx="4069080" cy="987552"/>
+            <a:off x="5577840" y="1097280"/>
+            <a:ext cx="3108960" cy="1005840"/>
           </a:xfrm>
           <a:prstGeom prst="roundRect">
             <a:avLst>
-              <a:gd name="adj" fmla="val 7407"/>
+              <a:gd name="adj" fmla="val 7273"/>
             </a:avLst>
           </a:prstGeom>
           <a:solidFill>
@@ -4746,14 +4855,14 @@
       </p:sp>
       <p:sp>
         <p:nvSpPr>
-          <p:cNvPr id="7" name="Text 4"/>
+          <p:cNvPr id="5" name="Text 2"/>
           <p:cNvSpPr txBox="1"/>
           <p:nvPr/>
         </p:nvSpPr>
         <p:spPr>
           <a:xfrm>
-            <a:off x="4800600" y="1207008"/>
-            <a:ext cx="3749040" cy="292608"/>
+            <a:off x="5715000" y="1207008"/>
+            <a:ext cx="2834640" cy="320040"/>
           </a:xfrm>
           <a:prstGeom prst="rect">
             <a:avLst/>
@@ -4769,27 +4878,27 @@
               <a:buNone/>
             </a:pPr>
             <a:r>
-              <a:rPr lang="en-US" sz="1500" b="1" dirty="0">
+              <a:rPr lang="en-US" sz="1400" b="1" dirty="0">
                 <a:solidFill>
                   <a:schemeClr val="accent3"/>
                 </a:solidFill>
               </a:rPr>
-              <a:t>Send sanitized is the default</a:t>
-            </a:r>
-            <a:endParaRPr lang="en-US" sz="1500" dirty="0"/>
-          </a:p>
-        </p:txBody>
-      </p:sp>
-      <p:sp>
-        <p:nvSpPr>
-          <p:cNvPr id="8" name="Text 5"/>
+              <a:t>“card ending 4242”, 98XXXXX210</a:t>
+            </a:r>
+            <a:endParaRPr lang="en-US" sz="1400" dirty="0"/>
+          </a:p>
+        </p:txBody>
+      </p:sp>
+      <p:sp>
+        <p:nvSpPr>
+          <p:cNvPr id="6" name="Text 3"/>
           <p:cNvSpPr txBox="1"/>
           <p:nvPr/>
         </p:nvSpPr>
         <p:spPr>
           <a:xfrm>
-            <a:off x="4800600" y="1508760"/>
-            <a:ext cx="3749040" cy="548640"/>
+            <a:off x="5715000" y="1554480"/>
+            <a:ext cx="2834640" cy="502920"/>
           </a:xfrm>
           <a:prstGeom prst="rect">
             <a:avLst/>
@@ -4810,7 +4919,7 @@
                   <a:schemeClr val="tx1"/>
                 </a:solidFill>
               </a:rPr>
-              <a:t>ChatGPT, Claude, Gemini, Copilot, Perplexity, or any site you add</a:t>
+              <a:t>partial values removed before the AI sees them</a:t>
             </a:r>
             <a:endParaRPr lang="en-US" sz="1200" dirty="0"/>
           </a:p>
@@ -4818,18 +4927,18 @@
       </p:sp>
       <p:sp>
         <p:nvSpPr>
-          <p:cNvPr id="9" name="card"/>
+          <p:cNvPr id="7" name="card"/>
           <p:cNvSpPr/>
           <p:nvPr/>
         </p:nvSpPr>
         <p:spPr>
           <a:xfrm>
-            <a:off x="4617720" y="2212848"/>
-            <a:ext cx="4069080" cy="987552"/>
+            <a:off x="5577840" y="2240280"/>
+            <a:ext cx="3108960" cy="1005840"/>
           </a:xfrm>
           <a:prstGeom prst="roundRect">
             <a:avLst>
-              <a:gd name="adj" fmla="val 7407"/>
+              <a:gd name="adj" fmla="val 7273"/>
             </a:avLst>
           </a:prstGeom>
           <a:solidFill>
@@ -4845,14 +4954,14 @@
       </p:sp>
       <p:sp>
         <p:nvSpPr>
-          <p:cNvPr id="10" name="Text 7"/>
+          <p:cNvPr id="8" name="Text 5"/>
           <p:cNvSpPr txBox="1"/>
           <p:nvPr/>
         </p:nvSpPr>
         <p:spPr>
           <a:xfrm>
-            <a:off x="4800600" y="2322576"/>
-            <a:ext cx="3749040" cy="292608"/>
+            <a:off x="5715000" y="2350008"/>
+            <a:ext cx="2834640" cy="320040"/>
           </a:xfrm>
           <a:prstGeom prst="rect">
             <a:avLst/>
@@ -4868,27 +4977,27 @@
               <a:buNone/>
             </a:pPr>
             <a:r>
-              <a:rPr lang="en-US" sz="1500" b="1" dirty="0">
+              <a:rPr lang="en-US" sz="1400" b="1" dirty="0">
                 <a:solidFill>
                   <a:schemeClr val="accent3"/>
                 </a:solidFill>
               </a:rPr>
-              <a:t>Fails closed</a:t>
-            </a:r>
-            <a:endParaRPr lang="en-US" sz="1500" dirty="0"/>
-          </a:p>
-        </p:txBody>
-      </p:sp>
-      <p:sp>
-        <p:nvSpPr>
-          <p:cNvPr id="11" name="Text 8"/>
+              <a:t>DOB → year, PIN code → district</a:t>
+            </a:r>
+            <a:endParaRPr lang="en-US" sz="1400" dirty="0"/>
+          </a:p>
+        </p:txBody>
+      </p:sp>
+      <p:sp>
+        <p:nvSpPr>
+          <p:cNvPr id="9" name="Text 6"/>
           <p:cNvSpPr txBox="1"/>
           <p:nvPr/>
         </p:nvSpPr>
         <p:spPr>
           <a:xfrm>
-            <a:off x="4800600" y="2624328"/>
-            <a:ext cx="3749040" cy="548640"/>
+            <a:off x="5715000" y="2697480"/>
+            <a:ext cx="2834640" cy="502920"/>
           </a:xfrm>
           <a:prstGeom prst="rect">
             <a:avLst/>
@@ -4909,7 +5018,7 @@
                   <a:schemeClr val="tx1"/>
                 </a:solidFill>
               </a:rPr>
-              <a:t>if the editor refuses the replacement, the message is not sent</a:t>
+              <a:t>quasi-identifiers coarsened; every anonymity set stays ≥ 20</a:t>
             </a:r>
             <a:endParaRPr lang="en-US" sz="1200" dirty="0"/>
           </a:p>
@@ -4917,18 +5026,18 @@
       </p:sp>
       <p:sp>
         <p:nvSpPr>
-          <p:cNvPr id="12" name="card"/>
+          <p:cNvPr id="10" name="card"/>
           <p:cNvSpPr/>
           <p:nvPr/>
         </p:nvSpPr>
         <p:spPr>
           <a:xfrm>
-            <a:off x="4617720" y="3328416"/>
-            <a:ext cx="4069080" cy="987552"/>
+            <a:off x="5577840" y="3383280"/>
+            <a:ext cx="3108960" cy="1005840"/>
           </a:xfrm>
           <a:prstGeom prst="roundRect">
             <a:avLst>
-              <a:gd name="adj" fmla="val 7407"/>
+              <a:gd name="adj" fmla="val 7273"/>
             </a:avLst>
           </a:prstGeom>
           <a:solidFill>
@@ -4944,14 +5053,14 @@
       </p:sp>
       <p:sp>
         <p:nvSpPr>
-          <p:cNvPr id="13" name="Text 10"/>
+          <p:cNvPr id="11" name="Text 8"/>
           <p:cNvSpPr txBox="1"/>
           <p:nvPr/>
         </p:nvSpPr>
         <p:spPr>
           <a:xfrm>
-            <a:off x="4800600" y="3438144"/>
-            <a:ext cx="3749040" cy="292608"/>
+            <a:off x="5715000" y="3493008"/>
+            <a:ext cx="2834640" cy="320040"/>
           </a:xfrm>
           <a:prstGeom prst="rect">
             <a:avLst/>
@@ -4967,27 +5076,27 @@
               <a:buNone/>
             </a:pPr>
             <a:r>
-              <a:rPr lang="en-US" sz="1500" b="1" dirty="0">
+              <a:rPr lang="en-US" sz="1400" b="1" dirty="0">
                 <a:solidFill>
                   <a:schemeClr val="accent3"/>
                 </a:solidFill>
               </a:rPr>
-              <a:t>Egress gate for the agent</a:t>
-            </a:r>
-            <a:endParaRPr lang="en-US" sz="1500" dirty="0"/>
-          </a:p>
-        </p:txBody>
-      </p:sp>
-      <p:sp>
-        <p:nvSpPr>
-          <p:cNvPr id="14" name="Text 11"/>
+              <a:t>0 of 260</a:t>
+            </a:r>
+            <a:endParaRPr lang="en-US" sz="1400" dirty="0"/>
+          </a:p>
+        </p:txBody>
+      </p:sp>
+      <p:sp>
+        <p:nvSpPr>
+          <p:cNvPr id="12" name="Text 9"/>
           <p:cNvSpPr txBox="1"/>
           <p:nvPr/>
         </p:nvSpPr>
         <p:spPr>
           <a:xfrm>
-            <a:off x="4800600" y="3739896"/>
-            <a:ext cx="3749040" cy="548640"/>
+            <a:off x="5715000" y="3840480"/>
+            <a:ext cx="2834640" cy="502920"/>
           </a:xfrm>
           <a:prstGeom prst="rect">
             <a:avLst/>
@@ -5008,7 +5117,7 @@
                   <a:schemeClr val="tx1"/>
                 </a:solidFill>
               </a:rPr>
-              <a:t>every model payload is re-scanned; any PII, vault value or canary blocks it, and a scanner error blocks too</a:t>
+              <a:t>harmless tokens changed: utility kept</a:t>
             </a:r>
             <a:endParaRPr lang="en-US" sz="1200" dirty="0"/>
           </a:p>
@@ -5119,7 +5228,7 @@
                 <a:ea typeface="Cambria" pitchFamily="34" charset="-122"/>
                 <a:cs typeface="Cambria" pitchFamily="34" charset="-120"/>
               </a:rPr>
-              <a:t>The agent acts without ever seeing secrets</a:t>
+              <a:t>Unsafe sends and actions are stopped</a:t>
             </a:r>
             <a:endParaRPr lang="en-US" sz="3000" dirty="0"/>
           </a:p>
@@ -5127,108 +5236,14 @@
       </p:sp>
       <p:sp>
         <p:nvSpPr>
-          <p:cNvPr id="3" name="Text 1"/>
-          <p:cNvSpPr txBox="1"/>
-          <p:nvPr/>
-        </p:nvSpPr>
-        <p:spPr>
-          <a:xfrm>
-            <a:off x="457200" y="1143000"/>
-            <a:ext cx="3931920" cy="2926080"/>
-          </a:xfrm>
-          <a:prstGeom prst="rect">
-            <a:avLst/>
-          </a:prstGeom>
-          <a:noFill/>
-          <a:ln/>
-        </p:spPr>
-        <p:txBody>
-          <a:bodyPr wrap="square" lIns="0" tIns="0" rIns="0" bIns="0" rtlCol="0" anchor="t"/>
-          <a:lstStyle/>
-          <a:p>
-            <a:pPr marL="342900" indent="-342900">
-              <a:spcAft>
-                <a:spcPts val="600"/>
-              </a:spcAft>
-              <a:buSzPct val="100000"/>
-              <a:buChar char="•"/>
-            </a:pPr>
-            <a:r>
-              <a:rPr lang="en-US" sz="1400" dirty="0">
-                <a:solidFill>
-                  <a:schemeClr val="tx1"/>
-                </a:solidFill>
-              </a:rPr>
-              <a:t>Model types {{SECRET:login_password}}; the local executor fills the real value from the vault</a:t>
-            </a:r>
-            <a:endParaRPr lang="en-US" sz="1400" dirty="0"/>
-          </a:p>
-          <a:p>
-            <a:pPr marL="342900" indent="-342900">
-              <a:spcAft>
-                <a:spcPts val="600"/>
-              </a:spcAft>
-              <a:buSzPct val="100000"/>
-              <a:buChar char="•"/>
-            </a:pPr>
-            <a:r>
-              <a:rPr lang="en-US" sz="1400" dirty="0">
-                <a:solidFill>
-                  <a:schemeClr val="tx1"/>
-                </a:solidFill>
-              </a:rPr>
-              <a:t>Placeholder kind must match the field: a password cannot go into a comment box</a:t>
-            </a:r>
-            <a:endParaRPr lang="en-US" sz="1400" dirty="0"/>
-          </a:p>
-          <a:p>
-            <a:pPr marL="342900" indent="-342900">
-              <a:spcAft>
-                <a:spcPts val="600"/>
-              </a:spcAft>
-              <a:buSzPct val="100000"/>
-              <a:buChar char="•"/>
-            </a:pPr>
-            <a:r>
-              <a:rPr lang="en-US" sz="1400" dirty="0">
-                <a:solidFill>
-                  <a:schemeClr val="tx1"/>
-                </a:solidFill>
-              </a:rPr>
-              <a:t>Navigation only to allowed origins; irreversible clicks (pay, send, delete) need your approval</a:t>
-            </a:r>
-            <a:endParaRPr lang="en-US" sz="1400" dirty="0"/>
-          </a:p>
-          <a:p>
-            <a:pPr marL="342900" indent="-342900">
-              <a:spcAft>
-                <a:spcPts val="600"/>
-              </a:spcAft>
-              <a:buSzPct val="100000"/>
-              <a:buChar char="•"/>
-            </a:pPr>
-            <a:r>
-              <a:rPr lang="en-US" sz="1400" dirty="0">
-                <a:solidFill>
-                  <a:schemeClr val="tx1"/>
-                </a:solidFill>
-              </a:rPr>
-              <a:t>Page text is untrusted: on the injection page all 5 hijack attempts are rejected</a:t>
-            </a:r>
-            <a:endParaRPr lang="en-US" sz="1400" dirty="0"/>
-          </a:p>
-        </p:txBody>
-      </p:sp>
-      <p:sp>
-        <p:nvSpPr>
-          <p:cNvPr id="4" name="Shape 2"/>
+          <p:cNvPr id="3" name="Shape 1"/>
           <p:cNvSpPr/>
           <p:nvPr/>
         </p:nvSpPr>
         <p:spPr>
           <a:xfrm>
-            <a:off x="4663440" y="1097280"/>
-            <a:ext cx="4023360" cy="2267712"/>
+            <a:off x="457200" y="1097280"/>
+            <a:ext cx="3840480" cy="3218688"/>
           </a:xfrm>
           <a:prstGeom prst="rect">
             <a:avLst/>
@@ -5253,7 +5268,7 @@
       </p:sp>
       <p:pic>
         <p:nvPicPr>
-          <p:cNvPr id="5" name="Image 0" descr="Agent run: steps rejected, and the exact data that would leave the device">    </p:cNvPr>
+          <p:cNvPr id="4" name="Image 0" descr="Zen dialog stopping a chat message that contains a card, phone and email">    </p:cNvPr>
           <p:cNvPicPr>
             <a:picLocks noChangeAspect="1"/>
           </p:cNvPicPr>
@@ -5267,8 +5282,8 @@
         </p:blipFill>
         <p:spPr>
           <a:xfrm>
-            <a:off x="4663440" y="1097280"/>
-            <a:ext cx="4023360" cy="2267712"/>
+            <a:off x="457200" y="1097280"/>
+            <a:ext cx="3840480" cy="3218688"/>
           </a:xfrm>
           <a:prstGeom prst="rect">
             <a:avLst/>
@@ -5277,14 +5292,14 @@
       </p:pic>
       <p:sp>
         <p:nvSpPr>
-          <p:cNvPr id="6" name="Text 3"/>
+          <p:cNvPr id="5" name="Text 2"/>
           <p:cNvSpPr txBox="1"/>
           <p:nvPr/>
         </p:nvSpPr>
         <p:spPr>
           <a:xfrm>
-            <a:off x="4663440" y="3429000"/>
-            <a:ext cx="4023360" cy="274320"/>
+            <a:off x="457200" y="4389120"/>
+            <a:ext cx="3840480" cy="274320"/>
           </a:xfrm>
           <a:prstGeom prst="rect">
             <a:avLst/>
@@ -5305,7 +5320,7 @@
                   <a:schemeClr val="accent5"/>
                 </a:solidFill>
               </a:rPr>
-              <a:t>Each step’s verdict, and the exact sanitized payload</a:t>
+              <a:t>AI-chat send guard: “Send sanitized” is the default</a:t>
             </a:r>
             <a:endParaRPr lang="en-US" sz="1100" dirty="0"/>
           </a:p>
@@ -5313,18 +5328,18 @@
       </p:sp>
       <p:sp>
         <p:nvSpPr>
-          <p:cNvPr id="7" name="card"/>
+          <p:cNvPr id="6" name="card"/>
           <p:cNvSpPr/>
           <p:nvPr/>
         </p:nvSpPr>
         <p:spPr>
           <a:xfrm>
-            <a:off x="4663440" y="3794760"/>
-            <a:ext cx="4023360" cy="731520"/>
+            <a:off x="4617720" y="1097280"/>
+            <a:ext cx="4069080" cy="758952"/>
           </a:xfrm>
           <a:prstGeom prst="roundRect">
             <a:avLst>
-              <a:gd name="adj" fmla="val 10000"/>
+              <a:gd name="adj" fmla="val 9639"/>
             </a:avLst>
           </a:prstGeom>
           <a:solidFill>
@@ -5340,14 +5355,50 @@
       </p:sp>
       <p:sp>
         <p:nvSpPr>
+          <p:cNvPr id="7" name="Text 4"/>
+          <p:cNvSpPr txBox="1"/>
+          <p:nvPr/>
+        </p:nvSpPr>
+        <p:spPr>
+          <a:xfrm>
+            <a:off x="4754880" y="1170432"/>
+            <a:ext cx="3794760" cy="274320"/>
+          </a:xfrm>
+          <a:prstGeom prst="rect">
+            <a:avLst/>
+          </a:prstGeom>
+          <a:noFill/>
+          <a:ln/>
+        </p:spPr>
+        <p:txBody>
+          <a:bodyPr wrap="square" lIns="0" tIns="0" rIns="0" bIns="0" rtlCol="0" anchor="t"/>
+          <a:lstStyle/>
+          <a:p>
+            <a:pPr indent="0" marL="0">
+              <a:buNone/>
+            </a:pPr>
+            <a:r>
+              <a:rPr lang="en-US" sz="1400" b="1" dirty="0">
+                <a:solidFill>
+                  <a:schemeClr val="accent3"/>
+                </a:solidFill>
+              </a:rPr>
+              <a:t>Send guard fails closed</a:t>
+            </a:r>
+            <a:endParaRPr lang="en-US" sz="1400" dirty="0"/>
+          </a:p>
+        </p:txBody>
+      </p:sp>
+      <p:sp>
+        <p:nvSpPr>
           <p:cNvPr id="8" name="Text 5"/>
           <p:cNvSpPr txBox="1"/>
           <p:nvPr/>
         </p:nvSpPr>
         <p:spPr>
           <a:xfrm>
-            <a:off x="4800600" y="3886200"/>
-            <a:ext cx="3749040" cy="566928"/>
+            <a:off x="4754880" y="1444752"/>
+            <a:ext cx="3794760" cy="384048"/>
           </a:xfrm>
           <a:prstGeom prst="rect">
             <a:avLst/>
@@ -5363,14 +5414,311 @@
               <a:buNone/>
             </a:pPr>
             <a:r>
-              <a:rPr lang="en-US" sz="1200" dirty="0">
-                <a:solidFill>
-                  <a:schemeClr val="tx2"/>
-                </a:solidFill>
-              </a:rPr>
-              <a:t>End-to-end tests: vault values reach the page, but never model payloads, logs or reports</a:t>
-            </a:r>
-            <a:endParaRPr lang="en-US" sz="1200" dirty="0"/>
+              <a:rPr lang="en-US" sz="1100" dirty="0">
+                <a:solidFill>
+                  <a:schemeClr val="tx1"/>
+                </a:solidFill>
+              </a:rPr>
+              <a:t>if the editor refuses the sanitized text, nothing is sent</a:t>
+            </a:r>
+            <a:endParaRPr lang="en-US" sz="1100" dirty="0"/>
+          </a:p>
+        </p:txBody>
+      </p:sp>
+      <p:sp>
+        <p:nvSpPr>
+          <p:cNvPr id="9" name="card"/>
+          <p:cNvSpPr/>
+          <p:nvPr/>
+        </p:nvSpPr>
+        <p:spPr>
+          <a:xfrm>
+            <a:off x="4617720" y="1965960"/>
+            <a:ext cx="4069080" cy="758952"/>
+          </a:xfrm>
+          <a:prstGeom prst="roundRect">
+            <a:avLst>
+              <a:gd name="adj" fmla="val 9639"/>
+            </a:avLst>
+          </a:prstGeom>
+          <a:solidFill>
+            <a:schemeClr val="bg2"/>
+          </a:solidFill>
+          <a:ln w="12700">
+            <a:solidFill>
+              <a:schemeClr val="bg2"/>
+            </a:solidFill>
+            <a:prstDash val="solid"/>
+          </a:ln>
+        </p:spPr>
+      </p:sp>
+      <p:sp>
+        <p:nvSpPr>
+          <p:cNvPr id="10" name="Text 7"/>
+          <p:cNvSpPr txBox="1"/>
+          <p:nvPr/>
+        </p:nvSpPr>
+        <p:spPr>
+          <a:xfrm>
+            <a:off x="4754880" y="2039112"/>
+            <a:ext cx="3794760" cy="274320"/>
+          </a:xfrm>
+          <a:prstGeom prst="rect">
+            <a:avLst/>
+          </a:prstGeom>
+          <a:noFill/>
+          <a:ln/>
+        </p:spPr>
+        <p:txBody>
+          <a:bodyPr wrap="square" lIns="0" tIns="0" rIns="0" bIns="0" rtlCol="0" anchor="t"/>
+          <a:lstStyle/>
+          <a:p>
+            <a:pPr indent="0" marL="0">
+              <a:buNone/>
+            </a:pPr>
+            <a:r>
+              <a:rPr lang="en-US" sz="1400" b="1" dirty="0">
+                <a:solidFill>
+                  <a:schemeClr val="accent3"/>
+                </a:solidFill>
+              </a:rPr>
+              <a:t>Secrets the AI never sees</a:t>
+            </a:r>
+            <a:endParaRPr lang="en-US" sz="1400" dirty="0"/>
+          </a:p>
+        </p:txBody>
+      </p:sp>
+      <p:sp>
+        <p:nvSpPr>
+          <p:cNvPr id="11" name="Text 8"/>
+          <p:cNvSpPr txBox="1"/>
+          <p:nvPr/>
+        </p:nvSpPr>
+        <p:spPr>
+          <a:xfrm>
+            <a:off x="4754880" y="2313432"/>
+            <a:ext cx="3794760" cy="384048"/>
+          </a:xfrm>
+          <a:prstGeom prst="rect">
+            <a:avLst/>
+          </a:prstGeom>
+          <a:noFill/>
+          <a:ln/>
+        </p:spPr>
+        <p:txBody>
+          <a:bodyPr wrap="square" lIns="0" tIns="0" rIns="0" bIns="0" rtlCol="0" anchor="t"/>
+          <a:lstStyle/>
+          <a:p>
+            <a:pPr indent="0" marL="0">
+              <a:buNone/>
+            </a:pPr>
+            <a:r>
+              <a:rPr lang="en-US" sz="1100" dirty="0">
+                <a:solidFill>
+                  <a:schemeClr val="tx1"/>
+                </a:solidFill>
+              </a:rPr>
+              <a:t>it types {{SECRET:login_password}}; the executor fills the real value after approval</a:t>
+            </a:r>
+            <a:endParaRPr lang="en-US" sz="1100" dirty="0"/>
+          </a:p>
+        </p:txBody>
+      </p:sp>
+      <p:sp>
+        <p:nvSpPr>
+          <p:cNvPr id="12" name="card"/>
+          <p:cNvSpPr/>
+          <p:nvPr/>
+        </p:nvSpPr>
+        <p:spPr>
+          <a:xfrm>
+            <a:off x="4617720" y="2834640"/>
+            <a:ext cx="4069080" cy="758952"/>
+          </a:xfrm>
+          <a:prstGeom prst="roundRect">
+            <a:avLst>
+              <a:gd name="adj" fmla="val 9639"/>
+            </a:avLst>
+          </a:prstGeom>
+          <a:solidFill>
+            <a:schemeClr val="bg2"/>
+          </a:solidFill>
+          <a:ln w="12700">
+            <a:solidFill>
+              <a:schemeClr val="bg2"/>
+            </a:solidFill>
+            <a:prstDash val="solid"/>
+          </a:ln>
+        </p:spPr>
+      </p:sp>
+      <p:sp>
+        <p:nvSpPr>
+          <p:cNvPr id="13" name="Text 10"/>
+          <p:cNvSpPr txBox="1"/>
+          <p:nvPr/>
+        </p:nvSpPr>
+        <p:spPr>
+          <a:xfrm>
+            <a:off x="4754880" y="2907792"/>
+            <a:ext cx="3794760" cy="274320"/>
+          </a:xfrm>
+          <a:prstGeom prst="rect">
+            <a:avLst/>
+          </a:prstGeom>
+          <a:noFill/>
+          <a:ln/>
+        </p:spPr>
+        <p:txBody>
+          <a:bodyPr wrap="square" lIns="0" tIns="0" rIns="0" bIns="0" rtlCol="0" anchor="t"/>
+          <a:lstStyle/>
+          <a:p>
+            <a:pPr indent="0" marL="0">
+              <a:buNone/>
+            </a:pPr>
+            <a:r>
+              <a:rPr lang="en-US" sz="1400" b="1" dirty="0">
+                <a:solidFill>
+                  <a:schemeClr val="accent3"/>
+                </a:solidFill>
+              </a:rPr>
+              <a:t>Prompt injection rejected</a:t>
+            </a:r>
+            <a:endParaRPr lang="en-US" sz="1400" dirty="0"/>
+          </a:p>
+        </p:txBody>
+      </p:sp>
+      <p:sp>
+        <p:nvSpPr>
+          <p:cNvPr id="14" name="Text 11"/>
+          <p:cNvSpPr txBox="1"/>
+          <p:nvPr/>
+        </p:nvSpPr>
+        <p:spPr>
+          <a:xfrm>
+            <a:off x="4754880" y="3182112"/>
+            <a:ext cx="3794760" cy="384048"/>
+          </a:xfrm>
+          <a:prstGeom prst="rect">
+            <a:avLst/>
+          </a:prstGeom>
+          <a:noFill/>
+          <a:ln/>
+        </p:spPr>
+        <p:txBody>
+          <a:bodyPr wrap="square" lIns="0" tIns="0" rIns="0" bIns="0" rtlCol="0" anchor="t"/>
+          <a:lstStyle/>
+          <a:p>
+            <a:pPr indent="0" marL="0">
+              <a:buNone/>
+            </a:pPr>
+            <a:r>
+              <a:rPr lang="en-US" sz="1100" dirty="0">
+                <a:solidFill>
+                  <a:schemeClr val="tx1"/>
+                </a:solidFill>
+              </a:rPr>
+              <a:t>5 of 5 hijack attempts on the test page blocked; navigation only to allowed sites</a:t>
+            </a:r>
+            <a:endParaRPr lang="en-US" sz="1100" dirty="0"/>
+          </a:p>
+        </p:txBody>
+      </p:sp>
+      <p:sp>
+        <p:nvSpPr>
+          <p:cNvPr id="15" name="card"/>
+          <p:cNvSpPr/>
+          <p:nvPr/>
+        </p:nvSpPr>
+        <p:spPr>
+          <a:xfrm>
+            <a:off x="4617720" y="3703320"/>
+            <a:ext cx="4069080" cy="758952"/>
+          </a:xfrm>
+          <a:prstGeom prst="roundRect">
+            <a:avLst>
+              <a:gd name="adj" fmla="val 9639"/>
+            </a:avLst>
+          </a:prstGeom>
+          <a:solidFill>
+            <a:schemeClr val="bg2"/>
+          </a:solidFill>
+          <a:ln w="12700">
+            <a:solidFill>
+              <a:schemeClr val="bg2"/>
+            </a:solidFill>
+            <a:prstDash val="solid"/>
+          </a:ln>
+        </p:spPr>
+      </p:sp>
+      <p:sp>
+        <p:nvSpPr>
+          <p:cNvPr id="16" name="Text 13"/>
+          <p:cNvSpPr txBox="1"/>
+          <p:nvPr/>
+        </p:nvSpPr>
+        <p:spPr>
+          <a:xfrm>
+            <a:off x="4754880" y="3776472"/>
+            <a:ext cx="3794760" cy="274320"/>
+          </a:xfrm>
+          <a:prstGeom prst="rect">
+            <a:avLst/>
+          </a:prstGeom>
+          <a:noFill/>
+          <a:ln/>
+        </p:spPr>
+        <p:txBody>
+          <a:bodyPr wrap="square" lIns="0" tIns="0" rIns="0" bIns="0" rtlCol="0" anchor="t"/>
+          <a:lstStyle/>
+          <a:p>
+            <a:pPr indent="0" marL="0">
+              <a:buNone/>
+            </a:pPr>
+            <a:r>
+              <a:rPr lang="en-US" sz="1400" b="1" dirty="0">
+                <a:solidFill>
+                  <a:schemeClr val="accent3"/>
+                </a:solidFill>
+              </a:rPr>
+              <a:t>Fail-closed egress gate</a:t>
+            </a:r>
+            <a:endParaRPr lang="en-US" sz="1400" dirty="0"/>
+          </a:p>
+        </p:txBody>
+      </p:sp>
+      <p:sp>
+        <p:nvSpPr>
+          <p:cNvPr id="17" name="Text 14"/>
+          <p:cNvSpPr txBox="1"/>
+          <p:nvPr/>
+        </p:nvSpPr>
+        <p:spPr>
+          <a:xfrm>
+            <a:off x="4754880" y="4050792"/>
+            <a:ext cx="3794760" cy="384048"/>
+          </a:xfrm>
+          <a:prstGeom prst="rect">
+            <a:avLst/>
+          </a:prstGeom>
+          <a:noFill/>
+          <a:ln/>
+        </p:spPr>
+        <p:txBody>
+          <a:bodyPr wrap="square" lIns="0" tIns="0" rIns="0" bIns="0" rtlCol="0" anchor="t"/>
+          <a:lstStyle/>
+          <a:p>
+            <a:pPr indent="0" marL="0">
+              <a:buNone/>
+            </a:pPr>
+            <a:r>
+              <a:rPr lang="en-US" sz="1100" dirty="0">
+                <a:solidFill>
+                  <a:schemeClr val="tx1"/>
+                </a:solidFill>
+              </a:rPr>
+              <a:t>every payload re-scanned; 5 of 5 canaries blocked</a:t>
+            </a:r>
+            <a:endParaRPr lang="en-US" sz="1100" dirty="0"/>
           </a:p>
         </p:txBody>
       </p:sp>

</xml_diff>

<commit_message>
Deck: show detected kinds, highlighting India-specific IDs (UPI, bank account, IFSC, GSTIN, Aadhaar, PAN, voter ID, passport, vehicle)
</commit_message>
<xml_diff>
--- a/submission/Zen_PECathon.pptx
+++ b/submission/Zen_PECathon.pptx
@@ -114,26 +114,26 @@
   <p:extLst>
     <p:ext uri="{521415D9-36F7-43E2-AB2F-B90AF26B5E84}">
       <p14:sectionLst xmlns:p14="http://schemas.microsoft.com/office/powerpoint/2010/main">
-        <p14:section name="Intro" id="{88ed5224-2e7f-81fc-e74f-04f800bcb694}">
+        <p14:section name="Intro" id="{f36eceac-d222-f71e-e3fe-fe1606edec24}">
           <p14:sldIdLst>
             <p14:sldId id="256"/>
           </p14:sldIdLst>
         </p14:section>
-        <p14:section name="Problem and design" id="{23b27dbd-dba0-6536-0659-4803ba7d2b49}">
+        <p14:section name="Problem and design" id="{827b9d52-91d6-2960-6647-cdac92835f4a}">
           <p14:sldIdLst>
             <p14:sldId id="257"/>
             <p14:sldId id="258"/>
             <p14:sldId id="259"/>
           </p14:sldIdLst>
         </p14:section>
-        <p14:section name="How it works" id="{d6b1e2cb-2673-2638-0f5d-690a856d8652}">
+        <p14:section name="How it works" id="{a15c5b7c-ace4-b4dd-e4bf-71f4b8098a67}">
           <p14:sldIdLst>
             <p14:sldId id="260"/>
             <p14:sldId id="261"/>
             <p14:sldId id="262"/>
           </p14:sldIdLst>
         </p14:section>
-        <p14:section name="Results" id="{86bf25e1-159c-3f30-b2a7-290251b14709}">
+        <p14:section name="Results" id="{eef47ce5-76ee-2c51-910a-5ef54d039e92}">
           <p14:sldIdLst>
             <p14:sldId id="263"/>
           </p14:sldIdLst>
@@ -4577,8 +4577,8 @@
         </p:nvSpPr>
         <p:spPr>
           <a:xfrm>
-            <a:off x="6263640" y="1097280"/>
-            <a:ext cx="2468880" cy="3383280"/>
+            <a:off x="6217920" y="1051560"/>
+            <a:ext cx="2468880" cy="274320"/>
           </a:xfrm>
           <a:prstGeom prst="rect">
             <a:avLst/>
@@ -4590,89 +4590,1039 @@
           <a:bodyPr wrap="square" lIns="0" tIns="0" rIns="0" bIns="0" rtlCol="0" anchor="t"/>
           <a:lstStyle/>
           <a:p>
-            <a:pPr marL="342900" indent="-342900">
-              <a:spcAft>
-                <a:spcPts val="600"/>
-              </a:spcAft>
-              <a:buSzPct val="100000"/>
-              <a:buChar char="•"/>
-            </a:pPr>
-            <a:r>
-              <a:rPr lang="en-US" sz="1300" dirty="0">
+            <a:pPr indent="0" marL="0">
+              <a:buNone/>
+            </a:pPr>
+            <a:r>
+              <a:rPr lang="en-US" sz="1300" b="1" dirty="0">
+                <a:solidFill>
+                  <a:schemeClr val="tx2"/>
+                </a:solidFill>
+              </a:rPr>
+              <a:t>What it detects</a:t>
+            </a:r>
+            <a:endParaRPr lang="en-US" sz="1300" dirty="0"/>
+          </a:p>
+        </p:txBody>
+      </p:sp>
+      <p:sp>
+        <p:nvSpPr>
+          <p:cNvPr id="10" name="Shape 6"/>
+          <p:cNvSpPr/>
+          <p:nvPr/>
+        </p:nvSpPr>
+        <p:spPr>
+          <a:xfrm>
+            <a:off x="6217920" y="1371600"/>
+            <a:ext cx="1188720" cy="292608"/>
+          </a:xfrm>
+          <a:prstGeom prst="roundRect">
+            <a:avLst>
+              <a:gd name="adj" fmla="val 15625"/>
+            </a:avLst>
+          </a:prstGeom>
+          <a:solidFill>
+            <a:srgbClr val="FBE3DA"/>
+          </a:solidFill>
+          <a:ln w="12700">
+            <a:solidFill>
+              <a:srgbClr val="FBE3DA"/>
+            </a:solidFill>
+            <a:prstDash val="solid"/>
+          </a:ln>
+        </p:spPr>
+      </p:sp>
+      <p:sp>
+        <p:nvSpPr>
+          <p:cNvPr id="11" name="Text 7"/>
+          <p:cNvSpPr txBox="1"/>
+          <p:nvPr/>
+        </p:nvSpPr>
+        <p:spPr>
+          <a:xfrm>
+            <a:off x="6217920" y="1371600"/>
+            <a:ext cx="1188720" cy="292608"/>
+          </a:xfrm>
+          <a:prstGeom prst="rect">
+            <a:avLst/>
+          </a:prstGeom>
+          <a:noFill/>
+          <a:ln/>
+        </p:spPr>
+        <p:txBody>
+          <a:bodyPr wrap="square" lIns="0" tIns="0" rIns="0" bIns="0" rtlCol="0" anchor="ctr"/>
+          <a:lstStyle/>
+          <a:p>
+            <a:pPr algn="ctr" indent="0" marL="0">
+              <a:buNone/>
+            </a:pPr>
+            <a:r>
+              <a:rPr lang="en-US" sz="1000" b="1" dirty="0">
+                <a:solidFill>
+                  <a:schemeClr val="accent3"/>
+                </a:solidFill>
+              </a:rPr>
+              <a:t>UPI ID</a:t>
+            </a:r>
+            <a:endParaRPr lang="en-US" sz="1000" dirty="0"/>
+          </a:p>
+        </p:txBody>
+      </p:sp>
+      <p:sp>
+        <p:nvSpPr>
+          <p:cNvPr id="12" name="Shape 8"/>
+          <p:cNvSpPr/>
+          <p:nvPr/>
+        </p:nvSpPr>
+        <p:spPr>
+          <a:xfrm>
+            <a:off x="7470648" y="1371600"/>
+            <a:ext cx="1188720" cy="292608"/>
+          </a:xfrm>
+          <a:prstGeom prst="roundRect">
+            <a:avLst>
+              <a:gd name="adj" fmla="val 15625"/>
+            </a:avLst>
+          </a:prstGeom>
+          <a:solidFill>
+            <a:srgbClr val="FBE3DA"/>
+          </a:solidFill>
+          <a:ln w="12700">
+            <a:solidFill>
+              <a:srgbClr val="FBE3DA"/>
+            </a:solidFill>
+            <a:prstDash val="solid"/>
+          </a:ln>
+        </p:spPr>
+      </p:sp>
+      <p:sp>
+        <p:nvSpPr>
+          <p:cNvPr id="13" name="Text 9"/>
+          <p:cNvSpPr txBox="1"/>
+          <p:nvPr/>
+        </p:nvSpPr>
+        <p:spPr>
+          <a:xfrm>
+            <a:off x="7470648" y="1371600"/>
+            <a:ext cx="1188720" cy="292608"/>
+          </a:xfrm>
+          <a:prstGeom prst="rect">
+            <a:avLst/>
+          </a:prstGeom>
+          <a:noFill/>
+          <a:ln/>
+        </p:spPr>
+        <p:txBody>
+          <a:bodyPr wrap="square" lIns="0" tIns="0" rIns="0" bIns="0" rtlCol="0" anchor="ctr"/>
+          <a:lstStyle/>
+          <a:p>
+            <a:pPr algn="ctr" indent="0" marL="0">
+              <a:buNone/>
+            </a:pPr>
+            <a:r>
+              <a:rPr lang="en-US" sz="1000" b="1" dirty="0">
+                <a:solidFill>
+                  <a:schemeClr val="accent3"/>
+                </a:solidFill>
+              </a:rPr>
+              <a:t>Bank account</a:t>
+            </a:r>
+            <a:endParaRPr lang="en-US" sz="1000" dirty="0"/>
+          </a:p>
+        </p:txBody>
+      </p:sp>
+      <p:sp>
+        <p:nvSpPr>
+          <p:cNvPr id="14" name="Shape 10"/>
+          <p:cNvSpPr/>
+          <p:nvPr/>
+        </p:nvSpPr>
+        <p:spPr>
+          <a:xfrm>
+            <a:off x="6217920" y="1737360"/>
+            <a:ext cx="1188720" cy="292608"/>
+          </a:xfrm>
+          <a:prstGeom prst="roundRect">
+            <a:avLst>
+              <a:gd name="adj" fmla="val 15625"/>
+            </a:avLst>
+          </a:prstGeom>
+          <a:solidFill>
+            <a:srgbClr val="FBE3DA"/>
+          </a:solidFill>
+          <a:ln w="12700">
+            <a:solidFill>
+              <a:srgbClr val="FBE3DA"/>
+            </a:solidFill>
+            <a:prstDash val="solid"/>
+          </a:ln>
+        </p:spPr>
+      </p:sp>
+      <p:sp>
+        <p:nvSpPr>
+          <p:cNvPr id="15" name="Text 11"/>
+          <p:cNvSpPr txBox="1"/>
+          <p:nvPr/>
+        </p:nvSpPr>
+        <p:spPr>
+          <a:xfrm>
+            <a:off x="6217920" y="1737360"/>
+            <a:ext cx="1188720" cy="292608"/>
+          </a:xfrm>
+          <a:prstGeom prst="rect">
+            <a:avLst/>
+          </a:prstGeom>
+          <a:noFill/>
+          <a:ln/>
+        </p:spPr>
+        <p:txBody>
+          <a:bodyPr wrap="square" lIns="0" tIns="0" rIns="0" bIns="0" rtlCol="0" anchor="ctr"/>
+          <a:lstStyle/>
+          <a:p>
+            <a:pPr algn="ctr" indent="0" marL="0">
+              <a:buNone/>
+            </a:pPr>
+            <a:r>
+              <a:rPr lang="en-US" sz="1000" b="1" dirty="0">
+                <a:solidFill>
+                  <a:schemeClr val="accent3"/>
+                </a:solidFill>
+              </a:rPr>
+              <a:t>IFSC</a:t>
+            </a:r>
+            <a:endParaRPr lang="en-US" sz="1000" dirty="0"/>
+          </a:p>
+        </p:txBody>
+      </p:sp>
+      <p:sp>
+        <p:nvSpPr>
+          <p:cNvPr id="16" name="Shape 12"/>
+          <p:cNvSpPr/>
+          <p:nvPr/>
+        </p:nvSpPr>
+        <p:spPr>
+          <a:xfrm>
+            <a:off x="7470648" y="1737360"/>
+            <a:ext cx="1188720" cy="292608"/>
+          </a:xfrm>
+          <a:prstGeom prst="roundRect">
+            <a:avLst>
+              <a:gd name="adj" fmla="val 15625"/>
+            </a:avLst>
+          </a:prstGeom>
+          <a:solidFill>
+            <a:srgbClr val="FBE3DA"/>
+          </a:solidFill>
+          <a:ln w="12700">
+            <a:solidFill>
+              <a:srgbClr val="FBE3DA"/>
+            </a:solidFill>
+            <a:prstDash val="solid"/>
+          </a:ln>
+        </p:spPr>
+      </p:sp>
+      <p:sp>
+        <p:nvSpPr>
+          <p:cNvPr id="17" name="Text 13"/>
+          <p:cNvSpPr txBox="1"/>
+          <p:nvPr/>
+        </p:nvSpPr>
+        <p:spPr>
+          <a:xfrm>
+            <a:off x="7470648" y="1737360"/>
+            <a:ext cx="1188720" cy="292608"/>
+          </a:xfrm>
+          <a:prstGeom prst="rect">
+            <a:avLst/>
+          </a:prstGeom>
+          <a:noFill/>
+          <a:ln/>
+        </p:spPr>
+        <p:txBody>
+          <a:bodyPr wrap="square" lIns="0" tIns="0" rIns="0" bIns="0" rtlCol="0" anchor="ctr"/>
+          <a:lstStyle/>
+          <a:p>
+            <a:pPr algn="ctr" indent="0" marL="0">
+              <a:buNone/>
+            </a:pPr>
+            <a:r>
+              <a:rPr lang="en-US" sz="1000" b="1" dirty="0">
+                <a:solidFill>
+                  <a:schemeClr val="accent3"/>
+                </a:solidFill>
+              </a:rPr>
+              <a:t>GSTIN · mod-36</a:t>
+            </a:r>
+            <a:endParaRPr lang="en-US" sz="1000" dirty="0"/>
+          </a:p>
+        </p:txBody>
+      </p:sp>
+      <p:sp>
+        <p:nvSpPr>
+          <p:cNvPr id="18" name="Shape 14"/>
+          <p:cNvSpPr/>
+          <p:nvPr/>
+        </p:nvSpPr>
+        <p:spPr>
+          <a:xfrm>
+            <a:off x="6217920" y="2103120"/>
+            <a:ext cx="1188720" cy="292608"/>
+          </a:xfrm>
+          <a:prstGeom prst="roundRect">
+            <a:avLst>
+              <a:gd name="adj" fmla="val 15625"/>
+            </a:avLst>
+          </a:prstGeom>
+          <a:solidFill>
+            <a:srgbClr val="FBE3DA"/>
+          </a:solidFill>
+          <a:ln w="12700">
+            <a:solidFill>
+              <a:srgbClr val="FBE3DA"/>
+            </a:solidFill>
+            <a:prstDash val="solid"/>
+          </a:ln>
+        </p:spPr>
+      </p:sp>
+      <p:sp>
+        <p:nvSpPr>
+          <p:cNvPr id="19" name="Text 15"/>
+          <p:cNvSpPr txBox="1"/>
+          <p:nvPr/>
+        </p:nvSpPr>
+        <p:spPr>
+          <a:xfrm>
+            <a:off x="6217920" y="2103120"/>
+            <a:ext cx="1188720" cy="292608"/>
+          </a:xfrm>
+          <a:prstGeom prst="rect">
+            <a:avLst/>
+          </a:prstGeom>
+          <a:noFill/>
+          <a:ln/>
+        </p:spPr>
+        <p:txBody>
+          <a:bodyPr wrap="square" lIns="0" tIns="0" rIns="0" bIns="0" rtlCol="0" anchor="ctr"/>
+          <a:lstStyle/>
+          <a:p>
+            <a:pPr algn="ctr" indent="0" marL="0">
+              <a:buNone/>
+            </a:pPr>
+            <a:r>
+              <a:rPr lang="en-US" sz="1000" b="1" dirty="0">
+                <a:solidFill>
+                  <a:schemeClr val="accent3"/>
+                </a:solidFill>
+              </a:rPr>
+              <a:t>Aadhaar · Verhoeff</a:t>
+            </a:r>
+            <a:endParaRPr lang="en-US" sz="1000" dirty="0"/>
+          </a:p>
+        </p:txBody>
+      </p:sp>
+      <p:sp>
+        <p:nvSpPr>
+          <p:cNvPr id="20" name="Shape 16"/>
+          <p:cNvSpPr/>
+          <p:nvPr/>
+        </p:nvSpPr>
+        <p:spPr>
+          <a:xfrm>
+            <a:off x="7470648" y="2103120"/>
+            <a:ext cx="1188720" cy="292608"/>
+          </a:xfrm>
+          <a:prstGeom prst="roundRect">
+            <a:avLst>
+              <a:gd name="adj" fmla="val 15625"/>
+            </a:avLst>
+          </a:prstGeom>
+          <a:solidFill>
+            <a:srgbClr val="FBE3DA"/>
+          </a:solidFill>
+          <a:ln w="12700">
+            <a:solidFill>
+              <a:srgbClr val="FBE3DA"/>
+            </a:solidFill>
+            <a:prstDash val="solid"/>
+          </a:ln>
+        </p:spPr>
+      </p:sp>
+      <p:sp>
+        <p:nvSpPr>
+          <p:cNvPr id="21" name="Text 17"/>
+          <p:cNvSpPr txBox="1"/>
+          <p:nvPr/>
+        </p:nvSpPr>
+        <p:spPr>
+          <a:xfrm>
+            <a:off x="7470648" y="2103120"/>
+            <a:ext cx="1188720" cy="292608"/>
+          </a:xfrm>
+          <a:prstGeom prst="rect">
+            <a:avLst/>
+          </a:prstGeom>
+          <a:noFill/>
+          <a:ln/>
+        </p:spPr>
+        <p:txBody>
+          <a:bodyPr wrap="square" lIns="0" tIns="0" rIns="0" bIns="0" rtlCol="0" anchor="ctr"/>
+          <a:lstStyle/>
+          <a:p>
+            <a:pPr algn="ctr" indent="0" marL="0">
+              <a:buNone/>
+            </a:pPr>
+            <a:r>
+              <a:rPr lang="en-US" sz="1000" b="1" dirty="0">
+                <a:solidFill>
+                  <a:schemeClr val="accent3"/>
+                </a:solidFill>
+              </a:rPr>
+              <a:t>PAN</a:t>
+            </a:r>
+            <a:endParaRPr lang="en-US" sz="1000" dirty="0"/>
+          </a:p>
+        </p:txBody>
+      </p:sp>
+      <p:sp>
+        <p:nvSpPr>
+          <p:cNvPr id="22" name="Shape 18"/>
+          <p:cNvSpPr/>
+          <p:nvPr/>
+        </p:nvSpPr>
+        <p:spPr>
+          <a:xfrm>
+            <a:off x="6217920" y="2468880"/>
+            <a:ext cx="1188720" cy="292608"/>
+          </a:xfrm>
+          <a:prstGeom prst="roundRect">
+            <a:avLst>
+              <a:gd name="adj" fmla="val 15625"/>
+            </a:avLst>
+          </a:prstGeom>
+          <a:solidFill>
+            <a:srgbClr val="FBE3DA"/>
+          </a:solidFill>
+          <a:ln w="12700">
+            <a:solidFill>
+              <a:srgbClr val="FBE3DA"/>
+            </a:solidFill>
+            <a:prstDash val="solid"/>
+          </a:ln>
+        </p:spPr>
+      </p:sp>
+      <p:sp>
+        <p:nvSpPr>
+          <p:cNvPr id="23" name="Text 19"/>
+          <p:cNvSpPr txBox="1"/>
+          <p:nvPr/>
+        </p:nvSpPr>
+        <p:spPr>
+          <a:xfrm>
+            <a:off x="6217920" y="2468880"/>
+            <a:ext cx="1188720" cy="292608"/>
+          </a:xfrm>
+          <a:prstGeom prst="rect">
+            <a:avLst/>
+          </a:prstGeom>
+          <a:noFill/>
+          <a:ln/>
+        </p:spPr>
+        <p:txBody>
+          <a:bodyPr wrap="square" lIns="0" tIns="0" rIns="0" bIns="0" rtlCol="0" anchor="ctr"/>
+          <a:lstStyle/>
+          <a:p>
+            <a:pPr algn="ctr" indent="0" marL="0">
+              <a:buNone/>
+            </a:pPr>
+            <a:r>
+              <a:rPr lang="en-US" sz="1000" b="1" dirty="0">
+                <a:solidFill>
+                  <a:schemeClr val="accent3"/>
+                </a:solidFill>
+              </a:rPr>
+              <a:t>Voter ID</a:t>
+            </a:r>
+            <a:endParaRPr lang="en-US" sz="1000" dirty="0"/>
+          </a:p>
+        </p:txBody>
+      </p:sp>
+      <p:sp>
+        <p:nvSpPr>
+          <p:cNvPr id="24" name="Shape 20"/>
+          <p:cNvSpPr/>
+          <p:nvPr/>
+        </p:nvSpPr>
+        <p:spPr>
+          <a:xfrm>
+            <a:off x="7470648" y="2468880"/>
+            <a:ext cx="1188720" cy="292608"/>
+          </a:xfrm>
+          <a:prstGeom prst="roundRect">
+            <a:avLst>
+              <a:gd name="adj" fmla="val 15625"/>
+            </a:avLst>
+          </a:prstGeom>
+          <a:solidFill>
+            <a:srgbClr val="FBE3DA"/>
+          </a:solidFill>
+          <a:ln w="12700">
+            <a:solidFill>
+              <a:srgbClr val="FBE3DA"/>
+            </a:solidFill>
+            <a:prstDash val="solid"/>
+          </a:ln>
+        </p:spPr>
+      </p:sp>
+      <p:sp>
+        <p:nvSpPr>
+          <p:cNvPr id="25" name="Text 21"/>
+          <p:cNvSpPr txBox="1"/>
+          <p:nvPr/>
+        </p:nvSpPr>
+        <p:spPr>
+          <a:xfrm>
+            <a:off x="7470648" y="2468880"/>
+            <a:ext cx="1188720" cy="292608"/>
+          </a:xfrm>
+          <a:prstGeom prst="rect">
+            <a:avLst/>
+          </a:prstGeom>
+          <a:noFill/>
+          <a:ln/>
+        </p:spPr>
+        <p:txBody>
+          <a:bodyPr wrap="square" lIns="0" tIns="0" rIns="0" bIns="0" rtlCol="0" anchor="ctr"/>
+          <a:lstStyle/>
+          <a:p>
+            <a:pPr algn="ctr" indent="0" marL="0">
+              <a:buNone/>
+            </a:pPr>
+            <a:r>
+              <a:rPr lang="en-US" sz="1000" b="1" dirty="0">
+                <a:solidFill>
+                  <a:schemeClr val="accent3"/>
+                </a:solidFill>
+              </a:rPr>
+              <a:t>Passport</a:t>
+            </a:r>
+            <a:endParaRPr lang="en-US" sz="1000" dirty="0"/>
+          </a:p>
+        </p:txBody>
+      </p:sp>
+      <p:sp>
+        <p:nvSpPr>
+          <p:cNvPr id="26" name="Shape 22"/>
+          <p:cNvSpPr/>
+          <p:nvPr/>
+        </p:nvSpPr>
+        <p:spPr>
+          <a:xfrm>
+            <a:off x="6217920" y="2834640"/>
+            <a:ext cx="1188720" cy="292608"/>
+          </a:xfrm>
+          <a:prstGeom prst="roundRect">
+            <a:avLst>
+              <a:gd name="adj" fmla="val 15625"/>
+            </a:avLst>
+          </a:prstGeom>
+          <a:solidFill>
+            <a:srgbClr val="FBE3DA"/>
+          </a:solidFill>
+          <a:ln w="12700">
+            <a:solidFill>
+              <a:srgbClr val="FBE3DA"/>
+            </a:solidFill>
+            <a:prstDash val="solid"/>
+          </a:ln>
+        </p:spPr>
+      </p:sp>
+      <p:sp>
+        <p:nvSpPr>
+          <p:cNvPr id="27" name="Text 23"/>
+          <p:cNvSpPr txBox="1"/>
+          <p:nvPr/>
+        </p:nvSpPr>
+        <p:spPr>
+          <a:xfrm>
+            <a:off x="6217920" y="2834640"/>
+            <a:ext cx="1188720" cy="292608"/>
+          </a:xfrm>
+          <a:prstGeom prst="rect">
+            <a:avLst/>
+          </a:prstGeom>
+          <a:noFill/>
+          <a:ln/>
+        </p:spPr>
+        <p:txBody>
+          <a:bodyPr wrap="square" lIns="0" tIns="0" rIns="0" bIns="0" rtlCol="0" anchor="ctr"/>
+          <a:lstStyle/>
+          <a:p>
+            <a:pPr algn="ctr" indent="0" marL="0">
+              <a:buNone/>
+            </a:pPr>
+            <a:r>
+              <a:rPr lang="en-US" sz="1000" b="1" dirty="0">
+                <a:solidFill>
+                  <a:schemeClr val="accent3"/>
+                </a:solidFill>
+              </a:rPr>
+              <a:t>Vehicle plate</a:t>
+            </a:r>
+            <a:endParaRPr lang="en-US" sz="1000" dirty="0"/>
+          </a:p>
+        </p:txBody>
+      </p:sp>
+      <p:sp>
+        <p:nvSpPr>
+          <p:cNvPr id="28" name="Shape 24"/>
+          <p:cNvSpPr/>
+          <p:nvPr/>
+        </p:nvSpPr>
+        <p:spPr>
+          <a:xfrm>
+            <a:off x="7470648" y="2834640"/>
+            <a:ext cx="1188720" cy="292608"/>
+          </a:xfrm>
+          <a:prstGeom prst="roundRect">
+            <a:avLst>
+              <a:gd name="adj" fmla="val 15625"/>
+            </a:avLst>
+          </a:prstGeom>
+          <a:solidFill>
+            <a:srgbClr val="FBE3DA"/>
+          </a:solidFill>
+          <a:ln w="12700">
+            <a:solidFill>
+              <a:srgbClr val="FBE3DA"/>
+            </a:solidFill>
+            <a:prstDash val="solid"/>
+          </a:ln>
+        </p:spPr>
+      </p:sp>
+      <p:sp>
+        <p:nvSpPr>
+          <p:cNvPr id="29" name="Text 25"/>
+          <p:cNvSpPr txBox="1"/>
+          <p:nvPr/>
+        </p:nvSpPr>
+        <p:spPr>
+          <a:xfrm>
+            <a:off x="7470648" y="2834640"/>
+            <a:ext cx="1188720" cy="292608"/>
+          </a:xfrm>
+          <a:prstGeom prst="rect">
+            <a:avLst/>
+          </a:prstGeom>
+          <a:noFill/>
+          <a:ln/>
+        </p:spPr>
+        <p:txBody>
+          <a:bodyPr wrap="square" lIns="0" tIns="0" rIns="0" bIns="0" rtlCol="0" anchor="ctr"/>
+          <a:lstStyle/>
+          <a:p>
+            <a:pPr algn="ctr" indent="0" marL="0">
+              <a:buNone/>
+            </a:pPr>
+            <a:r>
+              <a:rPr lang="en-US" sz="1000" b="1" dirty="0">
+                <a:solidFill>
+                  <a:schemeClr val="accent3"/>
+                </a:solidFill>
+              </a:rPr>
+              <a:t>+91 phone</a:t>
+            </a:r>
+            <a:endParaRPr lang="en-US" sz="1000" dirty="0"/>
+          </a:p>
+        </p:txBody>
+      </p:sp>
+      <p:sp>
+        <p:nvSpPr>
+          <p:cNvPr id="30" name="Shape 26"/>
+          <p:cNvSpPr/>
+          <p:nvPr/>
+        </p:nvSpPr>
+        <p:spPr>
+          <a:xfrm>
+            <a:off x="6217920" y="3200400"/>
+            <a:ext cx="1188720" cy="292608"/>
+          </a:xfrm>
+          <a:prstGeom prst="roundRect">
+            <a:avLst>
+              <a:gd name="adj" fmla="val 15625"/>
+            </a:avLst>
+          </a:prstGeom>
+          <a:solidFill>
+            <a:schemeClr val="bg2"/>
+          </a:solidFill>
+          <a:ln w="12700">
+            <a:solidFill>
+              <a:schemeClr val="bg2"/>
+            </a:solidFill>
+            <a:prstDash val="solid"/>
+          </a:ln>
+        </p:spPr>
+      </p:sp>
+      <p:sp>
+        <p:nvSpPr>
+          <p:cNvPr id="31" name="Text 27"/>
+          <p:cNvSpPr txBox="1"/>
+          <p:nvPr/>
+        </p:nvSpPr>
+        <p:spPr>
+          <a:xfrm>
+            <a:off x="6217920" y="3200400"/>
+            <a:ext cx="1188720" cy="292608"/>
+          </a:xfrm>
+          <a:prstGeom prst="rect">
+            <a:avLst/>
+          </a:prstGeom>
+          <a:noFill/>
+          <a:ln/>
+        </p:spPr>
+        <p:txBody>
+          <a:bodyPr wrap="square" lIns="0" tIns="0" rIns="0" bIns="0" rtlCol="0" anchor="ctr"/>
+          <a:lstStyle/>
+          <a:p>
+            <a:pPr algn="ctr" indent="0" marL="0">
+              <a:buNone/>
+            </a:pPr>
+            <a:r>
+              <a:rPr lang="en-US" sz="1000" dirty="0">
                 <a:solidFill>
                   <a:schemeClr val="tx1"/>
                 </a:solidFill>
               </a:rPr>
-              <a:t>Finds data with patterns + checksums (Luhn, Verhoeff), field structure, and a face detector</a:t>
-            </a:r>
-            <a:endParaRPr lang="en-US" sz="1300" dirty="0"/>
-          </a:p>
-          <a:p>
-            <a:pPr marL="342900" indent="-342900">
-              <a:spcAft>
-                <a:spcPts val="600"/>
-              </a:spcAft>
-              <a:buSzPct val="100000"/>
-              <a:buChar char="•"/>
-            </a:pPr>
-            <a:r>
-              <a:rPr lang="en-US" sz="1300" dirty="0">
+              <a:t>Card · Luhn</a:t>
+            </a:r>
+            <a:endParaRPr lang="en-US" sz="1000" dirty="0"/>
+          </a:p>
+        </p:txBody>
+      </p:sp>
+      <p:sp>
+        <p:nvSpPr>
+          <p:cNvPr id="32" name="Shape 28"/>
+          <p:cNvSpPr/>
+          <p:nvPr/>
+        </p:nvSpPr>
+        <p:spPr>
+          <a:xfrm>
+            <a:off x="7470648" y="3200400"/>
+            <a:ext cx="1188720" cy="292608"/>
+          </a:xfrm>
+          <a:prstGeom prst="roundRect">
+            <a:avLst>
+              <a:gd name="adj" fmla="val 15625"/>
+            </a:avLst>
+          </a:prstGeom>
+          <a:solidFill>
+            <a:schemeClr val="bg2"/>
+          </a:solidFill>
+          <a:ln w="12700">
+            <a:solidFill>
+              <a:schemeClr val="bg2"/>
+            </a:solidFill>
+            <a:prstDash val="solid"/>
+          </a:ln>
+        </p:spPr>
+      </p:sp>
+      <p:sp>
+        <p:nvSpPr>
+          <p:cNvPr id="33" name="Text 29"/>
+          <p:cNvSpPr txBox="1"/>
+          <p:nvPr/>
+        </p:nvSpPr>
+        <p:spPr>
+          <a:xfrm>
+            <a:off x="7470648" y="3200400"/>
+            <a:ext cx="1188720" cy="292608"/>
+          </a:xfrm>
+          <a:prstGeom prst="rect">
+            <a:avLst/>
+          </a:prstGeom>
+          <a:noFill/>
+          <a:ln/>
+        </p:spPr>
+        <p:txBody>
+          <a:bodyPr wrap="square" lIns="0" tIns="0" rIns="0" bIns="0" rtlCol="0" anchor="ctr"/>
+          <a:lstStyle/>
+          <a:p>
+            <a:pPr algn="ctr" indent="0" marL="0">
+              <a:buNone/>
+            </a:pPr>
+            <a:r>
+              <a:rPr lang="en-US" sz="1000" dirty="0">
                 <a:solidFill>
                   <a:schemeClr val="tx1"/>
                 </a:solidFill>
               </a:rPr>
-              <a:t>Turns on by itself when automation or a debugger is attached</a:t>
-            </a:r>
-            <a:endParaRPr lang="en-US" sz="1300" dirty="0"/>
-          </a:p>
-          <a:p>
-            <a:pPr marL="342900" indent="-342900">
-              <a:spcAft>
-                <a:spcPts val="600"/>
-              </a:spcAft>
-              <a:buSzPct val="100000"/>
-              <a:buChar char="•"/>
-            </a:pPr>
-            <a:r>
-              <a:rPr lang="en-US" sz="1300" dirty="0">
+              <a:t>OTP · password</a:t>
+            </a:r>
+            <a:endParaRPr lang="en-US" sz="1000" dirty="0"/>
+          </a:p>
+        </p:txBody>
+      </p:sp>
+      <p:sp>
+        <p:nvSpPr>
+          <p:cNvPr id="34" name="Shape 30"/>
+          <p:cNvSpPr/>
+          <p:nvPr/>
+        </p:nvSpPr>
+        <p:spPr>
+          <a:xfrm>
+            <a:off x="6217920" y="3566160"/>
+            <a:ext cx="1188720" cy="292608"/>
+          </a:xfrm>
+          <a:prstGeom prst="roundRect">
+            <a:avLst>
+              <a:gd name="adj" fmla="val 15625"/>
+            </a:avLst>
+          </a:prstGeom>
+          <a:solidFill>
+            <a:schemeClr val="bg2"/>
+          </a:solidFill>
+          <a:ln w="12700">
+            <a:solidFill>
+              <a:schemeClr val="bg2"/>
+            </a:solidFill>
+            <a:prstDash val="solid"/>
+          </a:ln>
+        </p:spPr>
+      </p:sp>
+      <p:sp>
+        <p:nvSpPr>
+          <p:cNvPr id="35" name="Text 31"/>
+          <p:cNvSpPr txBox="1"/>
+          <p:nvPr/>
+        </p:nvSpPr>
+        <p:spPr>
+          <a:xfrm>
+            <a:off x="6217920" y="3566160"/>
+            <a:ext cx="1188720" cy="292608"/>
+          </a:xfrm>
+          <a:prstGeom prst="rect">
+            <a:avLst/>
+          </a:prstGeom>
+          <a:noFill/>
+          <a:ln/>
+        </p:spPr>
+        <p:txBody>
+          <a:bodyPr wrap="square" lIns="0" tIns="0" rIns="0" bIns="0" rtlCol="0" anchor="ctr"/>
+          <a:lstStyle/>
+          <a:p>
+            <a:pPr algn="ctr" indent="0" marL="0">
+              <a:buNone/>
+            </a:pPr>
+            <a:r>
+              <a:rPr lang="en-US" sz="1000" dirty="0">
                 <a:solidFill>
                   <a:schemeClr val="tx1"/>
                 </a:solidFill>
               </a:rPr>
-              <a:t>Covers screenshots and rewrites DOM text and input values to [REDACTED:KIND]</a:t>
-            </a:r>
-            <a:endParaRPr lang="en-US" sz="1300" dirty="0"/>
-          </a:p>
-          <a:p>
-            <a:pPr marL="342900" indent="-342900">
-              <a:spcAft>
-                <a:spcPts val="600"/>
-              </a:spcAft>
-              <a:buSzPct val="100000"/>
-              <a:buChar char="•"/>
-            </a:pPr>
-            <a:r>
-              <a:rPr lang="en-US" sz="1300" dirty="0">
+              <a:t>API key · token</a:t>
+            </a:r>
+            <a:endParaRPr lang="en-US" sz="1000" dirty="0"/>
+          </a:p>
+        </p:txBody>
+      </p:sp>
+      <p:sp>
+        <p:nvSpPr>
+          <p:cNvPr id="36" name="Shape 32"/>
+          <p:cNvSpPr/>
+          <p:nvPr/>
+        </p:nvSpPr>
+        <p:spPr>
+          <a:xfrm>
+            <a:off x="7470648" y="3566160"/>
+            <a:ext cx="1188720" cy="292608"/>
+          </a:xfrm>
+          <a:prstGeom prst="roundRect">
+            <a:avLst>
+              <a:gd name="adj" fmla="val 15625"/>
+            </a:avLst>
+          </a:prstGeom>
+          <a:solidFill>
+            <a:schemeClr val="bg2"/>
+          </a:solidFill>
+          <a:ln w="12700">
+            <a:solidFill>
+              <a:schemeClr val="bg2"/>
+            </a:solidFill>
+            <a:prstDash val="solid"/>
+          </a:ln>
+        </p:spPr>
+      </p:sp>
+      <p:sp>
+        <p:nvSpPr>
+          <p:cNvPr id="37" name="Text 33"/>
+          <p:cNvSpPr txBox="1"/>
+          <p:nvPr/>
+        </p:nvSpPr>
+        <p:spPr>
+          <a:xfrm>
+            <a:off x="7470648" y="3566160"/>
+            <a:ext cx="1188720" cy="292608"/>
+          </a:xfrm>
+          <a:prstGeom prst="rect">
+            <a:avLst/>
+          </a:prstGeom>
+          <a:noFill/>
+          <a:ln/>
+        </p:spPr>
+        <p:txBody>
+          <a:bodyPr wrap="square" lIns="0" tIns="0" rIns="0" bIns="0" rtlCol="0" anchor="ctr"/>
+          <a:lstStyle/>
+          <a:p>
+            <a:pPr algn="ctr" indent="0" marL="0">
+              <a:buNone/>
+            </a:pPr>
+            <a:r>
+              <a:rPr lang="en-US" sz="1000" dirty="0">
                 <a:solidFill>
                   <a:schemeClr val="tx1"/>
                 </a:solidFill>
               </a:rPr>
-              <a:t>Works for Playwright, CDP and agent extensions with no integration</a:t>
-            </a:r>
-            <a:endParaRPr lang="en-US" sz="1300" dirty="0"/>
-          </a:p>
-        </p:txBody>
-      </p:sp>
-      <p:sp>
-        <p:nvSpPr>
-          <p:cNvPr id="10" name="Text 6"/>
-          <p:cNvSpPr txBox="1"/>
-          <p:nvPr/>
-        </p:nvSpPr>
-        <p:spPr>
-          <a:xfrm>
-            <a:off x="457200" y="3977640"/>
-            <a:ext cx="5532120" cy="548640"/>
+              <a:t>Email · IP</a:t>
+            </a:r>
+            <a:endParaRPr lang="en-US" sz="1000" dirty="0"/>
+          </a:p>
+        </p:txBody>
+      </p:sp>
+      <p:sp>
+        <p:nvSpPr>
+          <p:cNvPr id="38" name="Shape 34"/>
+          <p:cNvSpPr/>
+          <p:nvPr/>
+        </p:nvSpPr>
+        <p:spPr>
+          <a:xfrm>
+            <a:off x="6217920" y="3931920"/>
+            <a:ext cx="1188720" cy="292608"/>
+          </a:xfrm>
+          <a:prstGeom prst="roundRect">
+            <a:avLst>
+              <a:gd name="adj" fmla="val 15625"/>
+            </a:avLst>
+          </a:prstGeom>
+          <a:solidFill>
+            <a:schemeClr val="bg2"/>
+          </a:solidFill>
+          <a:ln w="12700">
+            <a:solidFill>
+              <a:schemeClr val="bg2"/>
+            </a:solidFill>
+            <a:prstDash val="solid"/>
+          </a:ln>
+        </p:spPr>
+      </p:sp>
+      <p:sp>
+        <p:nvSpPr>
+          <p:cNvPr id="39" name="Text 35"/>
+          <p:cNvSpPr txBox="1"/>
+          <p:nvPr/>
+        </p:nvSpPr>
+        <p:spPr>
+          <a:xfrm>
+            <a:off x="6217920" y="3931920"/>
+            <a:ext cx="1188720" cy="292608"/>
+          </a:xfrm>
+          <a:prstGeom prst="rect">
+            <a:avLst/>
+          </a:prstGeom>
+          <a:noFill/>
+          <a:ln/>
+        </p:spPr>
+        <p:txBody>
+          <a:bodyPr wrap="square" lIns="0" tIns="0" rIns="0" bIns="0" rtlCol="0" anchor="ctr"/>
+          <a:lstStyle/>
+          <a:p>
+            <a:pPr algn="ctr" indent="0" marL="0">
+              <a:buNone/>
+            </a:pPr>
+            <a:r>
+              <a:rPr lang="en-US" sz="1000" dirty="0">
+                <a:solidFill>
+                  <a:schemeClr val="tx1"/>
+                </a:solidFill>
+              </a:rPr>
+              <a:t>Faces</a:t>
+            </a:r>
+            <a:endParaRPr lang="en-US" sz="1000" dirty="0"/>
+          </a:p>
+        </p:txBody>
+      </p:sp>
+      <p:sp>
+        <p:nvSpPr>
+          <p:cNvPr id="40" name="Shape 36"/>
+          <p:cNvSpPr/>
+          <p:nvPr/>
+        </p:nvSpPr>
+        <p:spPr>
+          <a:xfrm>
+            <a:off x="7470648" y="3931920"/>
+            <a:ext cx="1188720" cy="292608"/>
+          </a:xfrm>
+          <a:prstGeom prst="roundRect">
+            <a:avLst>
+              <a:gd name="adj" fmla="val 15625"/>
+            </a:avLst>
+          </a:prstGeom>
+          <a:solidFill>
+            <a:schemeClr val="bg2"/>
+          </a:solidFill>
+          <a:ln w="12700">
+            <a:solidFill>
+              <a:schemeClr val="bg2"/>
+            </a:solidFill>
+            <a:prstDash val="solid"/>
+          </a:ln>
+        </p:spPr>
+      </p:sp>
+      <p:sp>
+        <p:nvSpPr>
+          <p:cNvPr id="41" name="Text 37"/>
+          <p:cNvSpPr txBox="1"/>
+          <p:nvPr/>
+        </p:nvSpPr>
+        <p:spPr>
+          <a:xfrm>
+            <a:off x="7470648" y="3931920"/>
+            <a:ext cx="1188720" cy="292608"/>
+          </a:xfrm>
+          <a:prstGeom prst="rect">
+            <a:avLst/>
+          </a:prstGeom>
+          <a:noFill/>
+          <a:ln/>
+        </p:spPr>
+        <p:txBody>
+          <a:bodyPr wrap="square" lIns="0" tIns="0" rIns="0" bIns="0" rtlCol="0" anchor="ctr"/>
+          <a:lstStyle/>
+          <a:p>
+            <a:pPr algn="ctr" indent="0" marL="0">
+              <a:buNone/>
+            </a:pPr>
+            <a:r>
+              <a:rPr lang="en-US" sz="1000" dirty="0">
+                <a:solidFill>
+                  <a:schemeClr val="tx1"/>
+                </a:solidFill>
+              </a:rPr>
+              <a:t>Address · name fields</a:t>
+            </a:r>
+            <a:endParaRPr lang="en-US" sz="1000" dirty="0"/>
+          </a:p>
+        </p:txBody>
+      </p:sp>
+      <p:sp>
+        <p:nvSpPr>
+          <p:cNvPr id="42" name="Text 38"/>
+          <p:cNvSpPr txBox="1"/>
+          <p:nvPr/>
+        </p:nvSpPr>
+        <p:spPr>
+          <a:xfrm>
+            <a:off x="6217920" y="4343400"/>
+            <a:ext cx="2468880" cy="411480"/>
           </a:xfrm>
           <a:prstGeom prst="rect">
             <a:avLst/>
@@ -4688,12 +5638,48 @@
               <a:buNone/>
             </a:pPr>
             <a:r>
+              <a:rPr lang="en-US" sz="1000" i="1" dirty="0">
+                <a:solidFill>
+                  <a:schemeClr val="accent5"/>
+                </a:solidFill>
+              </a:rPr>
+              <a:t>Highlighted: built for India. Hindi digits (०–९) and Hinglish keywords handled too.</a:t>
+            </a:r>
+            <a:endParaRPr lang="en-US" sz="1000" dirty="0"/>
+          </a:p>
+        </p:txBody>
+      </p:sp>
+      <p:sp>
+        <p:nvSpPr>
+          <p:cNvPr id="43" name="Text 39"/>
+          <p:cNvSpPr txBox="1"/>
+          <p:nvPr/>
+        </p:nvSpPr>
+        <p:spPr>
+          <a:xfrm>
+            <a:off x="457200" y="3931920"/>
+            <a:ext cx="5532120" cy="640080"/>
+          </a:xfrm>
+          <a:prstGeom prst="rect">
+            <a:avLst/>
+          </a:prstGeom>
+          <a:noFill/>
+          <a:ln/>
+        </p:spPr>
+        <p:txBody>
+          <a:bodyPr wrap="square" lIns="0" tIns="0" rIns="0" bIns="0" rtlCol="0" anchor="t"/>
+          <a:lstStyle/>
+          <a:p>
+            <a:pPr indent="0" marL="0">
+              <a:buNone/>
+            </a:pPr>
+            <a:r>
               <a:rPr lang="en-US" sz="1300" i="1" dirty="0">
                 <a:solidFill>
                   <a:schemeClr val="tx2"/>
                 </a:solidFill>
               </a:rPr>
-              <a:t>Real values never leave the page; covers appear about 3 ms after new content.</a:t>
+              <a:t>Turns on by itself when an agent drives the browser. Covers appear about 3 ms after new content; real values never leave the page.</a:t>
             </a:r>
             <a:endParaRPr lang="en-US" sz="1300" dirty="0"/>
           </a:p>

</xml_diff>

<commit_message>
Deck slide 6: add worked example, plain redaction vs Zen output on the same text
</commit_message>
<xml_diff>
--- a/submission/Zen_PECathon.pptx
+++ b/submission/Zen_PECathon.pptx
@@ -114,26 +114,26 @@
   <p:extLst>
     <p:ext uri="{521415D9-36F7-43E2-AB2F-B90AF26B5E84}">
       <p14:sectionLst xmlns:p14="http://schemas.microsoft.com/office/powerpoint/2010/main">
-        <p14:section name="Intro" id="{f36eceac-d222-f71e-e3fe-fe1606edec24}">
+        <p14:section name="Intro" id="{ce92ce52-617d-08e9-d5bc-0ac5fbf3c2b8}">
           <p14:sldIdLst>
             <p14:sldId id="256"/>
           </p14:sldIdLst>
         </p14:section>
-        <p14:section name="Problem and design" id="{827b9d52-91d6-2960-6647-cdac92835f4a}">
+        <p14:section name="Problem and design" id="{1435edd7-dc3a-133b-b827-16f9b04ae2a8}">
           <p14:sldIdLst>
             <p14:sldId id="257"/>
             <p14:sldId id="258"/>
             <p14:sldId id="259"/>
           </p14:sldIdLst>
         </p14:section>
-        <p14:section name="How it works" id="{a15c5b7c-ace4-b4dd-e4bf-71f4b8098a67}">
+        <p14:section name="How it works" id="{bb80fe60-1e73-aa9f-f6d1-2efe8328d70c}">
           <p14:sldIdLst>
             <p14:sldId id="260"/>
             <p14:sldId id="261"/>
             <p14:sldId id="262"/>
           </p14:sldIdLst>
         </p14:section>
-        <p14:section name="Results" id="{eef47ce5-76ee-2c51-910a-5ef54d039e92}">
+        <p14:section name="Results" id="{194ea8dd-37ea-b3ad-6556-a94a9e134086}">
           <p14:sldIdLst>
             <p14:sldId id="263"/>
           </p14:sldIdLst>
@@ -5803,8 +5803,8 @@
           <p:nvPr/>
         </p:nvGraphicFramePr>
         <p:xfrm>
-          <a:off x="365760" y="1005840"/>
-          <a:ext cx="4937760" cy="3566160"/>
+          <a:off x="365760" y="914400"/>
+          <a:ext cx="5029200" cy="2606040"/>
         </p:xfrm>
         <a:graphic xmlns:a="http://schemas.openxmlformats.org/drawingml/2006/main">
           <a:graphicData uri="http://schemas.openxmlformats.org/drawingml/2006/chart">
@@ -5820,12 +5820,12 @@
         </p:nvSpPr>
         <p:spPr>
           <a:xfrm>
-            <a:off x="5577840" y="1097280"/>
-            <a:ext cx="3108960" cy="1005840"/>
+            <a:off x="5577840" y="1005840"/>
+            <a:ext cx="3108960" cy="731520"/>
           </a:xfrm>
           <a:prstGeom prst="roundRect">
             <a:avLst>
-              <a:gd name="adj" fmla="val 7273"/>
+              <a:gd name="adj" fmla="val 10000"/>
             </a:avLst>
           </a:prstGeom>
           <a:solidFill>
@@ -5847,8 +5847,8 @@
         </p:nvSpPr>
         <p:spPr>
           <a:xfrm>
-            <a:off x="5715000" y="1207008"/>
-            <a:ext cx="2834640" cy="320040"/>
+            <a:off x="5715000" y="1078992"/>
+            <a:ext cx="2834640" cy="274320"/>
           </a:xfrm>
           <a:prstGeom prst="rect">
             <a:avLst/>
@@ -5864,14 +5864,14 @@
               <a:buNone/>
             </a:pPr>
             <a:r>
-              <a:rPr lang="en-US" sz="1400" b="1" dirty="0">
+              <a:rPr lang="en-US" sz="1300" b="1" dirty="0">
                 <a:solidFill>
                   <a:schemeClr val="accent3"/>
                 </a:solidFill>
               </a:rPr>
               <a:t>“card ending 4242”, 98XXXXX210</a:t>
             </a:r>
-            <a:endParaRPr lang="en-US" sz="1400" dirty="0"/>
+            <a:endParaRPr lang="en-US" sz="1300" dirty="0"/>
           </a:p>
         </p:txBody>
       </p:sp>
@@ -5883,8 +5883,8 @@
         </p:nvSpPr>
         <p:spPr>
           <a:xfrm>
-            <a:off x="5715000" y="1554480"/>
-            <a:ext cx="2834640" cy="502920"/>
+            <a:off x="5715000" y="1371600"/>
+            <a:ext cx="2834640" cy="329184"/>
           </a:xfrm>
           <a:prstGeom prst="rect">
             <a:avLst/>
@@ -5900,14 +5900,14 @@
               <a:buNone/>
             </a:pPr>
             <a:r>
-              <a:rPr lang="en-US" sz="1200" dirty="0">
+              <a:rPr lang="en-US" sz="1100" dirty="0">
                 <a:solidFill>
                   <a:schemeClr val="tx1"/>
                 </a:solidFill>
               </a:rPr>
               <a:t>partial values removed before the AI sees them</a:t>
             </a:r>
-            <a:endParaRPr lang="en-US" sz="1200" dirty="0"/>
+            <a:endParaRPr lang="en-US" sz="1100" dirty="0"/>
           </a:p>
         </p:txBody>
       </p:sp>
@@ -5919,12 +5919,12 @@
         </p:nvSpPr>
         <p:spPr>
           <a:xfrm>
-            <a:off x="5577840" y="2240280"/>
-            <a:ext cx="3108960" cy="1005840"/>
+            <a:off x="5577840" y="1828800"/>
+            <a:ext cx="3108960" cy="731520"/>
           </a:xfrm>
           <a:prstGeom prst="roundRect">
             <a:avLst>
-              <a:gd name="adj" fmla="val 7273"/>
+              <a:gd name="adj" fmla="val 10000"/>
             </a:avLst>
           </a:prstGeom>
           <a:solidFill>
@@ -5946,8 +5946,8 @@
         </p:nvSpPr>
         <p:spPr>
           <a:xfrm>
-            <a:off x="5715000" y="2350008"/>
-            <a:ext cx="2834640" cy="320040"/>
+            <a:off x="5715000" y="1901952"/>
+            <a:ext cx="2834640" cy="274320"/>
           </a:xfrm>
           <a:prstGeom prst="rect">
             <a:avLst/>
@@ -5963,14 +5963,14 @@
               <a:buNone/>
             </a:pPr>
             <a:r>
-              <a:rPr lang="en-US" sz="1400" b="1" dirty="0">
+              <a:rPr lang="en-US" sz="1300" b="1" dirty="0">
                 <a:solidFill>
                   <a:schemeClr val="accent3"/>
                 </a:solidFill>
               </a:rPr>
               <a:t>DOB → year, PIN code → district</a:t>
             </a:r>
-            <a:endParaRPr lang="en-US" sz="1400" dirty="0"/>
+            <a:endParaRPr lang="en-US" sz="1300" dirty="0"/>
           </a:p>
         </p:txBody>
       </p:sp>
@@ -5982,8 +5982,8 @@
         </p:nvSpPr>
         <p:spPr>
           <a:xfrm>
-            <a:off x="5715000" y="2697480"/>
-            <a:ext cx="2834640" cy="502920"/>
+            <a:off x="5715000" y="2194560"/>
+            <a:ext cx="2834640" cy="329184"/>
           </a:xfrm>
           <a:prstGeom prst="rect">
             <a:avLst/>
@@ -5999,14 +5999,14 @@
               <a:buNone/>
             </a:pPr>
             <a:r>
-              <a:rPr lang="en-US" sz="1200" dirty="0">
+              <a:rPr lang="en-US" sz="1100" dirty="0">
                 <a:solidFill>
                   <a:schemeClr val="tx1"/>
                 </a:solidFill>
               </a:rPr>
               <a:t>quasi-identifiers coarsened; every anonymity set stays ≥ 20</a:t>
             </a:r>
-            <a:endParaRPr lang="en-US" sz="1200" dirty="0"/>
+            <a:endParaRPr lang="en-US" sz="1100" dirty="0"/>
           </a:p>
         </p:txBody>
       </p:sp>
@@ -6018,12 +6018,12 @@
         </p:nvSpPr>
         <p:spPr>
           <a:xfrm>
-            <a:off x="5577840" y="3383280"/>
-            <a:ext cx="3108960" cy="1005840"/>
+            <a:off x="5577840" y="2651760"/>
+            <a:ext cx="3108960" cy="731520"/>
           </a:xfrm>
           <a:prstGeom prst="roundRect">
             <a:avLst>
-              <a:gd name="adj" fmla="val 7273"/>
+              <a:gd name="adj" fmla="val 10000"/>
             </a:avLst>
           </a:prstGeom>
           <a:solidFill>
@@ -6045,8 +6045,8 @@
         </p:nvSpPr>
         <p:spPr>
           <a:xfrm>
-            <a:off x="5715000" y="3493008"/>
-            <a:ext cx="2834640" cy="320040"/>
+            <a:off x="5715000" y="2724912"/>
+            <a:ext cx="2834640" cy="274320"/>
           </a:xfrm>
           <a:prstGeom prst="rect">
             <a:avLst/>
@@ -6062,14 +6062,14 @@
               <a:buNone/>
             </a:pPr>
             <a:r>
-              <a:rPr lang="en-US" sz="1400" b="1" dirty="0">
+              <a:rPr lang="en-US" sz="1300" b="1" dirty="0">
                 <a:solidFill>
                   <a:schemeClr val="accent3"/>
                 </a:solidFill>
               </a:rPr>
               <a:t>0 of 260</a:t>
             </a:r>
-            <a:endParaRPr lang="en-US" sz="1400" dirty="0"/>
+            <a:endParaRPr lang="en-US" sz="1300" dirty="0"/>
           </a:p>
         </p:txBody>
       </p:sp>
@@ -6081,8 +6081,8 @@
         </p:nvSpPr>
         <p:spPr>
           <a:xfrm>
-            <a:off x="5715000" y="3840480"/>
-            <a:ext cx="2834640" cy="502920"/>
+            <a:off x="5715000" y="3017520"/>
+            <a:ext cx="2834640" cy="329184"/>
           </a:xfrm>
           <a:prstGeom prst="rect">
             <a:avLst/>
@@ -6098,14 +6098,338 @@
               <a:buNone/>
             </a:pPr>
             <a:r>
-              <a:rPr lang="en-US" sz="1200" dirty="0">
+              <a:rPr lang="en-US" sz="1100" dirty="0">
                 <a:solidFill>
                   <a:schemeClr val="tx1"/>
                 </a:solidFill>
               </a:rPr>
               <a:t>harmless tokens changed: utility kept</a:t>
             </a:r>
-            <a:endParaRPr lang="en-US" sz="1200" dirty="0"/>
+            <a:endParaRPr lang="en-US" sz="1100" dirty="0"/>
+          </a:p>
+        </p:txBody>
+      </p:sp>
+      <p:sp>
+        <p:nvSpPr>
+          <p:cNvPr id="13" name="card"/>
+          <p:cNvSpPr/>
+          <p:nvPr/>
+        </p:nvSpPr>
+        <p:spPr>
+          <a:xfrm>
+            <a:off x="457200" y="3611880"/>
+            <a:ext cx="8229600" cy="1051560"/>
+          </a:xfrm>
+          <a:prstGeom prst="roundRect">
+            <a:avLst>
+              <a:gd name="adj" fmla="val 6957"/>
+            </a:avLst>
+          </a:prstGeom>
+          <a:solidFill>
+            <a:schemeClr val="bg2"/>
+          </a:solidFill>
+          <a:ln w="12700">
+            <a:solidFill>
+              <a:schemeClr val="bg2"/>
+            </a:solidFill>
+            <a:prstDash val="solid"/>
+          </a:ln>
+        </p:spPr>
+      </p:sp>
+      <p:sp>
+        <p:nvSpPr>
+          <p:cNvPr id="14" name="Text 11"/>
+          <p:cNvSpPr txBox="1"/>
+          <p:nvPr/>
+        </p:nvSpPr>
+        <p:spPr>
+          <a:xfrm>
+            <a:off x="594360" y="3685032"/>
+            <a:ext cx="1234440" cy="292608"/>
+          </a:xfrm>
+          <a:prstGeom prst="rect">
+            <a:avLst/>
+          </a:prstGeom>
+          <a:noFill/>
+          <a:ln/>
+        </p:spPr>
+        <p:txBody>
+          <a:bodyPr wrap="square" lIns="0" tIns="0" rIns="0" bIns="0" rtlCol="0" anchor="ctr"/>
+          <a:lstStyle/>
+          <a:p>
+            <a:pPr indent="0" marL="0">
+              <a:buNone/>
+            </a:pPr>
+            <a:r>
+              <a:rPr lang="en-US" sz="1100" b="1" dirty="0">
+                <a:solidFill>
+                  <a:schemeClr val="tx2"/>
+                </a:solidFill>
+              </a:rPr>
+              <a:t>On the page</a:t>
+            </a:r>
+            <a:endParaRPr lang="en-US" sz="1100" dirty="0"/>
+          </a:p>
+        </p:txBody>
+      </p:sp>
+      <p:sp>
+        <p:nvSpPr>
+          <p:cNvPr id="15" name="Text 12"/>
+          <p:cNvSpPr txBox="1"/>
+          <p:nvPr/>
+        </p:nvSpPr>
+        <p:spPr>
+          <a:xfrm>
+            <a:off x="1828800" y="3685032"/>
+            <a:ext cx="5120640" cy="292608"/>
+          </a:xfrm>
+          <a:prstGeom prst="rect">
+            <a:avLst/>
+          </a:prstGeom>
+          <a:noFill/>
+          <a:ln/>
+        </p:spPr>
+        <p:txBody>
+          <a:bodyPr wrap="square" lIns="0" tIns="0" rIns="0" bIns="0" rtlCol="0" anchor="ctr"/>
+          <a:lstStyle/>
+          <a:p>
+            <a:pPr indent="0" marL="0">
+              <a:buNone/>
+            </a:pPr>
+            <a:r>
+              <a:rPr lang="en-US" sz="1000" dirty="0">
+                <a:solidFill>
+                  <a:schemeClr val="tx1"/>
+                </a:solidFill>
+                <a:latin typeface="Courier New" pitchFamily="34" charset="0"/>
+                <a:ea typeface="Courier New" pitchFamily="34" charset="-122"/>
+                <a:cs typeface="Courier New" pitchFamily="34" charset="-120"/>
+              </a:rPr>
+              <a:t>Card ending 4242 · meera@example.com · DOB 14/03/1991 · PIN 560038</a:t>
+            </a:r>
+            <a:endParaRPr lang="en-US" sz="1000" dirty="0"/>
+          </a:p>
+        </p:txBody>
+      </p:sp>
+      <p:sp>
+        <p:nvSpPr>
+          <p:cNvPr id="16" name="Text 13"/>
+          <p:cNvSpPr txBox="1"/>
+          <p:nvPr/>
+        </p:nvSpPr>
+        <p:spPr>
+          <a:xfrm>
+            <a:off x="594360" y="4005072"/>
+            <a:ext cx="1234440" cy="292608"/>
+          </a:xfrm>
+          <a:prstGeom prst="rect">
+            <a:avLst/>
+          </a:prstGeom>
+          <a:noFill/>
+          <a:ln/>
+        </p:spPr>
+        <p:txBody>
+          <a:bodyPr wrap="square" lIns="0" tIns="0" rIns="0" bIns="0" rtlCol="0" anchor="ctr"/>
+          <a:lstStyle/>
+          <a:p>
+            <a:pPr indent="0" marL="0">
+              <a:buNone/>
+            </a:pPr>
+            <a:r>
+              <a:rPr lang="en-US" sz="1100" b="1" dirty="0">
+                <a:solidFill>
+                  <a:schemeClr val="tx2"/>
+                </a:solidFill>
+              </a:rPr>
+              <a:t>Plain redaction</a:t>
+            </a:r>
+            <a:endParaRPr lang="en-US" sz="1100" dirty="0"/>
+          </a:p>
+        </p:txBody>
+      </p:sp>
+      <p:sp>
+        <p:nvSpPr>
+          <p:cNvPr id="17" name="Text 14"/>
+          <p:cNvSpPr txBox="1"/>
+          <p:nvPr/>
+        </p:nvSpPr>
+        <p:spPr>
+          <a:xfrm>
+            <a:off x="1828800" y="4005072"/>
+            <a:ext cx="5120640" cy="292608"/>
+          </a:xfrm>
+          <a:prstGeom prst="rect">
+            <a:avLst/>
+          </a:prstGeom>
+          <a:noFill/>
+          <a:ln/>
+        </p:spPr>
+        <p:txBody>
+          <a:bodyPr wrap="square" lIns="0" tIns="0" rIns="0" bIns="0" rtlCol="0" anchor="ctr"/>
+          <a:lstStyle/>
+          <a:p>
+            <a:pPr indent="0" marL="0">
+              <a:buNone/>
+            </a:pPr>
+            <a:r>
+              <a:rPr lang="en-US" sz="1000" dirty="0">
+                <a:solidFill>
+                  <a:schemeClr val="tx1"/>
+                </a:solidFill>
+                <a:latin typeface="Courier New" pitchFamily="34" charset="0"/>
+                <a:ea typeface="Courier New" pitchFamily="34" charset="-122"/>
+                <a:cs typeface="Courier New" pitchFamily="34" charset="-120"/>
+              </a:rPr>
+              <a:t>Card ending 4242 · [REDACTED:EMAIL] · DOB 14/03/1991 · PIN 560038</a:t>
+            </a:r>
+            <a:endParaRPr lang="en-US" sz="1000" dirty="0"/>
+          </a:p>
+        </p:txBody>
+      </p:sp>
+      <p:sp>
+        <p:nvSpPr>
+          <p:cNvPr id="18" name="Text 15"/>
+          <p:cNvSpPr txBox="1"/>
+          <p:nvPr/>
+        </p:nvSpPr>
+        <p:spPr>
+          <a:xfrm>
+            <a:off x="6995160" y="4005072"/>
+            <a:ext cx="1645920" cy="292608"/>
+          </a:xfrm>
+          <a:prstGeom prst="rect">
+            <a:avLst/>
+          </a:prstGeom>
+          <a:noFill/>
+          <a:ln/>
+        </p:spPr>
+        <p:txBody>
+          <a:bodyPr wrap="square" lIns="0" tIns="0" rIns="0" bIns="0" rtlCol="0" anchor="ctr"/>
+          <a:lstStyle/>
+          <a:p>
+            <a:pPr indent="0" marL="0">
+              <a:buNone/>
+            </a:pPr>
+            <a:r>
+              <a:rPr lang="en-US" sz="1000" i="1" dirty="0">
+                <a:solidFill>
+                  <a:srgbClr val="BA1A1A"/>
+                </a:solidFill>
+              </a:rPr>
+              <a:t>digits, DOB, PIN leak</a:t>
+            </a:r>
+            <a:endParaRPr lang="en-US" sz="1000" dirty="0"/>
+          </a:p>
+        </p:txBody>
+      </p:sp>
+      <p:sp>
+        <p:nvSpPr>
+          <p:cNvPr id="19" name="Text 16"/>
+          <p:cNvSpPr txBox="1"/>
+          <p:nvPr/>
+        </p:nvSpPr>
+        <p:spPr>
+          <a:xfrm>
+            <a:off x="594360" y="4325112"/>
+            <a:ext cx="1234440" cy="292608"/>
+          </a:xfrm>
+          <a:prstGeom prst="rect">
+            <a:avLst/>
+          </a:prstGeom>
+          <a:noFill/>
+          <a:ln/>
+        </p:spPr>
+        <p:txBody>
+          <a:bodyPr wrap="square" lIns="0" tIns="0" rIns="0" bIns="0" rtlCol="0" anchor="ctr"/>
+          <a:lstStyle/>
+          <a:p>
+            <a:pPr indent="0" marL="0">
+              <a:buNone/>
+            </a:pPr>
+            <a:r>
+              <a:rPr lang="en-US" sz="1100" b="1" dirty="0">
+                <a:solidFill>
+                  <a:schemeClr val="tx2"/>
+                </a:solidFill>
+              </a:rPr>
+              <a:t>Zen sends</a:t>
+            </a:r>
+            <a:endParaRPr lang="en-US" sz="1100" dirty="0"/>
+          </a:p>
+        </p:txBody>
+      </p:sp>
+      <p:sp>
+        <p:nvSpPr>
+          <p:cNvPr id="20" name="Text 17"/>
+          <p:cNvSpPr txBox="1"/>
+          <p:nvPr/>
+        </p:nvSpPr>
+        <p:spPr>
+          <a:xfrm>
+            <a:off x="1828800" y="4325112"/>
+            <a:ext cx="5120640" cy="292608"/>
+          </a:xfrm>
+          <a:prstGeom prst="rect">
+            <a:avLst/>
+          </a:prstGeom>
+          <a:noFill/>
+          <a:ln/>
+        </p:spPr>
+        <p:txBody>
+          <a:bodyPr wrap="square" lIns="0" tIns="0" rIns="0" bIns="0" rtlCol="0" anchor="ctr"/>
+          <a:lstStyle/>
+          <a:p>
+            <a:pPr indent="0" marL="0">
+              <a:buNone/>
+            </a:pPr>
+            <a:r>
+              <a:rPr lang="en-US" sz="1000" b="1" dirty="0">
+                <a:solidFill>
+                  <a:schemeClr val="accent3"/>
+                </a:solidFill>
+                <a:latin typeface="Courier New" pitchFamily="34" charset="0"/>
+                <a:ea typeface="Courier New" pitchFamily="34" charset="-122"/>
+                <a:cs typeface="Courier New" pitchFamily="34" charset="-120"/>
+              </a:rPr>
+              <a:t>Card ending [MASKED] · [EMAIL_1] · DOB 1991 · PIN 560xxx</a:t>
+            </a:r>
+            <a:endParaRPr lang="en-US" sz="1000" dirty="0"/>
+          </a:p>
+        </p:txBody>
+      </p:sp>
+      <p:sp>
+        <p:nvSpPr>
+          <p:cNvPr id="21" name="Text 18"/>
+          <p:cNvSpPr txBox="1"/>
+          <p:nvPr/>
+        </p:nvSpPr>
+        <p:spPr>
+          <a:xfrm>
+            <a:off x="6995160" y="4325112"/>
+            <a:ext cx="1645920" cy="292608"/>
+          </a:xfrm>
+          <a:prstGeom prst="rect">
+            <a:avLst/>
+          </a:prstGeom>
+          <a:noFill/>
+          <a:ln/>
+        </p:spPr>
+        <p:txBody>
+          <a:bodyPr wrap="square" lIns="0" tIns="0" rIns="0" bIns="0" rtlCol="0" anchor="ctr"/>
+          <a:lstStyle/>
+          <a:p>
+            <a:pPr indent="0" marL="0">
+              <a:buNone/>
+            </a:pPr>
+            <a:r>
+              <a:rPr lang="en-US" sz="1000" i="1" dirty="0">
+                <a:solidFill>
+                  <a:schemeClr val="accent4"/>
+                </a:solidFill>
+              </a:rPr>
+              <a:t>only coarse hints left</a:t>
+            </a:r>
+            <a:endParaRPr lang="en-US" sz="1000" dirty="0"/>
           </a:p>
         </p:txBody>
       </p:sp>

</xml_diff>

<commit_message>
Deck slide 6: app screenshot (UPI, bank account, IFSC pseudonyms) instead of native chart; red-team result as text
</commit_message>
<xml_diff>
--- a/submission/Zen_PECathon.pptx
+++ b/submission/Zen_PECathon.pptx
@@ -114,26 +114,26 @@
   <p:extLst>
     <p:ext uri="{521415D9-36F7-43E2-AB2F-B90AF26B5E84}">
       <p14:sectionLst xmlns:p14="http://schemas.microsoft.com/office/powerpoint/2010/main">
-        <p14:section name="Intro" id="{ce92ce52-617d-08e9-d5bc-0ac5fbf3c2b8}">
+        <p14:section name="Intro" id="{2a33088f-c293-2936-cd1b-b9e70c473b00}">
           <p14:sldIdLst>
             <p14:sldId id="256"/>
           </p14:sldIdLst>
         </p14:section>
-        <p14:section name="Problem and design" id="{1435edd7-dc3a-133b-b827-16f9b04ae2a8}">
+        <p14:section name="Problem and design" id="{7c9d3da8-e2e4-fa03-76a8-948c0807347c}">
           <p14:sldIdLst>
             <p14:sldId id="257"/>
             <p14:sldId id="258"/>
             <p14:sldId id="259"/>
           </p14:sldIdLst>
         </p14:section>
-        <p14:section name="How it works" id="{bb80fe60-1e73-aa9f-f6d1-2efe8328d70c}">
+        <p14:section name="How it works" id="{0a57517a-2f66-8ae7-8337-d1acae4c603c}">
           <p14:sldIdLst>
             <p14:sldId id="260"/>
             <p14:sldId id="261"/>
             <p14:sldId id="262"/>
           </p14:sldIdLst>
         </p14:section>
-        <p14:section name="Results" id="{194ea8dd-37ea-b3ad-6556-a94a9e134086}">
+        <p14:section name="Results" id="{cd6f0a93-9a6c-fc38-9a7f-f491d7ab915a}">
           <p14:sldIdLst>
             <p14:sldId id="263"/>
           </p14:sldIdLst>
@@ -145,392 +145,6 @@
     </p:ext>
   </p:extLst>
 </p:presentation>
-</file>
-
-<file path=ppt/charts/chart1.xml><?xml version="1.0" encoding="utf-8"?>
-<c:chartSpace xmlns:c="http://schemas.openxmlformats.org/drawingml/2006/chart" xmlns:a="http://schemas.openxmlformats.org/drawingml/2006/main" xmlns:r="http://schemas.openxmlformats.org/officeDocument/2006/relationships">
-  <c:date1904 val="0"/>
-  <c:roundedCorners val="1"/>
-  <c:chart>
-    <c:title>
-      <c:tx>
-        <c:rich>
-          <a:bodyPr/>
-          <a:lstStyle/>
-          <a:p>
-            <a:pPr>
-              <a:defRPr sz="1200" b="0" i="0" u="none" strike="noStrike">
-                <a:solidFill>
-                  <a:srgbClr val="16140F"/>
-                </a:solidFill>
-                <a:latin typeface="+mn-lt"/>
-              </a:defRPr>
-            </a:pPr>
-            <a:r>
-              <a:rPr sz="1200" b="0" i="0" u="none" strike="noStrike">
-                <a:solidFill>
-                  <a:srgbClr val="16140F"/>
-                </a:solidFill>
-                <a:latin typeface="+mn-lt"/>
-              </a:rPr>
-              <a:t>Leak rate by attack type (%), 48 scenarios</a:t>
-            </a:r>
-          </a:p>
-        </c:rich>
-      </c:tx>
-      <c:layout/>
-      <c:overlay val="0"/>
-    </c:title>
-    <c:autoTitleDeleted val="0"/>
-    <c:plotArea>
-      <c:layout/>
-      <c:barChart>
-        <c:barDir val="col"/>
-        <c:grouping val="clustered"/>
-        <c:varyColors val="0"/>
-        <c:ser>
-          <c:idx val="0"/>
-          <c:order val="0"/>
-          <c:tx>
-            <c:strRef>
-              <c:f>Sheet1!$B$1</c:f>
-              <c:strCache>
-                <c:ptCount val="1"/>
-                <c:pt idx="0">
-                  <c:v>Plain redaction</c:v>
-                </c:pt>
-              </c:strCache>
-            </c:strRef>
-          </c:tx>
-          <c:spPr>
-            <a:solidFill>
-              <a:srgbClr val="D9B8AB"/>
-            </a:solidFill>
-            <a:effectLst/>
-          </c:spPr>
-          <c:invertIfNegative val="0"/>
-          <c:dLbls>
-            <c:numFmt formatCode="#,##0" sourceLinked="0"/>
-            <c:txPr>
-              <a:bodyPr/>
-              <a:lstStyle/>
-              <a:p>
-                <a:pPr>
-                  <a:defRPr b="0" i="0" strike="noStrike" sz="1000" u="none">
-                    <a:solidFill>
-                      <a:srgbClr val="5A4A40"/>
-                    </a:solidFill>
-                    <a:latin typeface="+mn-lt"/>
-                  </a:defRPr>
-                </a:pPr>
-              </a:p>
-            </c:txPr>
-            <c:showLegendKey val="0"/>
-            <c:showVal val="1"/>
-            <c:showCatName val="0"/>
-            <c:showSerName val="0"/>
-            <c:showPercent val="0"/>
-            <c:showBubbleSize val="0"/>
-            <c:showLeaderLines val="0"/>
-          </c:dLbls>
-          <c:cat>
-            <c:multiLvlStrRef>
-              <c:f>Sheet1!$A$2:$A$6</c:f>
-              <c:multiLvlStrCache>
-                <c:ptCount val="5"/>
-                <c:lvl>
-                  <c:pt idx="0">
-                    <c:v>Partial values</c:v>
-                  </c:pt>
-                  <c:pt idx="1">
-                    <c:v>Recomputable</c:v>
-                  </c:pt>
-                  <c:pt idx="2">
-                    <c:v>Quasi-IDs</c:v>
-                  </c:pt>
-                  <c:pt idx="3">
-                    <c:v>Cross-field</c:v>
-                  </c:pt>
-                  <c:pt idx="4">
-                    <c:v>Context</c:v>
-                  </c:pt>
-                </c:lvl>
-              </c:multiLvlStrCache>
-            </c:multiLvlStrRef>
-          </c:cat>
-          <c:val>
-            <c:numRef>
-              <c:f>Sheet1!$B$2:$B$6</c:f>
-              <c:numCache>
-                <c:formatCode>General</c:formatCode>
-                <c:ptCount val="5"/>
-                <c:pt idx="0">
-                  <c:v>100</c:v>
-                </c:pt>
-                <c:pt idx="1">
-                  <c:v>100</c:v>
-                </c:pt>
-                <c:pt idx="2">
-                  <c:v>100</c:v>
-                </c:pt>
-                <c:pt idx="3">
-                  <c:v>100</c:v>
-                </c:pt>
-                <c:pt idx="4">
-                  <c:v>100</c:v>
-                </c:pt>
-              </c:numCache>
-            </c:numRef>
-          </c:val>
-        </c:ser>
-        <c:ser>
-          <c:idx val="1"/>
-          <c:order val="1"/>
-          <c:tx>
-            <c:strRef>
-              <c:f>Sheet1!$C$1</c:f>
-              <c:strCache>
-                <c:ptCount val="1"/>
-                <c:pt idx="0">
-                  <c:v>Zen (minimised)</c:v>
-                </c:pt>
-              </c:strCache>
-            </c:strRef>
-          </c:tx>
-          <c:spPr>
-            <a:solidFill>
-              <a:srgbClr val="B8431E"/>
-            </a:solidFill>
-            <a:effectLst/>
-          </c:spPr>
-          <c:invertIfNegative val="0"/>
-          <c:dLbls>
-            <c:numFmt formatCode="#,##0" sourceLinked="0"/>
-            <c:txPr>
-              <a:bodyPr/>
-              <a:lstStyle/>
-              <a:p>
-                <a:pPr>
-                  <a:defRPr b="0" i="0" strike="noStrike" sz="1000" u="none">
-                    <a:solidFill>
-                      <a:srgbClr val="5A4A40"/>
-                    </a:solidFill>
-                    <a:latin typeface="+mn-lt"/>
-                  </a:defRPr>
-                </a:pPr>
-              </a:p>
-            </c:txPr>
-            <c:showLegendKey val="0"/>
-            <c:showVal val="1"/>
-            <c:showCatName val="0"/>
-            <c:showSerName val="0"/>
-            <c:showPercent val="0"/>
-            <c:showBubbleSize val="0"/>
-            <c:showLeaderLines val="0"/>
-          </c:dLbls>
-          <c:cat>
-            <c:multiLvlStrRef>
-              <c:f>Sheet1!$A$2:$A$6</c:f>
-              <c:multiLvlStrCache>
-                <c:ptCount val="5"/>
-                <c:lvl>
-                  <c:pt idx="0">
-                    <c:v>Partial values</c:v>
-                  </c:pt>
-                  <c:pt idx="1">
-                    <c:v>Recomputable</c:v>
-                  </c:pt>
-                  <c:pt idx="2">
-                    <c:v>Quasi-IDs</c:v>
-                  </c:pt>
-                  <c:pt idx="3">
-                    <c:v>Cross-field</c:v>
-                  </c:pt>
-                  <c:pt idx="4">
-                    <c:v>Context</c:v>
-                  </c:pt>
-                </c:lvl>
-              </c:multiLvlStrCache>
-            </c:multiLvlStrRef>
-          </c:cat>
-          <c:val>
-            <c:numRef>
-              <c:f>Sheet1!$C$2:$C$6</c:f>
-              <c:numCache>
-                <c:formatCode>General</c:formatCode>
-                <c:ptCount val="5"/>
-                <c:pt idx="0">
-                  <c:v>0</c:v>
-                </c:pt>
-                <c:pt idx="1">
-                  <c:v>9</c:v>
-                </c:pt>
-                <c:pt idx="2">
-                  <c:v>0</c:v>
-                </c:pt>
-                <c:pt idx="3">
-                  <c:v>12</c:v>
-                </c:pt>
-                <c:pt idx="4">
-                  <c:v>0</c:v>
-                </c:pt>
-              </c:numCache>
-            </c:numRef>
-          </c:val>
-        </c:ser>
-        <c:dLbls>
-          <c:numFmt formatCode="#,##0" sourceLinked="0"/>
-          <c:txPr>
-            <a:bodyPr/>
-            <a:lstStyle/>
-            <a:p>
-              <a:pPr>
-                <a:defRPr b="0" i="0" strike="noStrike" sz="1000" u="none">
-                  <a:solidFill>
-                    <a:srgbClr val="5A4A40"/>
-                  </a:solidFill>
-                  <a:latin typeface="+mn-lt"/>
-                </a:defRPr>
-              </a:pPr>
-            </a:p>
-          </c:txPr>
-          <c:showLegendKey val="0"/>
-          <c:showVal val="1"/>
-          <c:showCatName val="0"/>
-          <c:showSerName val="0"/>
-          <c:showPercent val="0"/>
-          <c:showBubbleSize val="0"/>
-          <c:showLeaderLines val="0"/>
-        </c:dLbls>
-        <c:gapWidth val="60"/>
-        <c:overlap val="0"/>
-        <c:axId val="2094734554"/>
-        <c:axId val="2094734552"/>
-        <c:axId val="2094734556"/>
-      </c:barChart>
-      <c:catAx>
-        <c:axId val="2094734554"/>
-        <c:scaling>
-          <c:orientation val="minMax"/>
-        </c:scaling>
-        <c:delete val="0"/>
-        <c:axPos val="b"/>
-        <c:numFmt formatCode="General" sourceLinked="1"/>
-        <c:majorTickMark val="out"/>
-        <c:minorTickMark val="none"/>
-        <c:tickLblPos val="low"/>
-        <c:spPr>
-          <a:ln w="12700" cap="flat">
-            <a:solidFill>
-              <a:srgbClr val="888888"/>
-            </a:solidFill>
-            <a:prstDash val="solid"/>
-            <a:round/>
-          </a:ln>
-        </c:spPr>
-        <c:txPr>
-          <a:bodyPr/>
-          <a:lstStyle/>
-          <a:p>
-            <a:pPr>
-              <a:defRPr sz="1000" b="0" i="0" u="none" strike="noStrike">
-                <a:solidFill>
-                  <a:srgbClr val="5A4A40"/>
-                </a:solidFill>
-                <a:latin typeface="+mn-lt"/>
-              </a:defRPr>
-            </a:pPr>
-            <a:endParaRPr lang="en-US"/>
-          </a:p>
-        </c:txPr>
-        <c:crossAx val="2094734552"/>
-        <c:crosses val="autoZero"/>
-        <c:auto val="1"/>
-        <c:lblAlgn val="ctr"/>
-        <c:noMultiLvlLbl val="1"/>
-      </c:catAx>
-      <c:valAx>
-        <c:axId val="2094734552"/>
-        <c:scaling>
-          <c:orientation val="minMax"/>
-          <c:max val="110"/>
-        </c:scaling>
-        <c:delete val="1"/>
-        <c:axPos val="l"/>
-        <c:numFmt formatCode="General" sourceLinked="0"/>
-        <c:majorTickMark val="out"/>
-        <c:minorTickMark val="none"/>
-        <c:tickLblPos val="nextTo"/>
-        <c:spPr>
-          <a:ln w="12700" cap="flat">
-            <a:solidFill>
-              <a:srgbClr val="888888"/>
-            </a:solidFill>
-            <a:prstDash val="solid"/>
-            <a:round/>
-          </a:ln>
-        </c:spPr>
-        <c:txPr>
-          <a:bodyPr/>
-          <a:lstStyle/>
-          <a:p>
-            <a:pPr>
-              <a:defRPr sz="1200" b="0" i="0" u="none" strike="noStrike">
-                <a:solidFill>
-                  <a:srgbClr val="000000"/>
-                </a:solidFill>
-                <a:latin typeface="Arial"/>
-              </a:defRPr>
-            </a:pPr>
-            <a:endParaRPr lang="en-US"/>
-          </a:p>
-        </c:txPr>
-        <c:crossAx val="2094734554"/>
-        <c:crosses val="autoZero"/>
-        <c:crossBetween val="between"/>
-      </c:valAx>
-      <c:spPr>
-        <a:noFill/>
-        <a:ln>
-          <a:noFill/>
-        </a:ln>
-        <a:effectLst/>
-      </c:spPr>
-    </c:plotArea>
-    <c:legend>
-      <c:legendPos val="b"/>
-      <c:overlay val="0"/>
-      <c:txPr>
-        <a:bodyPr/>
-        <a:lstStyle/>
-        <a:p>
-          <a:pPr>
-            <a:defRPr sz="1100">
-              <a:solidFill>
-                <a:srgbClr val="1B1C1A"/>
-              </a:solidFill>
-              <a:latin typeface="+mn-lt"/>
-              <a:cs typeface="+mn-lt"/>
-            </a:defRPr>
-          </a:pPr>
-          <a:endParaRPr lang="en-US"/>
-        </a:p>
-      </c:txPr>
-    </c:legend>
-    <c:plotVisOnly val="1"/>
-    <c:dispBlanksAs val="span"/>
-  </c:chart>
-  <c:spPr>
-    <a:noFill/>
-    <a:ln>
-      <a:noFill/>
-    </a:ln>
-    <a:effectLst/>
-  </c:spPr>
-  <c:externalData r:id="rId1">
-    <c:autoUpdate val="0"/>
-  </c:externalData>
-</c:chartSpace>
 </file>
 
 <file path=ppt/notesMasters/notesMaster1.xml><?xml version="1.0" encoding="utf-8"?>
@@ -1368,7 +982,7 @@
           <a:p>
             <a:r>
               <a:rPr lang="en-US" dirty="0"/>
-              <a:t>eval.inference.run: an offline attacker tries to recover each redacted value from context. Leak = exact recovery, at least 1 bit narrowed, or re-identification. 2 known-gap leaks remain after minimise.</a:t>
+              <a:t>eval.inference.run: an offline attacker tries to recover each redacted value from context. Leak = exact recovery, at least 1 bit narrowed, or re-identification. 2 known-gap leaks remain after minimise. Utility: 0 of 260 harmless tokens changed. Screenshot: the Zen web app in pseudonym mode; the same email maps to the same token.</a:t>
             </a:r>
             <a:endParaRPr lang="en-US" dirty="0"/>
           </a:p>
@@ -5796,25 +5410,65 @@
           </a:p>
         </p:txBody>
       </p:sp>
-      <p:graphicFrame>
-        <p:nvGraphicFramePr>
-          <p:cNvPr id="3" name="Chart 0" descr=""/>
-          <p:cNvGraphicFramePr/>
-          <p:nvPr/>
-        </p:nvGraphicFramePr>
-        <p:xfrm>
-          <a:off x="365760" y="914400"/>
-          <a:ext cx="5029200" cy="2606040"/>
-        </p:xfrm>
-        <a:graphic xmlns:a="http://schemas.openxmlformats.org/drawingml/2006/main">
-          <a:graphicData uri="http://schemas.openxmlformats.org/drawingml/2006/chart">
-            <c:chart xmlns:c="http://schemas.openxmlformats.org/drawingml/2006/chart" r:id="rId1"/>
-          </a:graphicData>
-        </a:graphic>
-      </p:graphicFrame>
-      <p:sp>
-        <p:nvSpPr>
-          <p:cNvPr id="4" name="card"/>
+      <p:sp>
+        <p:nvSpPr>
+          <p:cNvPr id="3" name="Shape 1"/>
+          <p:cNvSpPr/>
+          <p:nvPr/>
+        </p:nvSpPr>
+        <p:spPr>
+          <a:xfrm>
+            <a:off x="457200" y="960120"/>
+            <a:ext cx="4937760" cy="2560320"/>
+          </a:xfrm>
+          <a:prstGeom prst="rect">
+            <a:avLst/>
+          </a:prstGeom>
+          <a:solidFill>
+            <a:srgbClr val="FFFFFF"/>
+          </a:solidFill>
+          <a:ln w="12700">
+            <a:solidFill>
+              <a:schemeClr val="accent6"/>
+            </a:solidFill>
+            <a:prstDash val="solid"/>
+          </a:ln>
+          <a:effectLst>
+            <a:outerShdw sx="100000" sy="100000" kx="0" ky="0" algn="bl" rotWithShape="0" blurRad="76200" dist="25400" dir="5400000">
+              <a:srgbClr val="000000">
+                <a:alpha val="15000"/>
+              </a:srgbClr>
+            </a:outerShdw>
+          </a:effectLst>
+        </p:spPr>
+      </p:sp>
+      <p:pic>
+        <p:nvPicPr>
+          <p:cNvPr id="4" name="Image 0" descr="Zen web app: UPI ID, bank account, IFSC, email and phone replaced by consistent tokens such as [UPI_ID_1] and [EMAIL_1]">    </p:cNvPr>
+          <p:cNvPicPr>
+            <a:picLocks noChangeAspect="1"/>
+          </p:cNvPicPr>
+          <p:nvPr/>
+        </p:nvPicPr>
+        <p:blipFill>
+          <a:blip r:embed="rId1"/>
+          <a:stretch>
+            <a:fillRect/>
+          </a:stretch>
+        </p:blipFill>
+        <p:spPr>
+          <a:xfrm>
+            <a:off x="457200" y="960120"/>
+            <a:ext cx="4937760" cy="2560320"/>
+          </a:xfrm>
+          <a:prstGeom prst="rect">
+            <a:avLst/>
+          </a:prstGeom>
+        </p:spPr>
+      </p:pic>
+      <p:sp>
+        <p:nvSpPr>
+          <p:cNvPr id="5" name="card"/>
           <p:cNvSpPr/>
           <p:nvPr/>
         </p:nvSpPr>
@@ -5841,7 +5495,7 @@
       </p:sp>
       <p:sp>
         <p:nvSpPr>
-          <p:cNvPr id="5" name="Text 2"/>
+          <p:cNvPr id="6" name="Text 3"/>
           <p:cNvSpPr txBox="1"/>
           <p:nvPr/>
         </p:nvSpPr>
@@ -5877,7 +5531,7 @@
       </p:sp>
       <p:sp>
         <p:nvSpPr>
-          <p:cNvPr id="6" name="Text 3"/>
+          <p:cNvPr id="7" name="Text 4"/>
           <p:cNvSpPr txBox="1"/>
           <p:nvPr/>
         </p:nvSpPr>
@@ -5913,7 +5567,7 @@
       </p:sp>
       <p:sp>
         <p:nvSpPr>
-          <p:cNvPr id="7" name="card"/>
+          <p:cNvPr id="8" name="card"/>
           <p:cNvSpPr/>
           <p:nvPr/>
         </p:nvSpPr>
@@ -5940,7 +5594,7 @@
       </p:sp>
       <p:sp>
         <p:nvSpPr>
-          <p:cNvPr id="8" name="Text 5"/>
+          <p:cNvPr id="9" name="Text 6"/>
           <p:cNvSpPr txBox="1"/>
           <p:nvPr/>
         </p:nvSpPr>
@@ -5976,7 +5630,7 @@
       </p:sp>
       <p:sp>
         <p:nvSpPr>
-          <p:cNvPr id="9" name="Text 6"/>
+          <p:cNvPr id="10" name="Text 7"/>
           <p:cNvSpPr txBox="1"/>
           <p:nvPr/>
         </p:nvSpPr>
@@ -6012,7 +5666,7 @@
       </p:sp>
       <p:sp>
         <p:nvSpPr>
-          <p:cNvPr id="10" name="card"/>
+          <p:cNvPr id="11" name="card"/>
           <p:cNvSpPr/>
           <p:nvPr/>
         </p:nvSpPr>
@@ -6039,7 +5693,7 @@
       </p:sp>
       <p:sp>
         <p:nvSpPr>
-          <p:cNvPr id="11" name="Text 8"/>
+          <p:cNvPr id="12" name="Text 9"/>
           <p:cNvSpPr txBox="1"/>
           <p:nvPr/>
         </p:nvSpPr>
@@ -6067,7 +5721,7 @@
                   <a:schemeClr val="accent3"/>
                 </a:solidFill>
               </a:rPr>
-              <a:t>0 of 260</a:t>
+              <a:t>48 of 48 → 2 of 48</a:t>
             </a:r>
             <a:endParaRPr lang="en-US" sz="1300" dirty="0"/>
           </a:p>
@@ -6075,7 +5729,7 @@
       </p:sp>
       <p:sp>
         <p:nvSpPr>
-          <p:cNvPr id="12" name="Text 9"/>
+          <p:cNvPr id="13" name="Text 10"/>
           <p:cNvSpPr txBox="1"/>
           <p:nvPr/>
         </p:nvSpPr>
@@ -6103,7 +5757,7 @@
                   <a:schemeClr val="tx1"/>
                 </a:solidFill>
               </a:rPr>
-              <a:t>harmless tokens changed: utility kept</a:t>
+              <a:t>red-team scenarios where a value can be recovered: plain redaction vs Zen</a:t>
             </a:r>
             <a:endParaRPr lang="en-US" sz="1100" dirty="0"/>
           </a:p>
@@ -6111,7 +5765,7 @@
       </p:sp>
       <p:sp>
         <p:nvSpPr>
-          <p:cNvPr id="13" name="card"/>
+          <p:cNvPr id="14" name="card"/>
           <p:cNvSpPr/>
           <p:nvPr/>
         </p:nvSpPr>
@@ -6138,7 +5792,7 @@
       </p:sp>
       <p:sp>
         <p:nvSpPr>
-          <p:cNvPr id="14" name="Text 11"/>
+          <p:cNvPr id="15" name="Text 12"/>
           <p:cNvSpPr txBox="1"/>
           <p:nvPr/>
         </p:nvSpPr>
@@ -6174,7 +5828,7 @@
       </p:sp>
       <p:sp>
         <p:nvSpPr>
-          <p:cNvPr id="15" name="Text 12"/>
+          <p:cNvPr id="16" name="Text 13"/>
           <p:cNvSpPr txBox="1"/>
           <p:nvPr/>
         </p:nvSpPr>
@@ -6213,7 +5867,7 @@
       </p:sp>
       <p:sp>
         <p:nvSpPr>
-          <p:cNvPr id="16" name="Text 13"/>
+          <p:cNvPr id="17" name="Text 14"/>
           <p:cNvSpPr txBox="1"/>
           <p:nvPr/>
         </p:nvSpPr>
@@ -6249,7 +5903,7 @@
       </p:sp>
       <p:sp>
         <p:nvSpPr>
-          <p:cNvPr id="17" name="Text 14"/>
+          <p:cNvPr id="18" name="Text 15"/>
           <p:cNvSpPr txBox="1"/>
           <p:nvPr/>
         </p:nvSpPr>
@@ -6288,7 +5942,7 @@
       </p:sp>
       <p:sp>
         <p:nvSpPr>
-          <p:cNvPr id="18" name="Text 15"/>
+          <p:cNvPr id="19" name="Text 16"/>
           <p:cNvSpPr txBox="1"/>
           <p:nvPr/>
         </p:nvSpPr>
@@ -6324,7 +5978,7 @@
       </p:sp>
       <p:sp>
         <p:nvSpPr>
-          <p:cNvPr id="19" name="Text 16"/>
+          <p:cNvPr id="20" name="Text 17"/>
           <p:cNvSpPr txBox="1"/>
           <p:nvPr/>
         </p:nvSpPr>
@@ -6360,7 +6014,7 @@
       </p:sp>
       <p:sp>
         <p:nvSpPr>
-          <p:cNvPr id="20" name="Text 17"/>
+          <p:cNvPr id="21" name="Text 18"/>
           <p:cNvSpPr txBox="1"/>
           <p:nvPr/>
         </p:nvSpPr>
@@ -6399,7 +6053,7 @@
       </p:sp>
       <p:sp>
         <p:nvSpPr>
-          <p:cNvPr id="21" name="Text 18"/>
+          <p:cNvPr id="22" name="Text 19"/>
           <p:cNvSpPr txBox="1"/>
           <p:nvPr/>
         </p:nvSpPr>

</xml_diff>